<commit_message>
Fix: Applied White Theme and Ultra-Precision Graph Analysis for all 6 images
</commit_message>
<xml_diff>
--- a/output/3.pptx
+++ b/output/3.pptx
@@ -3104,8 +3104,8 @@
         </p:nvCxnSpPr>
         <p:spPr>
           <a:xfrm>
-            <a:off x="4114800.0" y="2571750.0"/>
-            <a:ext cx="3657600.0" cy="0.0"/>
+            <a:off x="3886200.0" y="2571750.0"/>
+            <a:ext cx="2743200.0" cy="0.0"/>
           </a:xfrm>
           <a:prstGeom prst="line">
             <a:avLst/>
@@ -3139,8 +3139,8 @@
         </p:nvCxnSpPr>
         <p:spPr>
           <a:xfrm flipV="1">
-            <a:off x="4572000.0" y="-1314450.0"/>
-            <a:ext cx="0.0" cy="4343400.0"/>
+            <a:off x="4572000.0" y="-171450.0"/>
+            <a:ext cx="0.0" cy="3200400.0"/>
           </a:xfrm>
           <a:prstGeom prst="line">
             <a:avLst/>
@@ -3174,8 +3174,8 @@
         </p:nvSpPr>
         <p:spPr>
           <a:xfrm>
-            <a:off x="4937760" y="-4857750"/>
-            <a:ext cx="2011680" cy="7110142"/>
+            <a:off x="4800600" y="241859"/>
+            <a:ext cx="1234440" cy="1826971"/>
           </a:xfrm>
           <a:custGeom>
             <a:avLst/>
@@ -3184,1212 +3184,1212 @@
             <a:cxnLst/>
             <a:rect l="l" t="t" r="r" b="b"/>
             <a:pathLst>
-              <a:path w="2011680" h="7110142">
+              <a:path w="1234440" h="1826971">
                 <a:moveTo>
-                  <a:pt x="0" y="7109460"/>
+                  <a:pt x="0" y="1826971"/>
                 </a:moveTo>
                 <a:lnTo>
-                  <a:pt x="6728" y="7110142"/>
-                </a:lnTo>
-                <a:close/>
-                <a:lnTo>
-                  <a:pt x="13456" y="7107519"/>
-                </a:lnTo>
-                <a:close/>
-                <a:lnTo>
-                  <a:pt x="20184" y="7103891"/>
-                </a:lnTo>
-                <a:close/>
-                <a:lnTo>
-                  <a:pt x="26912" y="7100570"/>
-                </a:lnTo>
-                <a:close/>
-                <a:lnTo>
-                  <a:pt x="33640" y="7097222"/>
-                </a:lnTo>
-                <a:close/>
-                <a:lnTo>
-                  <a:pt x="40368" y="7093843"/>
-                </a:lnTo>
-                <a:close/>
-                <a:lnTo>
-                  <a:pt x="47096" y="7090485"/>
-                </a:lnTo>
-                <a:close/>
-                <a:lnTo>
-                  <a:pt x="53824" y="7087121"/>
-                </a:lnTo>
-                <a:close/>
-                <a:lnTo>
-                  <a:pt x="60552" y="7083746"/>
-                </a:lnTo>
-                <a:close/>
-                <a:lnTo>
-                  <a:pt x="67280" y="7080417"/>
-                </a:lnTo>
-                <a:close/>
-                <a:lnTo>
-                  <a:pt x="74008" y="7077006"/>
-                </a:lnTo>
-                <a:close/>
-                <a:lnTo>
-                  <a:pt x="80736" y="7073570"/>
-                </a:lnTo>
-                <a:close/>
-                <a:lnTo>
-                  <a:pt x="87464" y="7070775"/>
-                </a:lnTo>
-                <a:close/>
-                <a:lnTo>
-                  <a:pt x="94192" y="7065723"/>
-                </a:lnTo>
-                <a:close/>
-                <a:lnTo>
-                  <a:pt x="100920" y="7058891"/>
-                </a:lnTo>
-                <a:close/>
-                <a:lnTo>
-                  <a:pt x="107648" y="7055292"/>
-                </a:lnTo>
-                <a:close/>
-                <a:lnTo>
-                  <a:pt x="114376" y="7052893"/>
-                </a:lnTo>
-                <a:close/>
-                <a:lnTo>
-                  <a:pt x="121104" y="7047849"/>
-                </a:lnTo>
-                <a:close/>
-                <a:lnTo>
-                  <a:pt x="127833" y="7041015"/>
-                </a:lnTo>
-                <a:close/>
-                <a:lnTo>
-                  <a:pt x="134561" y="7037835"/>
-                </a:lnTo>
-                <a:close/>
-                <a:lnTo>
-                  <a:pt x="141289" y="7032225"/>
-                </a:lnTo>
-                <a:close/>
-                <a:lnTo>
-                  <a:pt x="148017" y="7026088"/>
-                </a:lnTo>
-                <a:close/>
-                <a:lnTo>
-                  <a:pt x="154745" y="7023076"/>
-                </a:lnTo>
-                <a:close/>
-                <a:lnTo>
-                  <a:pt x="161473" y="7016451"/>
-                </a:lnTo>
-                <a:close/>
-                <a:lnTo>
-                  <a:pt x="168201" y="7011390"/>
-                </a:lnTo>
-                <a:close/>
-                <a:lnTo>
-                  <a:pt x="174929" y="7008036"/>
-                </a:lnTo>
-                <a:close/>
-                <a:lnTo>
-                  <a:pt x="181657" y="7001169"/>
-                </a:lnTo>
-                <a:close/>
-                <a:lnTo>
-                  <a:pt x="188385" y="6993620"/>
-                </a:lnTo>
-                <a:close/>
-                <a:lnTo>
-                  <a:pt x="195113" y="6988966"/>
-                </a:lnTo>
-                <a:close/>
-                <a:lnTo>
-                  <a:pt x="201841" y="6985522"/>
-                </a:lnTo>
-                <a:close/>
-                <a:lnTo>
-                  <a:pt x="208569" y="6978766"/>
-                </a:lnTo>
-                <a:close/>
-                <a:lnTo>
-                  <a:pt x="215297" y="6971902"/>
-                </a:lnTo>
-                <a:close/>
-                <a:lnTo>
-                  <a:pt x="222025" y="6964915"/>
-                </a:lnTo>
-                <a:close/>
-                <a:lnTo>
-                  <a:pt x="228753" y="6958480"/>
-                </a:lnTo>
-                <a:close/>
-                <a:lnTo>
-                  <a:pt x="235481" y="6955296"/>
-                </a:lnTo>
-                <a:close/>
-                <a:lnTo>
-                  <a:pt x="242209" y="6950015"/>
-                </a:lnTo>
-                <a:close/>
-                <a:lnTo>
-                  <a:pt x="248937" y="6942706"/>
-                </a:lnTo>
-                <a:close/>
-                <a:lnTo>
-                  <a:pt x="255665" y="6936082"/>
-                </a:lnTo>
-                <a:close/>
-                <a:lnTo>
-                  <a:pt x="262393" y="6929385"/>
-                </a:lnTo>
-                <a:close/>
-                <a:lnTo>
-                  <a:pt x="269121" y="6922626"/>
-                </a:lnTo>
-                <a:close/>
-                <a:lnTo>
-                  <a:pt x="275849" y="6915909"/>
-                </a:lnTo>
-                <a:close/>
-                <a:lnTo>
-                  <a:pt x="282577" y="6909179"/>
-                </a:lnTo>
-                <a:close/>
-                <a:lnTo>
-                  <a:pt x="289305" y="6902450"/>
-                </a:lnTo>
-                <a:close/>
-                <a:lnTo>
-                  <a:pt x="296033" y="6895723"/>
-                </a:lnTo>
-                <a:close/>
-                <a:lnTo>
-                  <a:pt x="302761" y="6888995"/>
-                </a:lnTo>
-                <a:close/>
-                <a:lnTo>
-                  <a:pt x="309489" y="6882266"/>
-                </a:lnTo>
-                <a:close/>
-                <a:lnTo>
-                  <a:pt x="316217" y="6875541"/>
-                </a:lnTo>
-                <a:close/>
-                <a:lnTo>
-                  <a:pt x="322945" y="6868805"/>
-                </a:lnTo>
-                <a:close/>
-                <a:lnTo>
-                  <a:pt x="329673" y="6862086"/>
-                </a:lnTo>
-                <a:close/>
-                <a:lnTo>
-                  <a:pt x="336401" y="6855383"/>
-                </a:lnTo>
-                <a:close/>
-                <a:lnTo>
-                  <a:pt x="343129" y="6848503"/>
-                </a:lnTo>
-                <a:close/>
-                <a:lnTo>
-                  <a:pt x="349857" y="6842150"/>
-                </a:lnTo>
-                <a:close/>
-                <a:lnTo>
-                  <a:pt x="356585" y="6835180"/>
-                </a:lnTo>
-                <a:close/>
-                <a:lnTo>
-                  <a:pt x="363313" y="6824973"/>
-                </a:lnTo>
-                <a:close/>
-                <a:lnTo>
-                  <a:pt x="370041" y="6816553"/>
-                </a:lnTo>
-                <a:close/>
-                <a:lnTo>
-                  <a:pt x="376769" y="6810714"/>
-                </a:lnTo>
-                <a:close/>
-                <a:lnTo>
-                  <a:pt x="383498" y="6803854"/>
-                </a:lnTo>
-                <a:close/>
-                <a:lnTo>
-                  <a:pt x="390226" y="6793755"/>
-                </a:lnTo>
-                <a:close/>
-                <a:lnTo>
-                  <a:pt x="396954" y="6785062"/>
-                </a:lnTo>
-                <a:close/>
-                <a:lnTo>
-                  <a:pt x="403682" y="6779163"/>
-                </a:lnTo>
-                <a:close/>
-                <a:lnTo>
-                  <a:pt x="410410" y="6772525"/>
-                </a:lnTo>
-                <a:close/>
-                <a:lnTo>
-                  <a:pt x="417138" y="6762387"/>
-                </a:lnTo>
-                <a:close/>
-                <a:lnTo>
-                  <a:pt x="423866" y="6754060"/>
-                </a:lnTo>
-                <a:close/>
-                <a:lnTo>
-                  <a:pt x="430594" y="6747189"/>
-                </a:lnTo>
-                <a:close/>
-                <a:lnTo>
-                  <a:pt x="437322" y="6736758"/>
-                </a:lnTo>
-                <a:close/>
-                <a:lnTo>
-                  <a:pt x="444050" y="6729316"/>
-                </a:lnTo>
-                <a:close/>
-                <a:lnTo>
-                  <a:pt x="450778" y="6721918"/>
-                </a:lnTo>
-                <a:close/>
-                <a:lnTo>
-                  <a:pt x="457506" y="6711183"/>
-                </a:lnTo>
-                <a:close/>
-                <a:lnTo>
-                  <a:pt x="464234" y="6700651"/>
-                </a:lnTo>
-                <a:close/>
-                <a:lnTo>
-                  <a:pt x="470962" y="6693410"/>
-                </a:lnTo>
-                <a:close/>
-                <a:lnTo>
-                  <a:pt x="477690" y="6685944"/>
-                </a:lnTo>
-                <a:close/>
-                <a:lnTo>
-                  <a:pt x="484418" y="6675455"/>
-                </a:lnTo>
-                <a:close/>
-                <a:lnTo>
-                  <a:pt x="491146" y="6665400"/>
-                </a:lnTo>
-                <a:close/>
-                <a:lnTo>
-                  <a:pt x="497874" y="6654864"/>
-                </a:lnTo>
-                <a:close/>
-                <a:lnTo>
-                  <a:pt x="504602" y="6645840"/>
-                </a:lnTo>
-                <a:close/>
-                <a:lnTo>
-                  <a:pt x="511330" y="6639380"/>
-                </a:lnTo>
-                <a:close/>
-                <a:lnTo>
-                  <a:pt x="518058" y="6629895"/>
-                </a:lnTo>
-                <a:close/>
-                <a:lnTo>
-                  <a:pt x="524786" y="6619328"/>
-                </a:lnTo>
-                <a:close/>
-                <a:lnTo>
-                  <a:pt x="531514" y="6609390"/>
-                </a:lnTo>
-                <a:close/>
-                <a:lnTo>
-                  <a:pt x="538242" y="6599286"/>
-                </a:lnTo>
-                <a:close/>
-                <a:lnTo>
-                  <a:pt x="544970" y="6589177"/>
-                </a:lnTo>
-                <a:close/>
-                <a:lnTo>
-                  <a:pt x="551698" y="6579095"/>
-                </a:lnTo>
-                <a:close/>
-                <a:lnTo>
-                  <a:pt x="558426" y="6569000"/>
-                </a:lnTo>
-                <a:close/>
-                <a:lnTo>
-                  <a:pt x="565154" y="6558909"/>
-                </a:lnTo>
-                <a:close/>
-                <a:lnTo>
-                  <a:pt x="571882" y="6548816"/>
-                </a:lnTo>
-                <a:close/>
-                <a:lnTo>
-                  <a:pt x="578610" y="6538726"/>
-                </a:lnTo>
-                <a:close/>
-                <a:lnTo>
-                  <a:pt x="585338" y="6528632"/>
-                </a:lnTo>
-                <a:close/>
-                <a:lnTo>
-                  <a:pt x="592066" y="6518532"/>
-                </a:lnTo>
-                <a:close/>
-                <a:lnTo>
-                  <a:pt x="598794" y="6508480"/>
-                </a:lnTo>
-                <a:close/>
-                <a:lnTo>
-                  <a:pt x="605522" y="6498300"/>
-                </a:lnTo>
-                <a:close/>
-                <a:lnTo>
-                  <a:pt x="612250" y="6488234"/>
-                </a:lnTo>
-                <a:close/>
-                <a:lnTo>
-                  <a:pt x="618978" y="6478641"/>
-                </a:lnTo>
-                <a:close/>
-                <a:lnTo>
-                  <a:pt x="625706" y="6466214"/>
-                </a:lnTo>
-                <a:close/>
-                <a:lnTo>
-                  <a:pt x="632435" y="6453022"/>
-                </a:lnTo>
-                <a:close/>
-                <a:lnTo>
-                  <a:pt x="639163" y="6443165"/>
-                </a:lnTo>
-                <a:close/>
-                <a:lnTo>
-                  <a:pt x="645891" y="6433858"/>
-                </a:lnTo>
-                <a:close/>
-                <a:lnTo>
-                  <a:pt x="652619" y="6421405"/>
-                </a:lnTo>
-                <a:close/>
-                <a:lnTo>
-                  <a:pt x="659347" y="6408327"/>
-                </a:lnTo>
-                <a:close/>
-                <a:lnTo>
-                  <a:pt x="666075" y="6398597"/>
-                </a:lnTo>
-                <a:close/>
-                <a:lnTo>
-                  <a:pt x="672803" y="6385596"/>
-                </a:lnTo>
-                <a:close/>
-                <a:lnTo>
-                  <a:pt x="679531" y="6373336"/>
-                </a:lnTo>
-                <a:close/>
-                <a:lnTo>
-                  <a:pt x="686259" y="6363461"/>
-                </a:lnTo>
-                <a:close/>
-                <a:lnTo>
-                  <a:pt x="692987" y="6350183"/>
-                </a:lnTo>
-                <a:close/>
-                <a:lnTo>
-                  <a:pt x="699715" y="6335796"/>
-                </a:lnTo>
-                <a:close/>
-                <a:lnTo>
-                  <a:pt x="706443" y="6323995"/>
-                </a:lnTo>
-                <a:close/>
-                <a:lnTo>
-                  <a:pt x="713171" y="6314035"/>
-                </a:lnTo>
-                <a:close/>
-                <a:lnTo>
-                  <a:pt x="719899" y="6300860"/>
-                </a:lnTo>
-                <a:close/>
-                <a:lnTo>
-                  <a:pt x="726627" y="6287017"/>
-                </a:lnTo>
-                <a:close/>
-                <a:lnTo>
-                  <a:pt x="733355" y="6273715"/>
-                </a:lnTo>
-                <a:close/>
-                <a:lnTo>
-                  <a:pt x="740083" y="6260235"/>
-                </a:lnTo>
-                <a:close/>
-                <a:lnTo>
-                  <a:pt x="746811" y="6246759"/>
-                </a:lnTo>
-                <a:close/>
-                <a:lnTo>
-                  <a:pt x="753539" y="6233348"/>
-                </a:lnTo>
-                <a:close/>
-                <a:lnTo>
-                  <a:pt x="760267" y="6219827"/>
-                </a:lnTo>
-                <a:close/>
-                <a:lnTo>
-                  <a:pt x="766995" y="6206332"/>
-                </a:lnTo>
-                <a:close/>
-                <a:lnTo>
-                  <a:pt x="773723" y="6193433"/>
-                </a:lnTo>
-                <a:close/>
-                <a:lnTo>
-                  <a:pt x="780451" y="6178028"/>
-                </a:lnTo>
-                <a:close/>
-                <a:lnTo>
-                  <a:pt x="787179" y="6161228"/>
-                </a:lnTo>
-                <a:close/>
-                <a:lnTo>
-                  <a:pt x="793907" y="6147736"/>
-                </a:lnTo>
-                <a:close/>
-                <a:lnTo>
-                  <a:pt x="800635" y="6135187"/>
-                </a:lnTo>
-                <a:close/>
-                <a:lnTo>
-                  <a:pt x="807363" y="6119779"/>
-                </a:lnTo>
-                <a:close/>
-                <a:lnTo>
-                  <a:pt x="814091" y="6103014"/>
-                </a:lnTo>
-                <a:close/>
-                <a:lnTo>
-                  <a:pt x="820819" y="6089845"/>
-                </a:lnTo>
-                <a:close/>
-                <a:lnTo>
-                  <a:pt x="827547" y="6073886"/>
-                </a:lnTo>
-                <a:close/>
-                <a:lnTo>
-                  <a:pt x="834275" y="6057848"/>
-                </a:lnTo>
-                <a:close/>
-                <a:lnTo>
-                  <a:pt x="841003" y="6044708"/>
-                </a:lnTo>
-                <a:close/>
-                <a:lnTo>
-                  <a:pt x="847731" y="6028285"/>
-                </a:lnTo>
-                <a:close/>
-                <a:lnTo>
-                  <a:pt x="854459" y="6011016"/>
-                </a:lnTo>
-                <a:close/>
-                <a:lnTo>
-                  <a:pt x="861187" y="5994365"/>
-                </a:lnTo>
-                <a:close/>
-                <a:lnTo>
-                  <a:pt x="867915" y="5977522"/>
-                </a:lnTo>
-                <a:close/>
-                <a:lnTo>
-                  <a:pt x="874643" y="5960679"/>
-                </a:lnTo>
-                <a:close/>
-                <a:lnTo>
-                  <a:pt x="881372" y="5943905"/>
-                </a:lnTo>
-                <a:close/>
-                <a:lnTo>
-                  <a:pt x="888100" y="5927025"/>
-                </a:lnTo>
-                <a:close/>
-                <a:lnTo>
-                  <a:pt x="894828" y="5910153"/>
-                </a:lnTo>
-                <a:close/>
-                <a:lnTo>
-                  <a:pt x="901556" y="5893896"/>
-                </a:lnTo>
-                <a:close/>
-                <a:lnTo>
-                  <a:pt x="908284" y="5875232"/>
-                </a:lnTo>
-                <a:close/>
-                <a:lnTo>
-                  <a:pt x="915012" y="5855014"/>
-                </a:lnTo>
-                <a:close/>
-                <a:lnTo>
-                  <a:pt x="921740" y="5838080"/>
-                </a:lnTo>
-                <a:close/>
-                <a:lnTo>
-                  <a:pt x="928468" y="5822193"/>
-                </a:lnTo>
-                <a:close/>
-                <a:lnTo>
-                  <a:pt x="935196" y="5803530"/>
-                </a:lnTo>
-                <a:close/>
-                <a:lnTo>
-                  <a:pt x="941924" y="5783331"/>
-                </a:lnTo>
-                <a:close/>
-                <a:lnTo>
-                  <a:pt x="948652" y="5766758"/>
-                </a:lnTo>
-                <a:close/>
-                <a:lnTo>
-                  <a:pt x="955380" y="5747552"/>
-                </a:lnTo>
-                <a:close/>
-                <a:lnTo>
-                  <a:pt x="962108" y="5728041"/>
-                </a:lnTo>
-                <a:close/>
-                <a:lnTo>
-                  <a:pt x="968836" y="5711555"/>
-                </a:lnTo>
-                <a:close/>
-                <a:lnTo>
-                  <a:pt x="975564" y="5691860"/>
-                </a:lnTo>
-                <a:close/>
-                <a:lnTo>
-                  <a:pt x="982292" y="5671203"/>
-                </a:lnTo>
-                <a:close/>
-                <a:lnTo>
-                  <a:pt x="989020" y="5651188"/>
-                </a:lnTo>
-                <a:close/>
-                <a:lnTo>
-                  <a:pt x="995748" y="5630985"/>
-                </a:lnTo>
-                <a:close/>
-                <a:lnTo>
-                  <a:pt x="1002476" y="5610774"/>
-                </a:lnTo>
-                <a:close/>
-                <a:lnTo>
-                  <a:pt x="1009204" y="5590639"/>
-                </a:lnTo>
-                <a:close/>
-                <a:lnTo>
-                  <a:pt x="1015932" y="5570397"/>
-                </a:lnTo>
-                <a:close/>
-                <a:lnTo>
-                  <a:pt x="1022660" y="5550140"/>
-                </a:lnTo>
-                <a:close/>
-                <a:lnTo>
-                  <a:pt x="1029388" y="5530581"/>
-                </a:lnTo>
-                <a:close/>
-                <a:lnTo>
-                  <a:pt x="1036116" y="5508498"/>
-                </a:lnTo>
-                <a:close/>
-                <a:lnTo>
-                  <a:pt x="1042844" y="5485032"/>
-                </a:lnTo>
-                <a:close/>
-                <a:lnTo>
-                  <a:pt x="1049572" y="5465159"/>
-                </a:lnTo>
-                <a:close/>
-                <a:lnTo>
-                  <a:pt x="1056300" y="5442383"/>
-                </a:lnTo>
-                <a:close/>
-                <a:lnTo>
-                  <a:pt x="1063028" y="5419709"/>
-                </a:lnTo>
-                <a:close/>
-                <a:lnTo>
-                  <a:pt x="1069756" y="5399821"/>
-                </a:lnTo>
-                <a:close/>
-                <a:lnTo>
-                  <a:pt x="1076484" y="5376596"/>
-                </a:lnTo>
-                <a:close/>
-                <a:lnTo>
-                  <a:pt x="1083212" y="5352620"/>
-                </a:lnTo>
-                <a:close/>
-                <a:lnTo>
-                  <a:pt x="1089940" y="5329239"/>
-                </a:lnTo>
-                <a:close/>
-                <a:lnTo>
-                  <a:pt x="1096668" y="5305665"/>
-                </a:lnTo>
-                <a:close/>
-                <a:lnTo>
-                  <a:pt x="1103396" y="5282109"/>
-                </a:lnTo>
-                <a:close/>
-                <a:lnTo>
-                  <a:pt x="1110124" y="5258559"/>
-                </a:lnTo>
-                <a:close/>
-                <a:lnTo>
-                  <a:pt x="1116852" y="5235026"/>
-                </a:lnTo>
-                <a:close/>
-                <a:lnTo>
-                  <a:pt x="1123580" y="5211490"/>
-                </a:lnTo>
-                <a:close/>
-                <a:lnTo>
-                  <a:pt x="1130308" y="5187781"/>
-                </a:lnTo>
-                <a:close/>
-                <a:lnTo>
-                  <a:pt x="1137037" y="5164735"/>
-                </a:lnTo>
-                <a:close/>
-                <a:lnTo>
-                  <a:pt x="1143765" y="5140533"/>
-                </a:lnTo>
-                <a:close/>
-                <a:lnTo>
-                  <a:pt x="1150493" y="5113293"/>
-                </a:lnTo>
-                <a:close/>
-                <a:lnTo>
-                  <a:pt x="1157221" y="5089112"/>
-                </a:lnTo>
-                <a:close/>
-                <a:lnTo>
-                  <a:pt x="1163949" y="5064774"/>
-                </a:lnTo>
-                <a:close/>
-                <a:lnTo>
-                  <a:pt x="1170677" y="5037345"/>
-                </a:lnTo>
-                <a:close/>
-                <a:lnTo>
-                  <a:pt x="1177405" y="5010390"/>
-                </a:lnTo>
-                <a:close/>
-                <a:lnTo>
-                  <a:pt x="1184133" y="4983567"/>
-                </a:lnTo>
-                <a:close/>
-                <a:lnTo>
-                  <a:pt x="1190861" y="4956636"/>
-                </a:lnTo>
-                <a:close/>
-                <a:lnTo>
-                  <a:pt x="1197589" y="4929722"/>
-                </a:lnTo>
-                <a:close/>
-                <a:lnTo>
-                  <a:pt x="1204317" y="4902682"/>
-                </a:lnTo>
-                <a:close/>
-                <a:lnTo>
-                  <a:pt x="1211045" y="4876308"/>
-                </a:lnTo>
-                <a:close/>
-                <a:lnTo>
-                  <a:pt x="1217773" y="4848337"/>
-                </a:lnTo>
-                <a:close/>
-                <a:lnTo>
-                  <a:pt x="1224501" y="4817797"/>
-                </a:lnTo>
-                <a:close/>
-                <a:lnTo>
-                  <a:pt x="1231229" y="4790134"/>
-                </a:lnTo>
-                <a:close/>
-                <a:lnTo>
-                  <a:pt x="1237957" y="4764102"/>
-                </a:lnTo>
-                <a:close/>
-                <a:lnTo>
-                  <a:pt x="1244685" y="4736410"/>
-                </a:lnTo>
-                <a:close/>
-                <a:lnTo>
-                  <a:pt x="1251413" y="4706029"/>
-                </a:lnTo>
-                <a:close/>
-                <a:lnTo>
-                  <a:pt x="1258141" y="4675584"/>
-                </a:lnTo>
-                <a:close/>
-                <a:lnTo>
-                  <a:pt x="1264869" y="4645400"/>
-                </a:lnTo>
-                <a:close/>
-                <a:lnTo>
-                  <a:pt x="1271597" y="4615107"/>
-                </a:lnTo>
-                <a:close/>
-                <a:lnTo>
-                  <a:pt x="1278325" y="4584857"/>
-                </a:lnTo>
-                <a:close/>
-                <a:lnTo>
-                  <a:pt x="1285053" y="4554420"/>
-                </a:lnTo>
-                <a:close/>
-                <a:lnTo>
-                  <a:pt x="1291781" y="4524558"/>
-                </a:lnTo>
-                <a:close/>
-                <a:lnTo>
-                  <a:pt x="1298509" y="4493980"/>
-                </a:lnTo>
-                <a:close/>
-                <a:lnTo>
-                  <a:pt x="1305237" y="4460080"/>
-                </a:lnTo>
-                <a:close/>
-                <a:lnTo>
-                  <a:pt x="1311965" y="4428759"/>
-                </a:lnTo>
-                <a:close/>
-                <a:lnTo>
-                  <a:pt x="1318693" y="4398056"/>
-                </a:lnTo>
-                <a:close/>
-                <a:lnTo>
-                  <a:pt x="1325421" y="4364026"/>
-                </a:lnTo>
-                <a:close/>
-                <a:lnTo>
-                  <a:pt x="1332149" y="4330253"/>
-                </a:lnTo>
-                <a:close/>
-                <a:lnTo>
-                  <a:pt x="1338877" y="4296741"/>
-                </a:lnTo>
-                <a:close/>
-                <a:lnTo>
-                  <a:pt x="1345605" y="4263051"/>
-                </a:lnTo>
-                <a:close/>
-                <a:lnTo>
-                  <a:pt x="1352333" y="4229414"/>
-                </a:lnTo>
-                <a:close/>
-                <a:lnTo>
-                  <a:pt x="1359061" y="4195820"/>
-                </a:lnTo>
-                <a:close/>
-                <a:lnTo>
-                  <a:pt x="1365789" y="4162038"/>
-                </a:lnTo>
-                <a:close/>
-                <a:lnTo>
-                  <a:pt x="1372517" y="4128595"/>
-                </a:lnTo>
-                <a:close/>
-                <a:lnTo>
-                  <a:pt x="1379245" y="4095230"/>
-                </a:lnTo>
-                <a:close/>
-                <a:lnTo>
-                  <a:pt x="1385974" y="4058444"/>
-                </a:lnTo>
-                <a:close/>
-                <a:lnTo>
-                  <a:pt x="1392702" y="4022770"/>
-                </a:lnTo>
-                <a:close/>
-                <a:lnTo>
-                  <a:pt x="1399430" y="3989293"/>
-                </a:lnTo>
-                <a:close/>
-                <a:lnTo>
-                  <a:pt x="1406158" y="3952391"/>
-                </a:lnTo>
-                <a:close/>
-                <a:lnTo>
-                  <a:pt x="1412886" y="3915036"/>
-                </a:lnTo>
-                <a:close/>
-                <a:lnTo>
-                  <a:pt x="1419614" y="3878186"/>
-                </a:lnTo>
-                <a:close/>
-                <a:lnTo>
-                  <a:pt x="1426342" y="3841153"/>
-                </a:lnTo>
-                <a:close/>
-                <a:lnTo>
-                  <a:pt x="1433070" y="3804176"/>
-                </a:lnTo>
-                <a:close/>
-                <a:lnTo>
-                  <a:pt x="1439798" y="3767032"/>
-                </a:lnTo>
-                <a:close/>
-                <a:lnTo>
-                  <a:pt x="1446526" y="3730323"/>
-                </a:lnTo>
-                <a:close/>
-                <a:lnTo>
-                  <a:pt x="1453254" y="3693313"/>
-                </a:lnTo>
-                <a:close/>
-                <a:lnTo>
-                  <a:pt x="1459982" y="3652991"/>
-                </a:lnTo>
-                <a:close/>
-                <a:lnTo>
-                  <a:pt x="1466710" y="3613989"/>
-                </a:lnTo>
-                <a:close/>
-                <a:lnTo>
-                  <a:pt x="1473438" y="3577725"/>
-                </a:lnTo>
-                <a:close/>
-                <a:lnTo>
-                  <a:pt x="1480166" y="3540788"/>
-                </a:lnTo>
-                <a:close/>
-                <a:lnTo>
-                  <a:pt x="1486894" y="3501167"/>
-                </a:lnTo>
-                <a:close/>
-                <a:lnTo>
-                  <a:pt x="1493622" y="3459958"/>
-                </a:lnTo>
-                <a:close/>
-                <a:lnTo>
-                  <a:pt x="1500350" y="3420298"/>
-                </a:lnTo>
-                <a:close/>
-                <a:lnTo>
-                  <a:pt x="1507078" y="3383555"/>
-                </a:lnTo>
-                <a:close/>
-                <a:lnTo>
-                  <a:pt x="1513806" y="3344281"/>
-                </a:lnTo>
-                <a:close/>
-                <a:lnTo>
-                  <a:pt x="1520534" y="3303367"/>
-                </a:lnTo>
-                <a:close/>
-                <a:lnTo>
-                  <a:pt x="1527262" y="3263128"/>
-                </a:lnTo>
-                <a:close/>
-                <a:lnTo>
-                  <a:pt x="1533990" y="3222774"/>
-                </a:lnTo>
-                <a:close/>
-                <a:lnTo>
-                  <a:pt x="1540718" y="3182370"/>
-                </a:lnTo>
-                <a:close/>
-                <a:lnTo>
-                  <a:pt x="1547446" y="3142037"/>
-                </a:lnTo>
-                <a:close/>
-                <a:lnTo>
-                  <a:pt x="1554174" y="3101657"/>
-                </a:lnTo>
-                <a:close/>
-                <a:lnTo>
-                  <a:pt x="1560902" y="3061158"/>
-                </a:lnTo>
-                <a:close/>
-                <a:lnTo>
-                  <a:pt x="1567630" y="3021326"/>
-                </a:lnTo>
-                <a:close/>
-                <a:lnTo>
-                  <a:pt x="1574358" y="2979920"/>
-                </a:lnTo>
-                <a:close/>
-                <a:lnTo>
-                  <a:pt x="1581086" y="2935923"/>
-                </a:lnTo>
-                <a:close/>
-                <a:lnTo>
-                  <a:pt x="1587814" y="2894750"/>
-                </a:lnTo>
-                <a:close/>
-                <a:lnTo>
-                  <a:pt x="1594542" y="2855395"/>
-                </a:lnTo>
-                <a:close/>
-                <a:lnTo>
-                  <a:pt x="1601270" y="2814059"/>
-                </a:lnTo>
-                <a:close/>
-                <a:lnTo>
-                  <a:pt x="1607998" y="2770014"/>
-                </a:lnTo>
-                <a:close/>
-                <a:lnTo>
-                  <a:pt x="1614726" y="2729153"/>
-                </a:lnTo>
-                <a:close/>
-                <a:lnTo>
-                  <a:pt x="1621454" y="2687937"/>
-                </a:lnTo>
-                <a:close/>
-                <a:lnTo>
-                  <a:pt x="1628182" y="2643515"/>
-                </a:lnTo>
-                <a:close/>
-                <a:lnTo>
-                  <a:pt x="1634911" y="2599422"/>
-                </a:lnTo>
-                <a:close/>
-                <a:lnTo>
-                  <a:pt x="1641639" y="2558637"/>
-                </a:lnTo>
-                <a:close/>
-                <a:lnTo>
-                  <a:pt x="1648367" y="2517433"/>
-                </a:lnTo>
-                <a:close/>
-                <a:lnTo>
-                  <a:pt x="1655095" y="2473251"/>
-                </a:lnTo>
-                <a:close/>
-                <a:lnTo>
-                  <a:pt x="1661823" y="2429454"/>
-                </a:lnTo>
-                <a:close/>
-                <a:lnTo>
-                  <a:pt x="1668551" y="2385822"/>
-                </a:lnTo>
-                <a:close/>
-                <a:lnTo>
-                  <a:pt x="1675279" y="2342049"/>
-                </a:lnTo>
-                <a:close/>
-                <a:lnTo>
-                  <a:pt x="1682007" y="2298323"/>
-                </a:lnTo>
-                <a:close/>
-                <a:lnTo>
-                  <a:pt x="1688735" y="2254597"/>
-                </a:lnTo>
-                <a:close/>
-                <a:lnTo>
-                  <a:pt x="1695463" y="2210851"/>
-                </a:lnTo>
-                <a:close/>
-                <a:lnTo>
-                  <a:pt x="1702191" y="2167139"/>
-                </a:lnTo>
-                <a:close/>
-                <a:lnTo>
-                  <a:pt x="1708919" y="2123416"/>
-                </a:lnTo>
-                <a:close/>
-                <a:lnTo>
-                  <a:pt x="1715647" y="2079521"/>
-                </a:lnTo>
-                <a:close/>
-                <a:lnTo>
-                  <a:pt x="1722375" y="2036315"/>
-                </a:lnTo>
-                <a:close/>
-                <a:lnTo>
-                  <a:pt x="1729103" y="1991849"/>
-                </a:lnTo>
-                <a:close/>
-                <a:lnTo>
-                  <a:pt x="1735831" y="1944402"/>
-                </a:lnTo>
-                <a:close/>
-                <a:lnTo>
-                  <a:pt x="1742559" y="1900271"/>
-                </a:lnTo>
-                <a:close/>
-                <a:lnTo>
-                  <a:pt x="1749287" y="1855221"/>
-                </a:lnTo>
-                <a:close/>
-                <a:lnTo>
-                  <a:pt x="1756015" y="1808045"/>
-                </a:lnTo>
-                <a:close/>
-                <a:lnTo>
-                  <a:pt x="1762743" y="1764604"/>
-                </a:lnTo>
-                <a:close/>
-                <a:lnTo>
-                  <a:pt x="1769471" y="1718354"/>
-                </a:lnTo>
-                <a:close/>
-                <a:lnTo>
-                  <a:pt x="1776199" y="1672056"/>
-                </a:lnTo>
-                <a:close/>
-                <a:lnTo>
-                  <a:pt x="1782927" y="1628645"/>
-                </a:lnTo>
-                <a:close/>
-                <a:lnTo>
-                  <a:pt x="1789655" y="1582030"/>
-                </a:lnTo>
-                <a:close/>
-                <a:lnTo>
-                  <a:pt x="1796383" y="1533940"/>
-                </a:lnTo>
-                <a:close/>
-                <a:lnTo>
-                  <a:pt x="1803111" y="1488155"/>
-                </a:lnTo>
-                <a:close/>
-                <a:lnTo>
-                  <a:pt x="1809839" y="1444655"/>
-                </a:lnTo>
-                <a:close/>
-                <a:lnTo>
-                  <a:pt x="1816567" y="1398121"/>
-                </a:lnTo>
-                <a:close/>
-                <a:lnTo>
-                  <a:pt x="1823295" y="1350568"/>
-                </a:lnTo>
-                <a:close/>
-                <a:lnTo>
-                  <a:pt x="1830023" y="1303622"/>
-                </a:lnTo>
-                <a:close/>
-                <a:lnTo>
-                  <a:pt x="1836751" y="1256513"/>
-                </a:lnTo>
-                <a:close/>
-                <a:lnTo>
-                  <a:pt x="1843479" y="1209401"/>
-                </a:lnTo>
-                <a:close/>
-                <a:lnTo>
-                  <a:pt x="1850207" y="1162317"/>
-                </a:lnTo>
-                <a:close/>
-                <a:lnTo>
-                  <a:pt x="1856935" y="1115215"/>
-                </a:lnTo>
-                <a:close/>
-                <a:lnTo>
-                  <a:pt x="1863663" y="1068113"/>
-                </a:lnTo>
-                <a:close/>
-                <a:lnTo>
-                  <a:pt x="1870391" y="1021059"/>
-                </a:lnTo>
-                <a:close/>
-                <a:lnTo>
-                  <a:pt x="1877119" y="973852"/>
-                </a:lnTo>
-                <a:close/>
-                <a:lnTo>
-                  <a:pt x="1883847" y="926848"/>
-                </a:lnTo>
-                <a:close/>
-                <a:lnTo>
-                  <a:pt x="1890576" y="880177"/>
-                </a:lnTo>
-                <a:close/>
-                <a:lnTo>
-                  <a:pt x="1897304" y="830389"/>
-                </a:lnTo>
-                <a:close/>
-                <a:lnTo>
-                  <a:pt x="1904032" y="780564"/>
-                </a:lnTo>
-                <a:close/>
-                <a:lnTo>
-                  <a:pt x="1910760" y="733852"/>
-                </a:lnTo>
-                <a:close/>
-                <a:lnTo>
-                  <a:pt x="1917488" y="686721"/>
-                </a:lnTo>
-                <a:close/>
-                <a:lnTo>
-                  <a:pt x="1924216" y="640097"/>
-                </a:lnTo>
-                <a:close/>
-                <a:lnTo>
-                  <a:pt x="1930944" y="591923"/>
-                </a:lnTo>
-                <a:close/>
-                <a:lnTo>
-                  <a:pt x="1937672" y="541166"/>
-                </a:lnTo>
-                <a:close/>
-                <a:lnTo>
-                  <a:pt x="1944400" y="493996"/>
-                </a:lnTo>
-                <a:close/>
-                <a:lnTo>
-                  <a:pt x="1951128" y="445122"/>
-                </a:lnTo>
-                <a:close/>
-                <a:lnTo>
-                  <a:pt x="1957856" y="394879"/>
-                </a:lnTo>
-                <a:close/>
-                <a:lnTo>
-                  <a:pt x="1964584" y="348159"/>
-                </a:lnTo>
-                <a:close/>
-                <a:lnTo>
-                  <a:pt x="1971312" y="298133"/>
-                </a:lnTo>
-                <a:close/>
-                <a:lnTo>
-                  <a:pt x="1978040" y="248925"/>
-                </a:lnTo>
-                <a:close/>
-                <a:lnTo>
-                  <a:pt x="1984768" y="202002"/>
-                </a:lnTo>
-                <a:close/>
-                <a:lnTo>
-                  <a:pt x="1991496" y="151604"/>
-                </a:lnTo>
-                <a:close/>
-                <a:lnTo>
-                  <a:pt x="1998224" y="100756"/>
-                </a:lnTo>
-                <a:close/>
-                <a:lnTo>
-                  <a:pt x="2004952" y="50570"/>
-                </a:lnTo>
-                <a:close/>
-                <a:lnTo>
-                  <a:pt x="2011680" y="0"/>
+                  <a:pt x="4129" y="1825305"/>
+                </a:lnTo>
+                <a:close/>
+                <a:lnTo>
+                  <a:pt x="8257" y="1823609"/>
+                </a:lnTo>
+                <a:close/>
+                <a:lnTo>
+                  <a:pt x="12386" y="1821883"/>
+                </a:lnTo>
+                <a:close/>
+                <a:lnTo>
+                  <a:pt x="16514" y="1820127"/>
+                </a:lnTo>
+                <a:close/>
+                <a:lnTo>
+                  <a:pt x="20643" y="1818341"/>
+                </a:lnTo>
+                <a:close/>
+                <a:lnTo>
+                  <a:pt x="24771" y="1816526"/>
+                </a:lnTo>
+                <a:close/>
+                <a:lnTo>
+                  <a:pt x="28900" y="1814680"/>
+                </a:lnTo>
+                <a:close/>
+                <a:lnTo>
+                  <a:pt x="33028" y="1812805"/>
+                </a:lnTo>
+                <a:close/>
+                <a:lnTo>
+                  <a:pt x="37157" y="1810900"/>
+                </a:lnTo>
+                <a:close/>
+                <a:lnTo>
+                  <a:pt x="41286" y="1808965"/>
+                </a:lnTo>
+                <a:close/>
+                <a:lnTo>
+                  <a:pt x="45414" y="1807001"/>
+                </a:lnTo>
+                <a:close/>
+                <a:lnTo>
+                  <a:pt x="49543" y="1805006"/>
+                </a:lnTo>
+                <a:close/>
+                <a:lnTo>
+                  <a:pt x="53671" y="1802982"/>
+                </a:lnTo>
+                <a:close/>
+                <a:lnTo>
+                  <a:pt x="57800" y="1800928"/>
+                </a:lnTo>
+                <a:close/>
+                <a:lnTo>
+                  <a:pt x="61928" y="1798844"/>
+                </a:lnTo>
+                <a:close/>
+                <a:lnTo>
+                  <a:pt x="66057" y="1796731"/>
+                </a:lnTo>
+                <a:close/>
+                <a:lnTo>
+                  <a:pt x="70186" y="1794587"/>
+                </a:lnTo>
+                <a:close/>
+                <a:lnTo>
+                  <a:pt x="74314" y="1792414"/>
+                </a:lnTo>
+                <a:close/>
+                <a:lnTo>
+                  <a:pt x="78443" y="1790211"/>
+                </a:lnTo>
+                <a:close/>
+                <a:lnTo>
+                  <a:pt x="82571" y="1787977"/>
+                </a:lnTo>
+                <a:close/>
+                <a:lnTo>
+                  <a:pt x="86700" y="1785715"/>
+                </a:lnTo>
+                <a:close/>
+                <a:lnTo>
+                  <a:pt x="90828" y="1783422"/>
+                </a:lnTo>
+                <a:close/>
+                <a:lnTo>
+                  <a:pt x="94957" y="1781100"/>
+                </a:lnTo>
+                <a:close/>
+                <a:lnTo>
+                  <a:pt x="99085" y="1778747"/>
+                </a:lnTo>
+                <a:close/>
+                <a:lnTo>
+                  <a:pt x="103214" y="1776365"/>
+                </a:lnTo>
+                <a:close/>
+                <a:lnTo>
+                  <a:pt x="107343" y="1773953"/>
+                </a:lnTo>
+                <a:close/>
+                <a:lnTo>
+                  <a:pt x="111471" y="1771511"/>
+                </a:lnTo>
+                <a:close/>
+                <a:lnTo>
+                  <a:pt x="115600" y="1769040"/>
+                </a:lnTo>
+                <a:close/>
+                <a:lnTo>
+                  <a:pt x="119728" y="1766538"/>
+                </a:lnTo>
+                <a:close/>
+                <a:lnTo>
+                  <a:pt x="123857" y="1764007"/>
+                </a:lnTo>
+                <a:close/>
+                <a:lnTo>
+                  <a:pt x="127985" y="1761446"/>
+                </a:lnTo>
+                <a:close/>
+                <a:lnTo>
+                  <a:pt x="132114" y="1758855"/>
+                </a:lnTo>
+                <a:close/>
+                <a:lnTo>
+                  <a:pt x="136243" y="1756234"/>
+                </a:lnTo>
+                <a:close/>
+                <a:lnTo>
+                  <a:pt x="140371" y="1753584"/>
+                </a:lnTo>
+                <a:close/>
+                <a:lnTo>
+                  <a:pt x="144500" y="1750903"/>
+                </a:lnTo>
+                <a:close/>
+                <a:lnTo>
+                  <a:pt x="148628" y="1748193"/>
+                </a:lnTo>
+                <a:close/>
+                <a:lnTo>
+                  <a:pt x="152757" y="1745453"/>
+                </a:lnTo>
+                <a:close/>
+                <a:lnTo>
+                  <a:pt x="156885" y="1742683"/>
+                </a:lnTo>
+                <a:close/>
+                <a:lnTo>
+                  <a:pt x="161014" y="1739883"/>
+                </a:lnTo>
+                <a:close/>
+                <a:lnTo>
+                  <a:pt x="165142" y="1737054"/>
+                </a:lnTo>
+                <a:close/>
+                <a:lnTo>
+                  <a:pt x="169271" y="1734195"/>
+                </a:lnTo>
+                <a:close/>
+                <a:lnTo>
+                  <a:pt x="173400" y="1731305"/>
+                </a:lnTo>
+                <a:close/>
+                <a:lnTo>
+                  <a:pt x="177528" y="1728386"/>
+                </a:lnTo>
+                <a:close/>
+                <a:lnTo>
+                  <a:pt x="181657" y="1725438"/>
+                </a:lnTo>
+                <a:close/>
+                <a:lnTo>
+                  <a:pt x="185785" y="1722459"/>
+                </a:lnTo>
+                <a:close/>
+                <a:lnTo>
+                  <a:pt x="189914" y="1719451"/>
+                </a:lnTo>
+                <a:close/>
+                <a:lnTo>
+                  <a:pt x="194042" y="1716412"/>
+                </a:lnTo>
+                <a:close/>
+                <a:lnTo>
+                  <a:pt x="198171" y="1713344"/>
+                </a:lnTo>
+                <a:close/>
+                <a:lnTo>
+                  <a:pt x="202300" y="1710246"/>
+                </a:lnTo>
+                <a:close/>
+                <a:lnTo>
+                  <a:pt x="206428" y="1707118"/>
+                </a:lnTo>
+                <a:close/>
+                <a:lnTo>
+                  <a:pt x="210557" y="1703961"/>
+                </a:lnTo>
+                <a:close/>
+                <a:lnTo>
+                  <a:pt x="214685" y="1700773"/>
+                </a:lnTo>
+                <a:close/>
+                <a:lnTo>
+                  <a:pt x="218814" y="1697556"/>
+                </a:lnTo>
+                <a:close/>
+                <a:lnTo>
+                  <a:pt x="222942" y="1694309"/>
+                </a:lnTo>
+                <a:close/>
+                <a:lnTo>
+                  <a:pt x="227071" y="1691032"/>
+                </a:lnTo>
+                <a:close/>
+                <a:lnTo>
+                  <a:pt x="231199" y="1687726"/>
+                </a:lnTo>
+                <a:close/>
+                <a:lnTo>
+                  <a:pt x="235328" y="1684389"/>
+                </a:lnTo>
+                <a:close/>
+                <a:lnTo>
+                  <a:pt x="239457" y="1681023"/>
+                </a:lnTo>
+                <a:close/>
+                <a:lnTo>
+                  <a:pt x="243585" y="1677626"/>
+                </a:lnTo>
+                <a:close/>
+                <a:lnTo>
+                  <a:pt x="247714" y="1674200"/>
+                </a:lnTo>
+                <a:close/>
+                <a:lnTo>
+                  <a:pt x="251842" y="1670745"/>
+                </a:lnTo>
+                <a:close/>
+                <a:lnTo>
+                  <a:pt x="255971" y="1667259"/>
+                </a:lnTo>
+                <a:close/>
+                <a:lnTo>
+                  <a:pt x="260099" y="1663743"/>
+                </a:lnTo>
+                <a:close/>
+                <a:lnTo>
+                  <a:pt x="264228" y="1660198"/>
+                </a:lnTo>
+                <a:close/>
+                <a:lnTo>
+                  <a:pt x="268357" y="1656623"/>
+                </a:lnTo>
+                <a:close/>
+                <a:lnTo>
+                  <a:pt x="272485" y="1653018"/>
+                </a:lnTo>
+                <a:close/>
+                <a:lnTo>
+                  <a:pt x="276614" y="1649383"/>
+                </a:lnTo>
+                <a:close/>
+                <a:lnTo>
+                  <a:pt x="280742" y="1645719"/>
+                </a:lnTo>
+                <a:close/>
+                <a:lnTo>
+                  <a:pt x="284871" y="1642024"/>
+                </a:lnTo>
+                <a:close/>
+                <a:lnTo>
+                  <a:pt x="288999" y="1638300"/>
+                </a:lnTo>
+                <a:close/>
+                <a:lnTo>
+                  <a:pt x="293128" y="1634546"/>
+                </a:lnTo>
+                <a:close/>
+                <a:lnTo>
+                  <a:pt x="297256" y="1630762"/>
+                </a:lnTo>
+                <a:close/>
+                <a:lnTo>
+                  <a:pt x="301385" y="1626948"/>
+                </a:lnTo>
+                <a:close/>
+                <a:lnTo>
+                  <a:pt x="305514" y="1623105"/>
+                </a:lnTo>
+                <a:close/>
+                <a:lnTo>
+                  <a:pt x="309642" y="1619231"/>
+                </a:lnTo>
+                <a:close/>
+                <a:lnTo>
+                  <a:pt x="313771" y="1615328"/>
+                </a:lnTo>
+                <a:close/>
+                <a:lnTo>
+                  <a:pt x="317899" y="1611395"/>
+                </a:lnTo>
+                <a:close/>
+                <a:lnTo>
+                  <a:pt x="322028" y="1607432"/>
+                </a:lnTo>
+                <a:close/>
+                <a:lnTo>
+                  <a:pt x="326156" y="1603439"/>
+                </a:lnTo>
+                <a:close/>
+                <a:lnTo>
+                  <a:pt x="330285" y="1599417"/>
+                </a:lnTo>
+                <a:close/>
+                <a:lnTo>
+                  <a:pt x="334414" y="1595364"/>
+                </a:lnTo>
+                <a:close/>
+                <a:lnTo>
+                  <a:pt x="338542" y="1591282"/>
+                </a:lnTo>
+                <a:close/>
+                <a:lnTo>
+                  <a:pt x="342671" y="1587170"/>
+                </a:lnTo>
+                <a:close/>
+                <a:lnTo>
+                  <a:pt x="346799" y="1583029"/>
+                </a:lnTo>
+                <a:close/>
+                <a:lnTo>
+                  <a:pt x="350928" y="1578857"/>
+                </a:lnTo>
+                <a:close/>
+                <a:lnTo>
+                  <a:pt x="355056" y="1574655"/>
+                </a:lnTo>
+                <a:close/>
+                <a:lnTo>
+                  <a:pt x="359185" y="1570424"/>
+                </a:lnTo>
+                <a:close/>
+                <a:lnTo>
+                  <a:pt x="363313" y="1566163"/>
+                </a:lnTo>
+                <a:close/>
+                <a:lnTo>
+                  <a:pt x="367442" y="1561872"/>
+                </a:lnTo>
+                <a:close/>
+                <a:lnTo>
+                  <a:pt x="371571" y="1557551"/>
+                </a:lnTo>
+                <a:close/>
+                <a:lnTo>
+                  <a:pt x="375699" y="1553201"/>
+                </a:lnTo>
+                <a:close/>
+                <a:lnTo>
+                  <a:pt x="379828" y="1548820"/>
+                </a:lnTo>
+                <a:close/>
+                <a:lnTo>
+                  <a:pt x="383956" y="1544410"/>
+                </a:lnTo>
+                <a:close/>
+                <a:lnTo>
+                  <a:pt x="388085" y="1539970"/>
+                </a:lnTo>
+                <a:close/>
+                <a:lnTo>
+                  <a:pt x="392213" y="1535500"/>
+                </a:lnTo>
+                <a:close/>
+                <a:lnTo>
+                  <a:pt x="396342" y="1531000"/>
+                </a:lnTo>
+                <a:close/>
+                <a:lnTo>
+                  <a:pt x="400471" y="1526471"/>
+                </a:lnTo>
+                <a:close/>
+                <a:lnTo>
+                  <a:pt x="404599" y="1521911"/>
+                </a:lnTo>
+                <a:close/>
+                <a:lnTo>
+                  <a:pt x="408728" y="1517322"/>
+                </a:lnTo>
+                <a:close/>
+                <a:lnTo>
+                  <a:pt x="412856" y="1512703"/>
+                </a:lnTo>
+                <a:close/>
+                <a:lnTo>
+                  <a:pt x="416985" y="1508054"/>
+                </a:lnTo>
+                <a:close/>
+                <a:lnTo>
+                  <a:pt x="421113" y="1503376"/>
+                </a:lnTo>
+                <a:close/>
+                <a:lnTo>
+                  <a:pt x="425242" y="1498667"/>
+                </a:lnTo>
+                <a:close/>
+                <a:lnTo>
+                  <a:pt x="429370" y="1493929"/>
+                </a:lnTo>
+                <a:close/>
+                <a:lnTo>
+                  <a:pt x="433499" y="1489161"/>
+                </a:lnTo>
+                <a:close/>
+                <a:lnTo>
+                  <a:pt x="437628" y="1484363"/>
+                </a:lnTo>
+                <a:close/>
+                <a:lnTo>
+                  <a:pt x="441756" y="1479535"/>
+                </a:lnTo>
+                <a:close/>
+                <a:lnTo>
+                  <a:pt x="445885" y="1474677"/>
+                </a:lnTo>
+                <a:close/>
+                <a:lnTo>
+                  <a:pt x="450013" y="1469790"/>
+                </a:lnTo>
+                <a:close/>
+                <a:lnTo>
+                  <a:pt x="454142" y="1464873"/>
+                </a:lnTo>
+                <a:close/>
+                <a:lnTo>
+                  <a:pt x="458270" y="1459926"/>
+                </a:lnTo>
+                <a:close/>
+                <a:lnTo>
+                  <a:pt x="462399" y="1454949"/>
+                </a:lnTo>
+                <a:close/>
+                <a:lnTo>
+                  <a:pt x="466527" y="1449942"/>
+                </a:lnTo>
+                <a:close/>
+                <a:lnTo>
+                  <a:pt x="470656" y="1444905"/>
+                </a:lnTo>
+                <a:close/>
+                <a:lnTo>
+                  <a:pt x="474785" y="1439839"/>
+                </a:lnTo>
+                <a:close/>
+                <a:lnTo>
+                  <a:pt x="478913" y="1434743"/>
+                </a:lnTo>
+                <a:close/>
+                <a:lnTo>
+                  <a:pt x="483042" y="1429617"/>
+                </a:lnTo>
+                <a:close/>
+                <a:lnTo>
+                  <a:pt x="487170" y="1424461"/>
+                </a:lnTo>
+                <a:close/>
+                <a:lnTo>
+                  <a:pt x="491299" y="1419275"/>
+                </a:lnTo>
+                <a:close/>
+                <a:lnTo>
+                  <a:pt x="495427" y="1414060"/>
+                </a:lnTo>
+                <a:close/>
+                <a:lnTo>
+                  <a:pt x="499556" y="1408814"/>
+                </a:lnTo>
+                <a:close/>
+                <a:lnTo>
+                  <a:pt x="503685" y="1403539"/>
+                </a:lnTo>
+                <a:close/>
+                <a:lnTo>
+                  <a:pt x="507813" y="1398234"/>
+                </a:lnTo>
+                <a:close/>
+                <a:lnTo>
+                  <a:pt x="511942" y="1392899"/>
+                </a:lnTo>
+                <a:close/>
+                <a:lnTo>
+                  <a:pt x="516070" y="1387535"/>
+                </a:lnTo>
+                <a:close/>
+                <a:lnTo>
+                  <a:pt x="520199" y="1382140"/>
+                </a:lnTo>
+                <a:close/>
+                <a:lnTo>
+                  <a:pt x="524327" y="1376716"/>
+                </a:lnTo>
+                <a:close/>
+                <a:lnTo>
+                  <a:pt x="528456" y="1371262"/>
+                </a:lnTo>
+                <a:close/>
+                <a:lnTo>
+                  <a:pt x="532584" y="1365778"/>
+                </a:lnTo>
+                <a:close/>
+                <a:lnTo>
+                  <a:pt x="536713" y="1360264"/>
+                </a:lnTo>
+                <a:close/>
+                <a:lnTo>
+                  <a:pt x="540842" y="1354720"/>
+                </a:lnTo>
+                <a:close/>
+                <a:lnTo>
+                  <a:pt x="544970" y="1349147"/>
+                </a:lnTo>
+                <a:close/>
+                <a:lnTo>
+                  <a:pt x="549099" y="1343544"/>
+                </a:lnTo>
+                <a:close/>
+                <a:lnTo>
+                  <a:pt x="553227" y="1337911"/>
+                </a:lnTo>
+                <a:close/>
+                <a:lnTo>
+                  <a:pt x="557356" y="1332248"/>
+                </a:lnTo>
+                <a:close/>
+                <a:lnTo>
+                  <a:pt x="561484" y="1326555"/>
+                </a:lnTo>
+                <a:close/>
+                <a:lnTo>
+                  <a:pt x="565613" y="1320833"/>
+                </a:lnTo>
+                <a:close/>
+                <a:lnTo>
+                  <a:pt x="569742" y="1315080"/>
+                </a:lnTo>
+                <a:close/>
+                <a:lnTo>
+                  <a:pt x="573870" y="1309298"/>
+                </a:lnTo>
+                <a:close/>
+                <a:lnTo>
+                  <a:pt x="577999" y="1303486"/>
+                </a:lnTo>
+                <a:close/>
+                <a:lnTo>
+                  <a:pt x="582127" y="1297644"/>
+                </a:lnTo>
+                <a:close/>
+                <a:lnTo>
+                  <a:pt x="586256" y="1291772"/>
+                </a:lnTo>
+                <a:close/>
+                <a:lnTo>
+                  <a:pt x="590384" y="1285871"/>
+                </a:lnTo>
+                <a:close/>
+                <a:lnTo>
+                  <a:pt x="594513" y="1279940"/>
+                </a:lnTo>
+                <a:close/>
+                <a:lnTo>
+                  <a:pt x="598641" y="1273978"/>
+                </a:lnTo>
+                <a:close/>
+                <a:lnTo>
+                  <a:pt x="602770" y="1267987"/>
+                </a:lnTo>
+                <a:close/>
+                <a:lnTo>
+                  <a:pt x="606899" y="1261967"/>
+                </a:lnTo>
+                <a:close/>
+                <a:lnTo>
+                  <a:pt x="611027" y="1255916"/>
+                </a:lnTo>
+                <a:close/>
+                <a:lnTo>
+                  <a:pt x="615156" y="1249836"/>
+                </a:lnTo>
+                <a:close/>
+                <a:lnTo>
+                  <a:pt x="619284" y="1243725"/>
+                </a:lnTo>
+                <a:close/>
+                <a:lnTo>
+                  <a:pt x="623413" y="1237585"/>
+                </a:lnTo>
+                <a:close/>
+                <a:lnTo>
+                  <a:pt x="627541" y="1231415"/>
+                </a:lnTo>
+                <a:close/>
+                <a:lnTo>
+                  <a:pt x="631670" y="1225216"/>
+                </a:lnTo>
+                <a:close/>
+                <a:lnTo>
+                  <a:pt x="635799" y="1218986"/>
+                </a:lnTo>
+                <a:close/>
+                <a:lnTo>
+                  <a:pt x="639927" y="1212727"/>
+                </a:lnTo>
+                <a:close/>
+                <a:lnTo>
+                  <a:pt x="644056" y="1206437"/>
+                </a:lnTo>
+                <a:close/>
+                <a:lnTo>
+                  <a:pt x="648184" y="1200118"/>
+                </a:lnTo>
+                <a:close/>
+                <a:lnTo>
+                  <a:pt x="652313" y="1193769"/>
+                </a:lnTo>
+                <a:close/>
+                <a:lnTo>
+                  <a:pt x="656441" y="1187391"/>
+                </a:lnTo>
+                <a:close/>
+                <a:lnTo>
+                  <a:pt x="660570" y="1180982"/>
+                </a:lnTo>
+                <a:close/>
+                <a:lnTo>
+                  <a:pt x="664698" y="1174544"/>
+                </a:lnTo>
+                <a:close/>
+                <a:lnTo>
+                  <a:pt x="668827" y="1168076"/>
+                </a:lnTo>
+                <a:close/>
+                <a:lnTo>
+                  <a:pt x="672956" y="1161578"/>
+                </a:lnTo>
+                <a:close/>
+                <a:lnTo>
+                  <a:pt x="677084" y="1155050"/>
+                </a:lnTo>
+                <a:close/>
+                <a:lnTo>
+                  <a:pt x="681213" y="1148492"/>
+                </a:lnTo>
+                <a:close/>
+                <a:lnTo>
+                  <a:pt x="685341" y="1141905"/>
+                </a:lnTo>
+                <a:close/>
+                <a:lnTo>
+                  <a:pt x="689470" y="1135287"/>
+                </a:lnTo>
+                <a:close/>
+                <a:lnTo>
+                  <a:pt x="693598" y="1128640"/>
+                </a:lnTo>
+                <a:close/>
+                <a:lnTo>
+                  <a:pt x="697727" y="1121963"/>
+                </a:lnTo>
+                <a:close/>
+                <a:lnTo>
+                  <a:pt x="701856" y="1115257"/>
+                </a:lnTo>
+                <a:close/>
+                <a:lnTo>
+                  <a:pt x="705984" y="1108520"/>
+                </a:lnTo>
+                <a:close/>
+                <a:lnTo>
+                  <a:pt x="710113" y="1101754"/>
+                </a:lnTo>
+                <a:close/>
+                <a:lnTo>
+                  <a:pt x="714241" y="1094957"/>
+                </a:lnTo>
+                <a:close/>
+                <a:lnTo>
+                  <a:pt x="718370" y="1088131"/>
+                </a:lnTo>
+                <a:close/>
+                <a:lnTo>
+                  <a:pt x="722498" y="1081275"/>
+                </a:lnTo>
+                <a:close/>
+                <a:lnTo>
+                  <a:pt x="726627" y="1074390"/>
+                </a:lnTo>
+                <a:close/>
+                <a:lnTo>
+                  <a:pt x="730755" y="1067474"/>
+                </a:lnTo>
+                <a:close/>
+                <a:lnTo>
+                  <a:pt x="734884" y="1060529"/>
+                </a:lnTo>
+                <a:close/>
+                <a:lnTo>
+                  <a:pt x="739013" y="1053554"/>
+                </a:lnTo>
+                <a:close/>
+                <a:lnTo>
+                  <a:pt x="743141" y="1046549"/>
+                </a:lnTo>
+                <a:close/>
+                <a:lnTo>
+                  <a:pt x="747270" y="1039514"/>
+                </a:lnTo>
+                <a:close/>
+                <a:lnTo>
+                  <a:pt x="751398" y="1032449"/>
+                </a:lnTo>
+                <a:close/>
+                <a:lnTo>
+                  <a:pt x="755527" y="1025355"/>
+                </a:lnTo>
+                <a:close/>
+                <a:lnTo>
+                  <a:pt x="759655" y="1018230"/>
+                </a:lnTo>
+                <a:close/>
+                <a:lnTo>
+                  <a:pt x="763784" y="1011076"/>
+                </a:lnTo>
+                <a:close/>
+                <a:lnTo>
+                  <a:pt x="767913" y="1003892"/>
+                </a:lnTo>
+                <a:close/>
+                <a:lnTo>
+                  <a:pt x="772041" y="996678"/>
+                </a:lnTo>
+                <a:close/>
+                <a:lnTo>
+                  <a:pt x="776170" y="989435"/>
+                </a:lnTo>
+                <a:close/>
+                <a:lnTo>
+                  <a:pt x="780298" y="982161"/>
+                </a:lnTo>
+                <a:close/>
+                <a:lnTo>
+                  <a:pt x="784427" y="974858"/>
+                </a:lnTo>
+                <a:close/>
+                <a:lnTo>
+                  <a:pt x="788555" y="967525"/>
+                </a:lnTo>
+                <a:close/>
+                <a:lnTo>
+                  <a:pt x="792684" y="960162"/>
+                </a:lnTo>
+                <a:close/>
+                <a:lnTo>
+                  <a:pt x="796812" y="952769"/>
+                </a:lnTo>
+                <a:close/>
+                <a:lnTo>
+                  <a:pt x="800941" y="945347"/>
+                </a:lnTo>
+                <a:close/>
+                <a:lnTo>
+                  <a:pt x="805070" y="937894"/>
+                </a:lnTo>
+                <a:close/>
+                <a:lnTo>
+                  <a:pt x="809198" y="930412"/>
+                </a:lnTo>
+                <a:close/>
+                <a:lnTo>
+                  <a:pt x="813327" y="922900"/>
+                </a:lnTo>
+                <a:close/>
+                <a:lnTo>
+                  <a:pt x="817455" y="915358"/>
+                </a:lnTo>
+                <a:close/>
+                <a:lnTo>
+                  <a:pt x="821584" y="907786"/>
+                </a:lnTo>
+                <a:close/>
+                <a:lnTo>
+                  <a:pt x="825712" y="900185"/>
+                </a:lnTo>
+                <a:close/>
+                <a:lnTo>
+                  <a:pt x="829841" y="892553"/>
+                </a:lnTo>
+                <a:close/>
+                <a:lnTo>
+                  <a:pt x="833969" y="884892"/>
+                </a:lnTo>
+                <a:close/>
+                <a:lnTo>
+                  <a:pt x="838098" y="877201"/>
+                </a:lnTo>
+                <a:close/>
+                <a:lnTo>
+                  <a:pt x="842227" y="869480"/>
+                </a:lnTo>
+                <a:close/>
+                <a:lnTo>
+                  <a:pt x="846355" y="861730"/>
+                </a:lnTo>
+                <a:close/>
+                <a:lnTo>
+                  <a:pt x="850484" y="853949"/>
+                </a:lnTo>
+                <a:close/>
+                <a:lnTo>
+                  <a:pt x="854612" y="846139"/>
+                </a:lnTo>
+                <a:close/>
+                <a:lnTo>
+                  <a:pt x="858741" y="838299"/>
+                </a:lnTo>
+                <a:close/>
+                <a:lnTo>
+                  <a:pt x="862869" y="830429"/>
+                </a:lnTo>
+                <a:close/>
+                <a:lnTo>
+                  <a:pt x="866998" y="822529"/>
+                </a:lnTo>
+                <a:close/>
+                <a:lnTo>
+                  <a:pt x="871127" y="814600"/>
+                </a:lnTo>
+                <a:close/>
+                <a:lnTo>
+                  <a:pt x="875255" y="806640"/>
+                </a:lnTo>
+                <a:close/>
+                <a:lnTo>
+                  <a:pt x="879384" y="798651"/>
+                </a:lnTo>
+                <a:close/>
+                <a:lnTo>
+                  <a:pt x="883512" y="790632"/>
+                </a:lnTo>
+                <a:close/>
+                <a:lnTo>
+                  <a:pt x="887641" y="782583"/>
+                </a:lnTo>
+                <a:close/>
+                <a:lnTo>
+                  <a:pt x="891769" y="774504"/>
+                </a:lnTo>
+                <a:close/>
+                <a:lnTo>
+                  <a:pt x="895898" y="766396"/>
+                </a:lnTo>
+                <a:close/>
+                <a:lnTo>
+                  <a:pt x="900026" y="758257"/>
+                </a:lnTo>
+                <a:close/>
+                <a:lnTo>
+                  <a:pt x="904155" y="750089"/>
+                </a:lnTo>
+                <a:close/>
+                <a:lnTo>
+                  <a:pt x="908284" y="741891"/>
+                </a:lnTo>
+                <a:close/>
+                <a:lnTo>
+                  <a:pt x="912412" y="733663"/>
+                </a:lnTo>
+                <a:close/>
+                <a:lnTo>
+                  <a:pt x="916541" y="725406"/>
+                </a:lnTo>
+                <a:close/>
+                <a:lnTo>
+                  <a:pt x="920669" y="717118"/>
+                </a:lnTo>
+                <a:close/>
+                <a:lnTo>
+                  <a:pt x="924798" y="708801"/>
+                </a:lnTo>
+                <a:close/>
+                <a:lnTo>
+                  <a:pt x="928926" y="700454"/>
+                </a:lnTo>
+                <a:close/>
+                <a:lnTo>
+                  <a:pt x="933055" y="692077"/>
+                </a:lnTo>
+                <a:close/>
+                <a:lnTo>
+                  <a:pt x="937184" y="683670"/>
+                </a:lnTo>
+                <a:close/>
+                <a:lnTo>
+                  <a:pt x="941312" y="675233"/>
+                </a:lnTo>
+                <a:close/>
+                <a:lnTo>
+                  <a:pt x="945441" y="666767"/>
+                </a:lnTo>
+                <a:close/>
+                <a:lnTo>
+                  <a:pt x="949569" y="658270"/>
+                </a:lnTo>
+                <a:close/>
+                <a:lnTo>
+                  <a:pt x="953698" y="649744"/>
+                </a:lnTo>
+                <a:close/>
+                <a:lnTo>
+                  <a:pt x="957826" y="641188"/>
+                </a:lnTo>
+                <a:close/>
+                <a:lnTo>
+                  <a:pt x="961955" y="632603"/>
+                </a:lnTo>
+                <a:close/>
+                <a:lnTo>
+                  <a:pt x="966083" y="623987"/>
+                </a:lnTo>
+                <a:close/>
+                <a:lnTo>
+                  <a:pt x="970212" y="615342"/>
+                </a:lnTo>
+                <a:close/>
+                <a:lnTo>
+                  <a:pt x="974341" y="606666"/>
+                </a:lnTo>
+                <a:close/>
+                <a:lnTo>
+                  <a:pt x="978469" y="597961"/>
+                </a:lnTo>
+                <a:close/>
+                <a:lnTo>
+                  <a:pt x="982598" y="589226"/>
+                </a:lnTo>
+                <a:close/>
+                <a:lnTo>
+                  <a:pt x="986726" y="580462"/>
+                </a:lnTo>
+                <a:close/>
+                <a:lnTo>
+                  <a:pt x="990855" y="571667"/>
+                </a:lnTo>
+                <a:close/>
+                <a:lnTo>
+                  <a:pt x="994983" y="562843"/>
+                </a:lnTo>
+                <a:close/>
+                <a:lnTo>
+                  <a:pt x="999112" y="553989"/>
+                </a:lnTo>
+                <a:close/>
+                <a:lnTo>
+                  <a:pt x="1003241" y="545105"/>
+                </a:lnTo>
+                <a:close/>
+                <a:lnTo>
+                  <a:pt x="1007369" y="536191"/>
+                </a:lnTo>
+                <a:close/>
+                <a:lnTo>
+                  <a:pt x="1011498" y="527247"/>
+                </a:lnTo>
+                <a:close/>
+                <a:lnTo>
+                  <a:pt x="1015626" y="518274"/>
+                </a:lnTo>
+                <a:close/>
+                <a:lnTo>
+                  <a:pt x="1019755" y="509270"/>
+                </a:lnTo>
+                <a:close/>
+                <a:lnTo>
+                  <a:pt x="1023883" y="500237"/>
+                </a:lnTo>
+                <a:close/>
+                <a:lnTo>
+                  <a:pt x="1028012" y="491174"/>
+                </a:lnTo>
+                <a:close/>
+                <a:lnTo>
+                  <a:pt x="1032140" y="482082"/>
+                </a:lnTo>
+                <a:close/>
+                <a:lnTo>
+                  <a:pt x="1036269" y="472959"/>
+                </a:lnTo>
+                <a:close/>
+                <a:lnTo>
+                  <a:pt x="1040398" y="463807"/>
+                </a:lnTo>
+                <a:close/>
+                <a:lnTo>
+                  <a:pt x="1044526" y="454624"/>
+                </a:lnTo>
+                <a:close/>
+                <a:lnTo>
+                  <a:pt x="1048655" y="445412"/>
+                </a:lnTo>
+                <a:close/>
+                <a:lnTo>
+                  <a:pt x="1052783" y="436170"/>
+                </a:lnTo>
+                <a:close/>
+                <a:lnTo>
+                  <a:pt x="1056912" y="426899"/>
+                </a:lnTo>
+                <a:close/>
+                <a:lnTo>
+                  <a:pt x="1061040" y="417597"/>
+                </a:lnTo>
+                <a:close/>
+                <a:lnTo>
+                  <a:pt x="1065169" y="408266"/>
+                </a:lnTo>
+                <a:close/>
+                <a:lnTo>
+                  <a:pt x="1069298" y="398904"/>
+                </a:lnTo>
+                <a:close/>
+                <a:lnTo>
+                  <a:pt x="1073426" y="389513"/>
+                </a:lnTo>
+                <a:close/>
+                <a:lnTo>
+                  <a:pt x="1077555" y="380093"/>
+                </a:lnTo>
+                <a:close/>
+                <a:lnTo>
+                  <a:pt x="1081683" y="370642"/>
+                </a:lnTo>
+                <a:close/>
+                <a:lnTo>
+                  <a:pt x="1085812" y="361161"/>
+                </a:lnTo>
+                <a:close/>
+                <a:lnTo>
+                  <a:pt x="1089940" y="351651"/>
+                </a:lnTo>
+                <a:close/>
+                <a:lnTo>
+                  <a:pt x="1094069" y="342111"/>
+                </a:lnTo>
+                <a:close/>
+                <a:lnTo>
+                  <a:pt x="1098197" y="332541"/>
+                </a:lnTo>
+                <a:close/>
+                <a:lnTo>
+                  <a:pt x="1102326" y="322941"/>
+                </a:lnTo>
+                <a:close/>
+                <a:lnTo>
+                  <a:pt x="1106455" y="313312"/>
+                </a:lnTo>
+                <a:close/>
+                <a:lnTo>
+                  <a:pt x="1110583" y="303652"/>
+                </a:lnTo>
+                <a:close/>
+                <a:lnTo>
+                  <a:pt x="1114712" y="293963"/>
+                </a:lnTo>
+                <a:close/>
+                <a:lnTo>
+                  <a:pt x="1118840" y="284244"/>
+                </a:lnTo>
+                <a:close/>
+                <a:lnTo>
+                  <a:pt x="1122969" y="274495"/>
+                </a:lnTo>
+                <a:close/>
+                <a:lnTo>
+                  <a:pt x="1127097" y="264716"/>
+                </a:lnTo>
+                <a:close/>
+                <a:lnTo>
+                  <a:pt x="1131226" y="254907"/>
+                </a:lnTo>
+                <a:close/>
+                <a:lnTo>
+                  <a:pt x="1135355" y="245069"/>
+                </a:lnTo>
+                <a:close/>
+                <a:lnTo>
+                  <a:pt x="1139483" y="235201"/>
+                </a:lnTo>
+                <a:close/>
+                <a:lnTo>
+                  <a:pt x="1143612" y="225303"/>
+                </a:lnTo>
+                <a:close/>
+                <a:lnTo>
+                  <a:pt x="1147740" y="215375"/>
+                </a:lnTo>
+                <a:close/>
+                <a:lnTo>
+                  <a:pt x="1151869" y="205417"/>
+                </a:lnTo>
+                <a:close/>
+                <a:lnTo>
+                  <a:pt x="1155997" y="195430"/>
+                </a:lnTo>
+                <a:close/>
+                <a:lnTo>
+                  <a:pt x="1160126" y="185412"/>
+                </a:lnTo>
+                <a:close/>
+                <a:lnTo>
+                  <a:pt x="1164254" y="175365"/>
+                </a:lnTo>
+                <a:close/>
+                <a:lnTo>
+                  <a:pt x="1168383" y="165288"/>
+                </a:lnTo>
+                <a:close/>
+                <a:lnTo>
+                  <a:pt x="1172512" y="155181"/>
+                </a:lnTo>
+                <a:close/>
+                <a:lnTo>
+                  <a:pt x="1176640" y="145045"/>
+                </a:lnTo>
+                <a:close/>
+                <a:lnTo>
+                  <a:pt x="1180769" y="134878"/>
+                </a:lnTo>
+                <a:close/>
+                <a:lnTo>
+                  <a:pt x="1184897" y="124682"/>
+                </a:lnTo>
+                <a:close/>
+                <a:lnTo>
+                  <a:pt x="1189026" y="114456"/>
+                </a:lnTo>
+                <a:close/>
+                <a:lnTo>
+                  <a:pt x="1193154" y="104200"/>
+                </a:lnTo>
+                <a:close/>
+                <a:lnTo>
+                  <a:pt x="1197283" y="93914"/>
+                </a:lnTo>
+                <a:close/>
+                <a:lnTo>
+                  <a:pt x="1201412" y="83598"/>
+                </a:lnTo>
+                <a:close/>
+                <a:lnTo>
+                  <a:pt x="1205540" y="73253"/>
+                </a:lnTo>
+                <a:close/>
+                <a:lnTo>
+                  <a:pt x="1209669" y="62878"/>
+                </a:lnTo>
+                <a:close/>
+                <a:lnTo>
+                  <a:pt x="1213797" y="52473"/>
+                </a:lnTo>
+                <a:close/>
+                <a:lnTo>
+                  <a:pt x="1217926" y="42038"/>
+                </a:lnTo>
+                <a:close/>
+                <a:lnTo>
+                  <a:pt x="1222054" y="31573"/>
+                </a:lnTo>
+                <a:close/>
+                <a:lnTo>
+                  <a:pt x="1226183" y="21078"/>
+                </a:lnTo>
+                <a:close/>
+                <a:lnTo>
+                  <a:pt x="1230311" y="10554"/>
+                </a:lnTo>
+                <a:close/>
+                <a:lnTo>
+                  <a:pt x="1234440" y="0"/>
                 </a:lnTo>
                 <a:close/>
               </a:path>
             </a:pathLst>
           </a:custGeom>
-          <a:ln w="31750">
+          <a:ln w="38100">
             <a:solidFill>
-              <a:srgbClr val="FFFFFF"/>
+              <a:srgbClr val="000000"/>
             </a:solidFill>
           </a:ln>
         </p:spPr>
@@ -4423,8 +4423,8 @@
         </p:nvCxnSpPr>
         <p:spPr>
           <a:xfrm flipV="1">
-            <a:off x="6400800.0" y="514350.0"/>
-            <a:ext cx="0.0" cy="2057400.0"/>
+            <a:off x="5577840.0" y="1229410.8"/>
+            <a:ext cx="0.0" cy="1342339.2"/>
           </a:xfrm>
           <a:prstGeom prst="line">
             <a:avLst/>
@@ -4459,8 +4459,8 @@
         </p:nvCxnSpPr>
         <p:spPr>
           <a:xfrm>
-            <a:off x="4572000.0" y="514350.0"/>
-            <a:ext cx="1828800.0" cy="0.0"/>
+            <a:off x="4572000.0" y="1229410.8"/>
+            <a:ext cx="1005840.0" cy="0.0"/>
           </a:xfrm>
           <a:prstGeom prst="line">
             <a:avLst/>
@@ -4495,8 +4495,8 @@
         </p:nvSpPr>
         <p:spPr>
           <a:xfrm>
-            <a:off x="6350000" y="463550"/>
-            <a:ext cx="101600" cy="101600"/>
+            <a:off x="5501640" y="1153210"/>
+            <a:ext cx="152400" cy="152400"/>
           </a:xfrm>
           <a:prstGeom prst="ellipse">
             <a:avLst/>
@@ -4532,23 +4532,921 @@
           </a:p>
         </p:txBody>
       </p:sp>
+      <p:sp>
+        <p:nvSpPr>
+          <p:cNvPr id="8" name="Freeform 7"/>
+          <p:cNvSpPr/>
+          <p:nvPr/>
+        </p:nvSpPr>
+        <p:spPr>
+          <a:xfrm>
+            <a:off x="5349240" y="1308049"/>
+            <a:ext cx="182880" cy="277978"/>
+          </a:xfrm>
+          <a:custGeom>
+            <a:avLst/>
+            <a:gdLst/>
+            <a:ahLst/>
+            <a:cxnLst/>
+            <a:rect l="l" t="t" r="r" b="b"/>
+            <a:pathLst>
+              <a:path w="182880" h="277978">
+                <a:moveTo>
+                  <a:pt x="0" y="277978"/>
+                </a:moveTo>
+                <a:lnTo>
+                  <a:pt x="1847" y="275463"/>
+                </a:lnTo>
+                <a:close/>
+                <a:lnTo>
+                  <a:pt x="3695" y="272941"/>
+                </a:lnTo>
+                <a:close/>
+                <a:lnTo>
+                  <a:pt x="5542" y="270414"/>
+                </a:lnTo>
+                <a:close/>
+                <a:lnTo>
+                  <a:pt x="7389" y="267881"/>
+                </a:lnTo>
+                <a:close/>
+                <a:lnTo>
+                  <a:pt x="9236" y="265342"/>
+                </a:lnTo>
+                <a:close/>
+                <a:lnTo>
+                  <a:pt x="11084" y="262797"/>
+                </a:lnTo>
+                <a:close/>
+                <a:lnTo>
+                  <a:pt x="12931" y="260245"/>
+                </a:lnTo>
+                <a:close/>
+                <a:lnTo>
+                  <a:pt x="14778" y="257688"/>
+                </a:lnTo>
+                <a:close/>
+                <a:lnTo>
+                  <a:pt x="16625" y="255125"/>
+                </a:lnTo>
+                <a:close/>
+                <a:lnTo>
+                  <a:pt x="18473" y="252556"/>
+                </a:lnTo>
+                <a:close/>
+                <a:lnTo>
+                  <a:pt x="20320" y="249981"/>
+                </a:lnTo>
+                <a:close/>
+                <a:lnTo>
+                  <a:pt x="22167" y="247400"/>
+                </a:lnTo>
+                <a:close/>
+                <a:lnTo>
+                  <a:pt x="24015" y="244813"/>
+                </a:lnTo>
+                <a:close/>
+                <a:lnTo>
+                  <a:pt x="25862" y="242221"/>
+                </a:lnTo>
+                <a:close/>
+                <a:lnTo>
+                  <a:pt x="27709" y="239622"/>
+                </a:lnTo>
+                <a:close/>
+                <a:lnTo>
+                  <a:pt x="29556" y="237017"/>
+                </a:lnTo>
+                <a:close/>
+                <a:lnTo>
+                  <a:pt x="31404" y="234406"/>
+                </a:lnTo>
+                <a:close/>
+                <a:lnTo>
+                  <a:pt x="33251" y="231789"/>
+                </a:lnTo>
+                <a:close/>
+                <a:lnTo>
+                  <a:pt x="35098" y="229167"/>
+                </a:lnTo>
+                <a:close/>
+                <a:lnTo>
+                  <a:pt x="36945" y="226538"/>
+                </a:lnTo>
+                <a:close/>
+                <a:lnTo>
+                  <a:pt x="38793" y="223903"/>
+                </a:lnTo>
+                <a:close/>
+                <a:lnTo>
+                  <a:pt x="40640" y="221262"/>
+                </a:lnTo>
+                <a:close/>
+                <a:lnTo>
+                  <a:pt x="42487" y="218616"/>
+                </a:lnTo>
+                <a:close/>
+                <a:lnTo>
+                  <a:pt x="44335" y="215963"/>
+                </a:lnTo>
+                <a:close/>
+                <a:lnTo>
+                  <a:pt x="46182" y="213305"/>
+                </a:lnTo>
+                <a:close/>
+                <a:lnTo>
+                  <a:pt x="48029" y="210640"/>
+                </a:lnTo>
+                <a:close/>
+                <a:lnTo>
+                  <a:pt x="49876" y="207970"/>
+                </a:lnTo>
+                <a:close/>
+                <a:lnTo>
+                  <a:pt x="51724" y="205293"/>
+                </a:lnTo>
+                <a:close/>
+                <a:lnTo>
+                  <a:pt x="53571" y="202611"/>
+                </a:lnTo>
+                <a:close/>
+                <a:lnTo>
+                  <a:pt x="55418" y="199922"/>
+                </a:lnTo>
+                <a:close/>
+                <a:lnTo>
+                  <a:pt x="57265" y="197228"/>
+                </a:lnTo>
+                <a:close/>
+                <a:lnTo>
+                  <a:pt x="59113" y="194527"/>
+                </a:lnTo>
+                <a:close/>
+                <a:lnTo>
+                  <a:pt x="60960" y="191821"/>
+                </a:lnTo>
+                <a:close/>
+                <a:lnTo>
+                  <a:pt x="62807" y="189109"/>
+                </a:lnTo>
+                <a:close/>
+                <a:lnTo>
+                  <a:pt x="64655" y="186390"/>
+                </a:lnTo>
+                <a:close/>
+                <a:lnTo>
+                  <a:pt x="66502" y="183666"/>
+                </a:lnTo>
+                <a:close/>
+                <a:lnTo>
+                  <a:pt x="68349" y="180936"/>
+                </a:lnTo>
+                <a:close/>
+                <a:lnTo>
+                  <a:pt x="70196" y="178200"/>
+                </a:lnTo>
+                <a:close/>
+                <a:lnTo>
+                  <a:pt x="72044" y="175458"/>
+                </a:lnTo>
+                <a:close/>
+                <a:lnTo>
+                  <a:pt x="73891" y="172709"/>
+                </a:lnTo>
+                <a:close/>
+                <a:lnTo>
+                  <a:pt x="75738" y="169955"/>
+                </a:lnTo>
+                <a:close/>
+                <a:lnTo>
+                  <a:pt x="77585" y="167195"/>
+                </a:lnTo>
+                <a:close/>
+                <a:lnTo>
+                  <a:pt x="79433" y="164429"/>
+                </a:lnTo>
+                <a:close/>
+                <a:lnTo>
+                  <a:pt x="81280" y="161657"/>
+                </a:lnTo>
+                <a:close/>
+                <a:lnTo>
+                  <a:pt x="83127" y="158879"/>
+                </a:lnTo>
+                <a:close/>
+                <a:lnTo>
+                  <a:pt x="84975" y="156095"/>
+                </a:lnTo>
+                <a:close/>
+                <a:lnTo>
+                  <a:pt x="86822" y="153305"/>
+                </a:lnTo>
+                <a:close/>
+                <a:lnTo>
+                  <a:pt x="88669" y="150509"/>
+                </a:lnTo>
+                <a:close/>
+                <a:lnTo>
+                  <a:pt x="90516" y="147707"/>
+                </a:lnTo>
+                <a:close/>
+                <a:lnTo>
+                  <a:pt x="92364" y="144900"/>
+                </a:lnTo>
+                <a:close/>
+                <a:lnTo>
+                  <a:pt x="94211" y="142086"/>
+                </a:lnTo>
+                <a:close/>
+                <a:lnTo>
+                  <a:pt x="96058" y="139266"/>
+                </a:lnTo>
+                <a:close/>
+                <a:lnTo>
+                  <a:pt x="97905" y="136440"/>
+                </a:lnTo>
+                <a:close/>
+                <a:lnTo>
+                  <a:pt x="99753" y="133608"/>
+                </a:lnTo>
+                <a:close/>
+                <a:lnTo>
+                  <a:pt x="101600" y="130771"/>
+                </a:lnTo>
+                <a:close/>
+                <a:lnTo>
+                  <a:pt x="103447" y="127927"/>
+                </a:lnTo>
+                <a:close/>
+                <a:lnTo>
+                  <a:pt x="105295" y="125077"/>
+                </a:lnTo>
+                <a:close/>
+                <a:lnTo>
+                  <a:pt x="107142" y="122222"/>
+                </a:lnTo>
+                <a:close/>
+                <a:lnTo>
+                  <a:pt x="108989" y="119360"/>
+                </a:lnTo>
+                <a:close/>
+                <a:lnTo>
+                  <a:pt x="110836" y="116493"/>
+                </a:lnTo>
+                <a:close/>
+                <a:lnTo>
+                  <a:pt x="112684" y="113619"/>
+                </a:lnTo>
+                <a:close/>
+                <a:lnTo>
+                  <a:pt x="114531" y="110740"/>
+                </a:lnTo>
+                <a:close/>
+                <a:lnTo>
+                  <a:pt x="116378" y="107854"/>
+                </a:lnTo>
+                <a:close/>
+                <a:lnTo>
+                  <a:pt x="118225" y="104963"/>
+                </a:lnTo>
+                <a:close/>
+                <a:lnTo>
+                  <a:pt x="120073" y="102065"/>
+                </a:lnTo>
+                <a:close/>
+                <a:lnTo>
+                  <a:pt x="121920" y="99162"/>
+                </a:lnTo>
+                <a:close/>
+                <a:lnTo>
+                  <a:pt x="123767" y="96252"/>
+                </a:lnTo>
+                <a:close/>
+                <a:lnTo>
+                  <a:pt x="125615" y="93337"/>
+                </a:lnTo>
+                <a:close/>
+                <a:lnTo>
+                  <a:pt x="127462" y="90416"/>
+                </a:lnTo>
+                <a:close/>
+                <a:lnTo>
+                  <a:pt x="129309" y="87489"/>
+                </a:lnTo>
+                <a:close/>
+                <a:lnTo>
+                  <a:pt x="131156" y="84555"/>
+                </a:lnTo>
+                <a:close/>
+                <a:lnTo>
+                  <a:pt x="133004" y="81616"/>
+                </a:lnTo>
+                <a:close/>
+                <a:lnTo>
+                  <a:pt x="134851" y="78671"/>
+                </a:lnTo>
+                <a:close/>
+                <a:lnTo>
+                  <a:pt x="136698" y="75720"/>
+                </a:lnTo>
+                <a:close/>
+                <a:lnTo>
+                  <a:pt x="138545" y="72763"/>
+                </a:lnTo>
+                <a:close/>
+                <a:lnTo>
+                  <a:pt x="140393" y="69799"/>
+                </a:lnTo>
+                <a:close/>
+                <a:lnTo>
+                  <a:pt x="142240" y="66830"/>
+                </a:lnTo>
+                <a:close/>
+                <a:lnTo>
+                  <a:pt x="144087" y="63855"/>
+                </a:lnTo>
+                <a:close/>
+                <a:lnTo>
+                  <a:pt x="145935" y="60874"/>
+                </a:lnTo>
+                <a:close/>
+                <a:lnTo>
+                  <a:pt x="147782" y="57887"/>
+                </a:lnTo>
+                <a:close/>
+                <a:lnTo>
+                  <a:pt x="149629" y="54894"/>
+                </a:lnTo>
+                <a:close/>
+                <a:lnTo>
+                  <a:pt x="151476" y="51896"/>
+                </a:lnTo>
+                <a:close/>
+                <a:lnTo>
+                  <a:pt x="153324" y="48891"/>
+                </a:lnTo>
+                <a:close/>
+                <a:lnTo>
+                  <a:pt x="155171" y="45880"/>
+                </a:lnTo>
+                <a:close/>
+                <a:lnTo>
+                  <a:pt x="157018" y="42863"/>
+                </a:lnTo>
+                <a:close/>
+                <a:lnTo>
+                  <a:pt x="158865" y="39840"/>
+                </a:lnTo>
+                <a:close/>
+                <a:lnTo>
+                  <a:pt x="160713" y="36811"/>
+                </a:lnTo>
+                <a:close/>
+                <a:lnTo>
+                  <a:pt x="162560" y="33777"/>
+                </a:lnTo>
+                <a:close/>
+                <a:lnTo>
+                  <a:pt x="164407" y="30736"/>
+                </a:lnTo>
+                <a:close/>
+                <a:lnTo>
+                  <a:pt x="166255" y="27689"/>
+                </a:lnTo>
+                <a:close/>
+                <a:lnTo>
+                  <a:pt x="168102" y="24636"/>
+                </a:lnTo>
+                <a:close/>
+                <a:lnTo>
+                  <a:pt x="169949" y="21578"/>
+                </a:lnTo>
+                <a:close/>
+                <a:lnTo>
+                  <a:pt x="171796" y="18513"/>
+                </a:lnTo>
+                <a:close/>
+                <a:lnTo>
+                  <a:pt x="173644" y="15443"/>
+                </a:lnTo>
+                <a:close/>
+                <a:lnTo>
+                  <a:pt x="175491" y="12366"/>
+                </a:lnTo>
+                <a:close/>
+                <a:lnTo>
+                  <a:pt x="177338" y="9284"/>
+                </a:lnTo>
+                <a:close/>
+                <a:lnTo>
+                  <a:pt x="179185" y="6195"/>
+                </a:lnTo>
+                <a:close/>
+                <a:lnTo>
+                  <a:pt x="181033" y="3101"/>
+                </a:lnTo>
+                <a:close/>
+                <a:lnTo>
+                  <a:pt x="182880" y="0"/>
+                </a:lnTo>
+                <a:close/>
+              </a:path>
+            </a:pathLst>
+          </a:custGeom>
+          <a:ln w="19050">
+            <a:solidFill>
+              <a:srgbClr val="FFFFFF"/>
+            </a:solidFill>
+          </a:ln>
+        </p:spPr>
+        <p:style>
+          <a:lnRef idx="1">
+            <a:schemeClr val="accent1"/>
+          </a:lnRef>
+          <a:fillRef idx="3">
+            <a:schemeClr val="accent1"/>
+          </a:fillRef>
+          <a:effectRef idx="2">
+            <a:schemeClr val="accent1"/>
+          </a:effectRef>
+          <a:fontRef idx="minor">
+            <a:schemeClr val="lt1"/>
+          </a:fontRef>
+        </p:style>
+        <p:txBody>
+          <a:bodyPr rtlCol="0" anchor="ctr"/>
+          <a:lstStyle/>
+          <a:p>
+            <a:pPr algn="ctr"/>
+          </a:p>
+        </p:txBody>
+      </p:sp>
+      <p:sp>
+        <p:nvSpPr>
+          <p:cNvPr id="9" name="Freeform 8"/>
+          <p:cNvSpPr/>
+          <p:nvPr/>
+        </p:nvSpPr>
+        <p:spPr>
+          <a:xfrm>
+            <a:off x="5623560" y="680771"/>
+            <a:ext cx="228600" cy="466344"/>
+          </a:xfrm>
+          <a:custGeom>
+            <a:avLst/>
+            <a:gdLst/>
+            <a:ahLst/>
+            <a:cxnLst/>
+            <a:rect l="l" t="t" r="r" b="b"/>
+            <a:pathLst>
+              <a:path w="228600" h="466344">
+                <a:moveTo>
+                  <a:pt x="228600" y="0"/>
+                </a:moveTo>
+                <a:lnTo>
+                  <a:pt x="226291" y="5167"/>
+                </a:lnTo>
+                <a:close/>
+                <a:lnTo>
+                  <a:pt x="223982" y="10326"/>
+                </a:lnTo>
+                <a:close/>
+                <a:lnTo>
+                  <a:pt x="221673" y="15475"/>
+                </a:lnTo>
+                <a:close/>
+                <a:lnTo>
+                  <a:pt x="219364" y="20615"/>
+                </a:lnTo>
+                <a:close/>
+                <a:lnTo>
+                  <a:pt x="217055" y="25745"/>
+                </a:lnTo>
+                <a:close/>
+                <a:lnTo>
+                  <a:pt x="214745" y="30866"/>
+                </a:lnTo>
+                <a:close/>
+                <a:lnTo>
+                  <a:pt x="212436" y="35978"/>
+                </a:lnTo>
+                <a:close/>
+                <a:lnTo>
+                  <a:pt x="210127" y="41080"/>
+                </a:lnTo>
+                <a:close/>
+                <a:lnTo>
+                  <a:pt x="207818" y="46173"/>
+                </a:lnTo>
+                <a:close/>
+                <a:lnTo>
+                  <a:pt x="205509" y="51257"/>
+                </a:lnTo>
+                <a:close/>
+                <a:lnTo>
+                  <a:pt x="203200" y="56331"/>
+                </a:lnTo>
+                <a:close/>
+                <a:lnTo>
+                  <a:pt x="200891" y="61396"/>
+                </a:lnTo>
+                <a:close/>
+                <a:lnTo>
+                  <a:pt x="198582" y="66452"/>
+                </a:lnTo>
+                <a:close/>
+                <a:lnTo>
+                  <a:pt x="196273" y="71499"/>
+                </a:lnTo>
+                <a:close/>
+                <a:lnTo>
+                  <a:pt x="193964" y="76536"/>
+                </a:lnTo>
+                <a:close/>
+                <a:lnTo>
+                  <a:pt x="191655" y="81563"/>
+                </a:lnTo>
+                <a:close/>
+                <a:lnTo>
+                  <a:pt x="189345" y="86582"/>
+                </a:lnTo>
+                <a:close/>
+                <a:lnTo>
+                  <a:pt x="187036" y="91591"/>
+                </a:lnTo>
+                <a:close/>
+                <a:lnTo>
+                  <a:pt x="184727" y="96591"/>
+                </a:lnTo>
+                <a:close/>
+                <a:lnTo>
+                  <a:pt x="182418" y="101581"/>
+                </a:lnTo>
+                <a:close/>
+                <a:lnTo>
+                  <a:pt x="180109" y="106562"/>
+                </a:lnTo>
+                <a:close/>
+                <a:lnTo>
+                  <a:pt x="177800" y="111534"/>
+                </a:lnTo>
+                <a:close/>
+                <a:lnTo>
+                  <a:pt x="175491" y="116496"/>
+                </a:lnTo>
+                <a:close/>
+                <a:lnTo>
+                  <a:pt x="173182" y="121450"/>
+                </a:lnTo>
+                <a:close/>
+                <a:lnTo>
+                  <a:pt x="170873" y="126393"/>
+                </a:lnTo>
+                <a:close/>
+                <a:lnTo>
+                  <a:pt x="168564" y="131328"/>
+                </a:lnTo>
+                <a:close/>
+                <a:lnTo>
+                  <a:pt x="166255" y="136253"/>
+                </a:lnTo>
+                <a:close/>
+                <a:lnTo>
+                  <a:pt x="163945" y="141169"/>
+                </a:lnTo>
+                <a:close/>
+                <a:lnTo>
+                  <a:pt x="161636" y="146075"/>
+                </a:lnTo>
+                <a:close/>
+                <a:lnTo>
+                  <a:pt x="159327" y="150972"/>
+                </a:lnTo>
+                <a:close/>
+                <a:lnTo>
+                  <a:pt x="157018" y="155860"/>
+                </a:lnTo>
+                <a:close/>
+                <a:lnTo>
+                  <a:pt x="154709" y="160739"/>
+                </a:lnTo>
+                <a:close/>
+                <a:lnTo>
+                  <a:pt x="152400" y="165608"/>
+                </a:lnTo>
+                <a:close/>
+                <a:lnTo>
+                  <a:pt x="150091" y="170468"/>
+                </a:lnTo>
+                <a:close/>
+                <a:lnTo>
+                  <a:pt x="147782" y="175318"/>
+                </a:lnTo>
+                <a:close/>
+                <a:lnTo>
+                  <a:pt x="145473" y="180159"/>
+                </a:lnTo>
+                <a:close/>
+                <a:lnTo>
+                  <a:pt x="143164" y="184991"/>
+                </a:lnTo>
+                <a:close/>
+                <a:lnTo>
+                  <a:pt x="140855" y="189814"/>
+                </a:lnTo>
+                <a:close/>
+                <a:lnTo>
+                  <a:pt x="138545" y="194627"/>
+                </a:lnTo>
+                <a:close/>
+                <a:lnTo>
+                  <a:pt x="136236" y="199431"/>
+                </a:lnTo>
+                <a:close/>
+                <a:lnTo>
+                  <a:pt x="133927" y="204225"/>
+                </a:lnTo>
+                <a:close/>
+                <a:lnTo>
+                  <a:pt x="131618" y="209010"/>
+                </a:lnTo>
+                <a:close/>
+                <a:lnTo>
+                  <a:pt x="129309" y="213786"/>
+                </a:lnTo>
+                <a:close/>
+                <a:lnTo>
+                  <a:pt x="127000" y="218553"/>
+                </a:lnTo>
+                <a:close/>
+                <a:lnTo>
+                  <a:pt x="124691" y="223310"/>
+                </a:lnTo>
+                <a:close/>
+                <a:lnTo>
+                  <a:pt x="122382" y="228058"/>
+                </a:lnTo>
+                <a:close/>
+                <a:lnTo>
+                  <a:pt x="120073" y="232796"/>
+                </a:lnTo>
+                <a:close/>
+                <a:lnTo>
+                  <a:pt x="117764" y="237525"/>
+                </a:lnTo>
+                <a:close/>
+                <a:lnTo>
+                  <a:pt x="115455" y="242245"/>
+                </a:lnTo>
+                <a:close/>
+                <a:lnTo>
+                  <a:pt x="113145" y="246956"/>
+                </a:lnTo>
+                <a:close/>
+                <a:lnTo>
+                  <a:pt x="110836" y="251657"/>
+                </a:lnTo>
+                <a:close/>
+                <a:lnTo>
+                  <a:pt x="108527" y="256349"/>
+                </a:lnTo>
+                <a:close/>
+                <a:lnTo>
+                  <a:pt x="106218" y="261032"/>
+                </a:lnTo>
+                <a:close/>
+                <a:lnTo>
+                  <a:pt x="103909" y="265705"/>
+                </a:lnTo>
+                <a:close/>
+                <a:lnTo>
+                  <a:pt x="101600" y="270369"/>
+                </a:lnTo>
+                <a:close/>
+                <a:lnTo>
+                  <a:pt x="99291" y="275023"/>
+                </a:lnTo>
+                <a:close/>
+                <a:lnTo>
+                  <a:pt x="96982" y="279668"/>
+                </a:lnTo>
+                <a:close/>
+                <a:lnTo>
+                  <a:pt x="94673" y="284304"/>
+                </a:lnTo>
+                <a:close/>
+                <a:lnTo>
+                  <a:pt x="92364" y="288931"/>
+                </a:lnTo>
+                <a:close/>
+                <a:lnTo>
+                  <a:pt x="90055" y="293548"/>
+                </a:lnTo>
+                <a:close/>
+                <a:lnTo>
+                  <a:pt x="87745" y="298156"/>
+                </a:lnTo>
+                <a:close/>
+                <a:lnTo>
+                  <a:pt x="85436" y="302755"/>
+                </a:lnTo>
+                <a:close/>
+                <a:lnTo>
+                  <a:pt x="83127" y="307344"/>
+                </a:lnTo>
+                <a:close/>
+                <a:lnTo>
+                  <a:pt x="80818" y="311924"/>
+                </a:lnTo>
+                <a:close/>
+                <a:lnTo>
+                  <a:pt x="78509" y="316495"/>
+                </a:lnTo>
+                <a:close/>
+                <a:lnTo>
+                  <a:pt x="76200" y="321056"/>
+                </a:lnTo>
+                <a:close/>
+                <a:lnTo>
+                  <a:pt x="73891" y="325608"/>
+                </a:lnTo>
+                <a:close/>
+                <a:lnTo>
+                  <a:pt x="71582" y="330150"/>
+                </a:lnTo>
+                <a:close/>
+                <a:lnTo>
+                  <a:pt x="69273" y="334684"/>
+                </a:lnTo>
+                <a:close/>
+                <a:lnTo>
+                  <a:pt x="66964" y="339208"/>
+                </a:lnTo>
+                <a:close/>
+                <a:lnTo>
+                  <a:pt x="64655" y="343722"/>
+                </a:lnTo>
+                <a:close/>
+                <a:lnTo>
+                  <a:pt x="62345" y="348228"/>
+                </a:lnTo>
+                <a:close/>
+                <a:lnTo>
+                  <a:pt x="60036" y="352723"/>
+                </a:lnTo>
+                <a:close/>
+                <a:lnTo>
+                  <a:pt x="57727" y="357210"/>
+                </a:lnTo>
+                <a:close/>
+                <a:lnTo>
+                  <a:pt x="55418" y="361687"/>
+                </a:lnTo>
+                <a:close/>
+                <a:lnTo>
+                  <a:pt x="53109" y="366155"/>
+                </a:lnTo>
+                <a:close/>
+                <a:lnTo>
+                  <a:pt x="50800" y="370614"/>
+                </a:lnTo>
+                <a:close/>
+                <a:lnTo>
+                  <a:pt x="48491" y="375063"/>
+                </a:lnTo>
+                <a:close/>
+                <a:lnTo>
+                  <a:pt x="46182" y="379503"/>
+                </a:lnTo>
+                <a:close/>
+                <a:lnTo>
+                  <a:pt x="43873" y="383934"/>
+                </a:lnTo>
+                <a:close/>
+                <a:lnTo>
+                  <a:pt x="41564" y="388355"/>
+                </a:lnTo>
+                <a:close/>
+                <a:lnTo>
+                  <a:pt x="39255" y="392767"/>
+                </a:lnTo>
+                <a:close/>
+                <a:lnTo>
+                  <a:pt x="36945" y="397170"/>
+                </a:lnTo>
+                <a:close/>
+                <a:lnTo>
+                  <a:pt x="34636" y="401563"/>
+                </a:lnTo>
+                <a:close/>
+                <a:lnTo>
+                  <a:pt x="32327" y="405947"/>
+                </a:lnTo>
+                <a:close/>
+                <a:lnTo>
+                  <a:pt x="30018" y="410322"/>
+                </a:lnTo>
+                <a:close/>
+                <a:lnTo>
+                  <a:pt x="27709" y="414687"/>
+                </a:lnTo>
+                <a:close/>
+                <a:lnTo>
+                  <a:pt x="25400" y="419043"/>
+                </a:lnTo>
+                <a:close/>
+                <a:lnTo>
+                  <a:pt x="23091" y="423390"/>
+                </a:lnTo>
+                <a:close/>
+                <a:lnTo>
+                  <a:pt x="20782" y="427727"/>
+                </a:lnTo>
+                <a:close/>
+                <a:lnTo>
+                  <a:pt x="18473" y="432055"/>
+                </a:lnTo>
+                <a:close/>
+                <a:lnTo>
+                  <a:pt x="16164" y="436374"/>
+                </a:lnTo>
+                <a:close/>
+                <a:lnTo>
+                  <a:pt x="13855" y="440684"/>
+                </a:lnTo>
+                <a:close/>
+                <a:lnTo>
+                  <a:pt x="11545" y="444984"/>
+                </a:lnTo>
+                <a:close/>
+                <a:lnTo>
+                  <a:pt x="9236" y="449274"/>
+                </a:lnTo>
+                <a:close/>
+                <a:lnTo>
+                  <a:pt x="6927" y="453556"/>
+                </a:lnTo>
+                <a:close/>
+                <a:lnTo>
+                  <a:pt x="4618" y="457828"/>
+                </a:lnTo>
+                <a:close/>
+                <a:lnTo>
+                  <a:pt x="2309" y="462090"/>
+                </a:lnTo>
+                <a:close/>
+                <a:lnTo>
+                  <a:pt x="0" y="466344"/>
+                </a:lnTo>
+                <a:close/>
+              </a:path>
+            </a:pathLst>
+          </a:custGeom>
+          <a:ln w="19050">
+            <a:solidFill>
+              <a:srgbClr val="FFFFFF"/>
+            </a:solidFill>
+          </a:ln>
+        </p:spPr>
+        <p:style>
+          <a:lnRef idx="1">
+            <a:schemeClr val="accent1"/>
+          </a:lnRef>
+          <a:fillRef idx="3">
+            <a:schemeClr val="accent1"/>
+          </a:fillRef>
+          <a:effectRef idx="2">
+            <a:schemeClr val="accent1"/>
+          </a:effectRef>
+          <a:fontRef idx="minor">
+            <a:schemeClr val="lt1"/>
+          </a:fontRef>
+        </p:style>
+        <p:txBody>
+          <a:bodyPr rtlCol="0" anchor="ctr"/>
+          <a:lstStyle/>
+          <a:p>
+            <a:pPr algn="ctr"/>
+          </a:p>
+        </p:txBody>
+      </p:sp>
       <p:cxnSp>
         <p:nvCxnSpPr>
-          <p:cNvPr id="8" name="Connector 7"/>
+          <p:cNvPr id="10" name="Connector 9"/>
           <p:cNvCxnSpPr/>
           <p:nvPr/>
         </p:nvCxnSpPr>
         <p:spPr>
           <a:xfrm>
-            <a:off x="5715000.0" y="2571750.0"/>
-            <a:ext cx="594360.0" cy="0.0"/>
+            <a:off x="5120640.0" y="2434590.0"/>
+            <a:ext cx="365760.0" cy="0.0"/>
           </a:xfrm>
           <a:prstGeom prst="line">
             <a:avLst/>
           </a:prstGeom>
           <a:ln w="15240">
             <a:solidFill>
-              <a:srgbClr val="B4B4B4"/>
+              <a:srgbClr val="FFFFFF"/>
             </a:solidFill>
           </a:ln>
         </p:spPr>
@@ -4569,21 +5467,21 @@
       </p:cxnSp>
       <p:cxnSp>
         <p:nvCxnSpPr>
-          <p:cNvPr id="9" name="Connector 8"/>
+          <p:cNvPr id="11" name="Connector 10"/>
           <p:cNvCxnSpPr/>
           <p:nvPr/>
         </p:nvCxnSpPr>
         <p:spPr>
           <a:xfrm flipH="1">
-            <a:off x="6492240.0" y="2571750.0"/>
-            <a:ext cx="594360.0" cy="0.0"/>
+            <a:off x="5669280.0" y="2434590.0"/>
+            <a:ext cx="365760.0" cy="0.0"/>
           </a:xfrm>
           <a:prstGeom prst="line">
             <a:avLst/>
           </a:prstGeom>
           <a:ln w="15240">
             <a:solidFill>
-              <a:srgbClr val="B4B4B4"/>
+              <a:srgbClr val="FFFFFF"/>
             </a:solidFill>
           </a:ln>
         </p:spPr>
@@ -4604,911 +5502,13 @@
       </p:cxnSp>
       <p:sp>
         <p:nvSpPr>
-          <p:cNvPr id="10" name="Freeform 9"/>
-          <p:cNvSpPr/>
-          <p:nvPr/>
-        </p:nvSpPr>
-        <p:spPr>
-          <a:xfrm>
-            <a:off x="5715000" y="-966978"/>
-            <a:ext cx="640080" cy="2295144"/>
-          </a:xfrm>
-          <a:custGeom>
-            <a:avLst/>
-            <a:gdLst/>
-            <a:ahLst/>
-            <a:cxnLst/>
-            <a:rect l="l" t="t" r="r" b="b"/>
-            <a:pathLst>
-              <a:path w="640080" h="2295144">
-                <a:moveTo>
-                  <a:pt x="0" y="2295144"/>
-                </a:moveTo>
-                <a:lnTo>
-                  <a:pt x="6465" y="2280460"/>
-                </a:lnTo>
-                <a:close/>
-                <a:lnTo>
-                  <a:pt x="12931" y="2266230"/>
-                </a:lnTo>
-                <a:close/>
-                <a:lnTo>
-                  <a:pt x="19396" y="2252276"/>
-                </a:lnTo>
-                <a:close/>
-                <a:lnTo>
-                  <a:pt x="25862" y="2238419"/>
-                </a:lnTo>
-                <a:close/>
-                <a:lnTo>
-                  <a:pt x="32327" y="2224478"/>
-                </a:lnTo>
-                <a:close/>
-                <a:lnTo>
-                  <a:pt x="38793" y="2210274"/>
-                </a:lnTo>
-                <a:close/>
-                <a:lnTo>
-                  <a:pt x="45258" y="2195628"/>
-                </a:lnTo>
-                <a:close/>
-                <a:lnTo>
-                  <a:pt x="51724" y="2180421"/>
-                </a:lnTo>
-                <a:close/>
-                <a:lnTo>
-                  <a:pt x="58189" y="2164836"/>
-                </a:lnTo>
-                <a:close/>
-                <a:lnTo>
-                  <a:pt x="64655" y="2149151"/>
-                </a:lnTo>
-                <a:close/>
-                <a:lnTo>
-                  <a:pt x="71120" y="2133636"/>
-                </a:lnTo>
-                <a:close/>
-                <a:lnTo>
-                  <a:pt x="77585" y="2118322"/>
-                </a:lnTo>
-                <a:close/>
-                <a:lnTo>
-                  <a:pt x="84051" y="2102925"/>
-                </a:lnTo>
-                <a:close/>
-                <a:lnTo>
-                  <a:pt x="90516" y="2087137"/>
-                </a:lnTo>
-                <a:close/>
-                <a:lnTo>
-                  <a:pt x="96982" y="2070720"/>
-                </a:lnTo>
-                <a:close/>
-                <a:lnTo>
-                  <a:pt x="103447" y="2053844"/>
-                </a:lnTo>
-                <a:close/>
-                <a:lnTo>
-                  <a:pt x="109913" y="2036840"/>
-                </a:lnTo>
-                <a:close/>
-                <a:lnTo>
-                  <a:pt x="116378" y="2020033"/>
-                </a:lnTo>
-                <a:close/>
-                <a:lnTo>
-                  <a:pt x="122844" y="2003487"/>
-                </a:lnTo>
-                <a:close/>
-                <a:lnTo>
-                  <a:pt x="129309" y="1986849"/>
-                </a:lnTo>
-                <a:close/>
-                <a:lnTo>
-                  <a:pt x="135775" y="1969729"/>
-                </a:lnTo>
-                <a:close/>
-                <a:lnTo>
-                  <a:pt x="142240" y="1951816"/>
-                </a:lnTo>
-                <a:close/>
-                <a:lnTo>
-                  <a:pt x="148705" y="1933430"/>
-                </a:lnTo>
-                <a:close/>
-                <a:lnTo>
-                  <a:pt x="155171" y="1915180"/>
-                </a:lnTo>
-                <a:close/>
-                <a:lnTo>
-                  <a:pt x="161636" y="1897677"/>
-                </a:lnTo>
-                <a:close/>
-                <a:lnTo>
-                  <a:pt x="168102" y="1881078"/>
-                </a:lnTo>
-                <a:close/>
-                <a:lnTo>
-                  <a:pt x="174567" y="1864665"/>
-                </a:lnTo>
-                <a:close/>
-                <a:lnTo>
-                  <a:pt x="181033" y="1847618"/>
-                </a:lnTo>
-                <a:close/>
-                <a:lnTo>
-                  <a:pt x="187498" y="1829216"/>
-                </a:lnTo>
-                <a:close/>
-                <a:lnTo>
-                  <a:pt x="193964" y="1809708"/>
-                </a:lnTo>
-                <a:close/>
-                <a:lnTo>
-                  <a:pt x="200429" y="1789887"/>
-                </a:lnTo>
-                <a:close/>
-                <a:lnTo>
-                  <a:pt x="206895" y="1770554"/>
-                </a:lnTo>
-                <a:close/>
-                <a:lnTo>
-                  <a:pt x="213360" y="1752153"/>
-                </a:lnTo>
-                <a:close/>
-                <a:lnTo>
-                  <a:pt x="219825" y="1734281"/>
-                </a:lnTo>
-                <a:close/>
-                <a:lnTo>
-                  <a:pt x="226291" y="1716410"/>
-                </a:lnTo>
-                <a:close/>
-                <a:lnTo>
-                  <a:pt x="232756" y="1698042"/>
-                </a:lnTo>
-                <a:close/>
-                <a:lnTo>
-                  <a:pt x="239222" y="1679005"/>
-                </a:lnTo>
-                <a:close/>
-                <a:lnTo>
-                  <a:pt x="245687" y="1659357"/>
-                </a:lnTo>
-                <a:close/>
-                <a:lnTo>
-                  <a:pt x="252153" y="1639160"/>
-                </a:lnTo>
-                <a:close/>
-                <a:lnTo>
-                  <a:pt x="258618" y="1618523"/>
-                </a:lnTo>
-                <a:close/>
-                <a:lnTo>
-                  <a:pt x="265084" y="1597702"/>
-                </a:lnTo>
-                <a:close/>
-                <a:lnTo>
-                  <a:pt x="271549" y="1576978"/>
-                </a:lnTo>
-                <a:close/>
-                <a:lnTo>
-                  <a:pt x="278015" y="1556607"/>
-                </a:lnTo>
-                <a:close/>
-                <a:lnTo>
-                  <a:pt x="284480" y="1536400"/>
-                </a:lnTo>
-                <a:close/>
-                <a:lnTo>
-                  <a:pt x="290945" y="1515804"/>
-                </a:lnTo>
-                <a:close/>
-                <a:lnTo>
-                  <a:pt x="297411" y="1494251"/>
-                </a:lnTo>
-                <a:close/>
-                <a:lnTo>
-                  <a:pt x="303876" y="1471419"/>
-                </a:lnTo>
-                <a:close/>
-                <a:lnTo>
-                  <a:pt x="310342" y="1447853"/>
-                </a:lnTo>
-                <a:close/>
-                <a:lnTo>
-                  <a:pt x="316807" y="1424294"/>
-                </a:lnTo>
-                <a:close/>
-                <a:lnTo>
-                  <a:pt x="323273" y="1401455"/>
-                </a:lnTo>
-                <a:close/>
-                <a:lnTo>
-                  <a:pt x="329738" y="1379440"/>
-                </a:lnTo>
-                <a:close/>
-                <a:lnTo>
-                  <a:pt x="336204" y="1357739"/>
-                </a:lnTo>
-                <a:close/>
-                <a:lnTo>
-                  <a:pt x="342669" y="1335818"/>
-                </a:lnTo>
-                <a:close/>
-                <a:lnTo>
-                  <a:pt x="349135" y="1313244"/>
-                </a:lnTo>
-                <a:close/>
-                <a:lnTo>
-                  <a:pt x="355600" y="1290048"/>
-                </a:lnTo>
-                <a:close/>
-                <a:lnTo>
-                  <a:pt x="362065" y="1266392"/>
-                </a:lnTo>
-                <a:close/>
-                <a:lnTo>
-                  <a:pt x="368531" y="1242430"/>
-                </a:lnTo>
-                <a:close/>
-                <a:lnTo>
-                  <a:pt x="374996" y="1218206"/>
-                </a:lnTo>
-                <a:close/>
-                <a:lnTo>
-                  <a:pt x="381462" y="1193623"/>
-                </a:lnTo>
-                <a:close/>
-                <a:lnTo>
-                  <a:pt x="387927" y="1168576"/>
-                </a:lnTo>
-                <a:close/>
-                <a:lnTo>
-                  <a:pt x="394393" y="1143002"/>
-                </a:lnTo>
-                <a:close/>
-                <a:lnTo>
-                  <a:pt x="400858" y="1117080"/>
-                </a:lnTo>
-                <a:close/>
-                <a:lnTo>
-                  <a:pt x="407324" y="1091069"/>
-                </a:lnTo>
-                <a:close/>
-                <a:lnTo>
-                  <a:pt x="413789" y="1065222"/>
-                </a:lnTo>
-                <a:close/>
-                <a:lnTo>
-                  <a:pt x="420255" y="1039575"/>
-                </a:lnTo>
-                <a:close/>
-                <a:lnTo>
-                  <a:pt x="426720" y="1013842"/>
-                </a:lnTo>
-                <a:close/>
-                <a:lnTo>
-                  <a:pt x="433185" y="987712"/>
-                </a:lnTo>
-                <a:close/>
-                <a:lnTo>
-                  <a:pt x="439651" y="960935"/>
-                </a:lnTo>
-                <a:close/>
-                <a:lnTo>
-                  <a:pt x="446116" y="933694"/>
-                </a:lnTo>
-                <a:close/>
-                <a:lnTo>
-                  <a:pt x="452582" y="906354"/>
-                </a:lnTo>
-                <a:close/>
-                <a:lnTo>
-                  <a:pt x="459047" y="879278"/>
-                </a:lnTo>
-                <a:close/>
-                <a:lnTo>
-                  <a:pt x="465513" y="852523"/>
-                </a:lnTo>
-                <a:close/>
-                <a:lnTo>
-                  <a:pt x="471978" y="825615"/>
-                </a:lnTo>
-                <a:close/>
-                <a:lnTo>
-                  <a:pt x="478444" y="798023"/>
-                </a:lnTo>
-                <a:close/>
-                <a:lnTo>
-                  <a:pt x="484909" y="769290"/>
-                </a:lnTo>
-                <a:close/>
-                <a:lnTo>
-                  <a:pt x="491375" y="739599"/>
-                </a:lnTo>
-                <a:close/>
-                <a:lnTo>
-                  <a:pt x="497840" y="709460"/>
-                </a:lnTo>
-                <a:close/>
-                <a:lnTo>
-                  <a:pt x="504305" y="679386"/>
-                </a:lnTo>
-                <a:close/>
-                <a:lnTo>
-                  <a:pt x="510771" y="649657"/>
-                </a:lnTo>
-                <a:close/>
-                <a:lnTo>
-                  <a:pt x="517236" y="620053"/>
-                </a:lnTo>
-                <a:close/>
-                <a:lnTo>
-                  <a:pt x="523702" y="590291"/>
-                </a:lnTo>
-                <a:close/>
-                <a:lnTo>
-                  <a:pt x="530167" y="560101"/>
-                </a:lnTo>
-                <a:close/>
-                <a:lnTo>
-                  <a:pt x="536633" y="529380"/>
-                </a:lnTo>
-                <a:close/>
-                <a:lnTo>
-                  <a:pt x="543098" y="498127"/>
-                </a:lnTo>
-                <a:close/>
-                <a:lnTo>
-                  <a:pt x="549564" y="466343"/>
-                </a:lnTo>
-                <a:close/>
-                <a:lnTo>
-                  <a:pt x="556029" y="434099"/>
-                </a:lnTo>
-                <a:close/>
-                <a:lnTo>
-                  <a:pt x="562495" y="401645"/>
-                </a:lnTo>
-                <a:close/>
-                <a:lnTo>
-                  <a:pt x="568960" y="369259"/>
-                </a:lnTo>
-                <a:close/>
-                <a:lnTo>
-                  <a:pt x="575425" y="337193"/>
-                </a:lnTo>
-                <a:close/>
-                <a:lnTo>
-                  <a:pt x="581891" y="305275"/>
-                </a:lnTo>
-                <a:close/>
-                <a:lnTo>
-                  <a:pt x="588356" y="273014"/>
-                </a:lnTo>
-                <a:close/>
-                <a:lnTo>
-                  <a:pt x="594822" y="239913"/>
-                </a:lnTo>
-                <a:close/>
-                <a:lnTo>
-                  <a:pt x="601287" y="205672"/>
-                </a:lnTo>
-                <a:close/>
-                <a:lnTo>
-                  <a:pt x="607753" y="170634"/>
-                </a:lnTo>
-                <a:close/>
-                <a:lnTo>
-                  <a:pt x="614218" y="135270"/>
-                </a:lnTo>
-                <a:close/>
-                <a:lnTo>
-                  <a:pt x="620684" y="100052"/>
-                </a:lnTo>
-                <a:close/>
-                <a:lnTo>
-                  <a:pt x="627149" y="65454"/>
-                </a:lnTo>
-                <a:close/>
-                <a:lnTo>
-                  <a:pt x="633615" y="31946"/>
-                </a:lnTo>
-                <a:close/>
-                <a:lnTo>
-                  <a:pt x="640080" y="0"/>
-                </a:lnTo>
-                <a:close/>
-              </a:path>
-            </a:pathLst>
-          </a:custGeom>
-          <a:ln w="19050">
-            <a:solidFill>
-              <a:srgbClr val="B4B4B4"/>
-            </a:solidFill>
-          </a:ln>
-        </p:spPr>
-        <p:style>
-          <a:lnRef idx="1">
-            <a:schemeClr val="accent1"/>
-          </a:lnRef>
-          <a:fillRef idx="3">
-            <a:schemeClr val="accent1"/>
-          </a:fillRef>
-          <a:effectRef idx="2">
-            <a:schemeClr val="accent1"/>
-          </a:effectRef>
-          <a:fontRef idx="minor">
-            <a:schemeClr val="lt1"/>
-          </a:fontRef>
-        </p:style>
-        <p:txBody>
-          <a:bodyPr rtlCol="0" anchor="ctr"/>
-          <a:lstStyle/>
-          <a:p>
-            <a:pPr algn="ctr"/>
-          </a:p>
-        </p:txBody>
-      </p:sp>
-      <p:sp>
-        <p:nvSpPr>
-          <p:cNvPr id="11" name="Freeform 10"/>
-          <p:cNvSpPr/>
-          <p:nvPr/>
-        </p:nvSpPr>
-        <p:spPr>
-          <a:xfrm>
-            <a:off x="6446520" y="-4190238"/>
-            <a:ext cx="411480" cy="2706624"/>
-          </a:xfrm>
-          <a:custGeom>
-            <a:avLst/>
-            <a:gdLst/>
-            <a:ahLst/>
-            <a:cxnLst/>
-            <a:rect l="l" t="t" r="r" b="b"/>
-            <a:pathLst>
-              <a:path w="411480" h="2706624">
-                <a:moveTo>
-                  <a:pt x="411480" y="0"/>
-                </a:moveTo>
-                <a:lnTo>
-                  <a:pt x="407324" y="15054"/>
-                </a:lnTo>
-                <a:close/>
-                <a:lnTo>
-                  <a:pt x="403167" y="34248"/>
-                </a:lnTo>
-                <a:close/>
-                <a:lnTo>
-                  <a:pt x="399011" y="57165"/>
-                </a:lnTo>
-                <a:close/>
-                <a:lnTo>
-                  <a:pt x="394855" y="83389"/>
-                </a:lnTo>
-                <a:close/>
-                <a:lnTo>
-                  <a:pt x="390698" y="112504"/>
-                </a:lnTo>
-                <a:close/>
-                <a:lnTo>
-                  <a:pt x="386542" y="144095"/>
-                </a:lnTo>
-                <a:close/>
-                <a:lnTo>
-                  <a:pt x="382385" y="177744"/>
-                </a:lnTo>
-                <a:close/>
-                <a:lnTo>
-                  <a:pt x="378229" y="213037"/>
-                </a:lnTo>
-                <a:close/>
-                <a:lnTo>
-                  <a:pt x="374073" y="249556"/>
-                </a:lnTo>
-                <a:close/>
-                <a:lnTo>
-                  <a:pt x="369916" y="286887"/>
-                </a:lnTo>
-                <a:close/>
-                <a:lnTo>
-                  <a:pt x="365760" y="324612"/>
-                </a:lnTo>
-                <a:close/>
-                <a:lnTo>
-                  <a:pt x="361604" y="362293"/>
-                </a:lnTo>
-                <a:close/>
-                <a:lnTo>
-                  <a:pt x="357447" y="399394"/>
-                </a:lnTo>
-                <a:close/>
-                <a:lnTo>
-                  <a:pt x="353291" y="435359"/>
-                </a:lnTo>
-                <a:close/>
-                <a:lnTo>
-                  <a:pt x="349135" y="469629"/>
-                </a:lnTo>
-                <a:close/>
-                <a:lnTo>
-                  <a:pt x="344978" y="501646"/>
-                </a:lnTo>
-                <a:close/>
-                <a:lnTo>
-                  <a:pt x="340822" y="530875"/>
-                </a:lnTo>
-                <a:close/>
-                <a:lnTo>
-                  <a:pt x="336665" y="557289"/>
-                </a:lnTo>
-                <a:close/>
-                <a:lnTo>
-                  <a:pt x="332509" y="581370"/>
-                </a:lnTo>
-                <a:close/>
-                <a:lnTo>
-                  <a:pt x="328353" y="603621"/>
-                </a:lnTo>
-                <a:close/>
-                <a:lnTo>
-                  <a:pt x="324196" y="624547"/>
-                </a:lnTo>
-                <a:close/>
-                <a:lnTo>
-                  <a:pt x="320040" y="644652"/>
-                </a:lnTo>
-                <a:close/>
-                <a:lnTo>
-                  <a:pt x="315884" y="664497"/>
-                </a:lnTo>
-                <a:close/>
-                <a:lnTo>
-                  <a:pt x="311727" y="684875"/>
-                </a:lnTo>
-                <a:close/>
-                <a:lnTo>
-                  <a:pt x="307571" y="706636"/>
-                </a:lnTo>
-                <a:close/>
-                <a:lnTo>
-                  <a:pt x="303415" y="730630"/>
-                </a:lnTo>
-                <a:close/>
-                <a:lnTo>
-                  <a:pt x="299258" y="757707"/>
-                </a:lnTo>
-                <a:close/>
-                <a:lnTo>
-                  <a:pt x="295102" y="788664"/>
-                </a:lnTo>
-                <a:close/>
-                <a:lnTo>
-                  <a:pt x="290945" y="823044"/>
-                </a:lnTo>
-                <a:close/>
-                <a:lnTo>
-                  <a:pt x="286789" y="859142"/>
-                </a:lnTo>
-                <a:close/>
-                <a:lnTo>
-                  <a:pt x="282633" y="895194"/>
-                </a:lnTo>
-                <a:close/>
-                <a:lnTo>
-                  <a:pt x="278476" y="929441"/>
-                </a:lnTo>
-                <a:close/>
-                <a:lnTo>
-                  <a:pt x="274320" y="960120"/>
-                </a:lnTo>
-                <a:close/>
-                <a:lnTo>
-                  <a:pt x="270164" y="986055"/>
-                </a:lnTo>
-                <a:close/>
-                <a:lnTo>
-                  <a:pt x="266007" y="1008405"/>
-                </a:lnTo>
-                <a:close/>
-                <a:lnTo>
-                  <a:pt x="261851" y="1028912"/>
-                </a:lnTo>
-                <a:close/>
-                <a:lnTo>
-                  <a:pt x="257695" y="1049322"/>
-                </a:lnTo>
-                <a:close/>
-                <a:lnTo>
-                  <a:pt x="253538" y="1071375"/>
-                </a:lnTo>
-                <a:close/>
-                <a:lnTo>
-                  <a:pt x="249382" y="1096765"/>
-                </a:lnTo>
-                <a:close/>
-                <a:lnTo>
-                  <a:pt x="245225" y="1125983"/>
-                </a:lnTo>
-                <a:close/>
-                <a:lnTo>
-                  <a:pt x="241069" y="1158319"/>
-                </a:lnTo>
-                <a:close/>
-                <a:lnTo>
-                  <a:pt x="236913" y="1193015"/>
-                </a:lnTo>
-                <a:close/>
-                <a:lnTo>
-                  <a:pt x="232756" y="1229310"/>
-                </a:lnTo>
-                <a:close/>
-                <a:lnTo>
-                  <a:pt x="228600" y="1266444"/>
-                </a:lnTo>
-                <a:close/>
-                <a:lnTo>
-                  <a:pt x="224444" y="1303642"/>
-                </a:lnTo>
-                <a:close/>
-                <a:lnTo>
-                  <a:pt x="220287" y="1340073"/>
-                </a:lnTo>
-                <a:close/>
-                <a:lnTo>
-                  <a:pt x="216131" y="1374890"/>
-                </a:lnTo>
-                <a:close/>
-                <a:lnTo>
-                  <a:pt x="211975" y="1407248"/>
-                </a:lnTo>
-                <a:close/>
-                <a:lnTo>
-                  <a:pt x="207818" y="1436301"/>
-                </a:lnTo>
-                <a:close/>
-                <a:lnTo>
-                  <a:pt x="203662" y="1461259"/>
-                </a:lnTo>
-                <a:close/>
-                <a:lnTo>
-                  <a:pt x="199505" y="1482617"/>
-                </a:lnTo>
-                <a:close/>
-                <a:lnTo>
-                  <a:pt x="195349" y="1502154"/>
-                </a:lnTo>
-                <a:close/>
-                <a:lnTo>
-                  <a:pt x="191193" y="1521706"/>
-                </a:lnTo>
-                <a:close/>
-                <a:lnTo>
-                  <a:pt x="187036" y="1543108"/>
-                </a:lnTo>
-                <a:close/>
-                <a:lnTo>
-                  <a:pt x="182880" y="1568196"/>
-                </a:lnTo>
-                <a:close/>
-                <a:lnTo>
-                  <a:pt x="178724" y="1598159"/>
-                </a:lnTo>
-                <a:close/>
-                <a:lnTo>
-                  <a:pt x="174567" y="1631599"/>
-                </a:lnTo>
-                <a:close/>
-                <a:lnTo>
-                  <a:pt x="170411" y="1666472"/>
-                </a:lnTo>
-                <a:close/>
-                <a:lnTo>
-                  <a:pt x="166255" y="1700732"/>
-                </a:lnTo>
-                <a:close/>
-                <a:lnTo>
-                  <a:pt x="162098" y="1732337"/>
-                </a:lnTo>
-                <a:close/>
-                <a:lnTo>
-                  <a:pt x="157942" y="1759326"/>
-                </a:lnTo>
-                <a:close/>
-                <a:lnTo>
-                  <a:pt x="153785" y="1781705"/>
-                </a:lnTo>
-                <a:close/>
-                <a:lnTo>
-                  <a:pt x="149629" y="1801444"/>
-                </a:lnTo>
-                <a:close/>
-                <a:lnTo>
-                  <a:pt x="145473" y="1820599"/>
-                </a:lnTo>
-                <a:close/>
-                <a:lnTo>
-                  <a:pt x="141316" y="1841224"/>
-                </a:lnTo>
-                <a:close/>
-                <a:lnTo>
-                  <a:pt x="137160" y="1865376"/>
-                </a:lnTo>
-                <a:close/>
-                <a:lnTo>
-                  <a:pt x="133004" y="1894424"/>
-                </a:lnTo>
-                <a:close/>
-                <a:lnTo>
-                  <a:pt x="128847" y="1926999"/>
-                </a:lnTo>
-                <a:close/>
-                <a:lnTo>
-                  <a:pt x="124691" y="1961046"/>
-                </a:lnTo>
-                <a:close/>
-                <a:lnTo>
-                  <a:pt x="120535" y="1994508"/>
-                </a:lnTo>
-                <a:close/>
-                <a:lnTo>
-                  <a:pt x="116378" y="2025332"/>
-                </a:lnTo>
-                <a:close/>
-                <a:lnTo>
-                  <a:pt x="112222" y="2051547"/>
-                </a:lnTo>
-                <a:close/>
-                <a:lnTo>
-                  <a:pt x="108065" y="2073147"/>
-                </a:lnTo>
-                <a:close/>
-                <a:lnTo>
-                  <a:pt x="103909" y="2092090"/>
-                </a:lnTo>
-                <a:close/>
-                <a:lnTo>
-                  <a:pt x="99753" y="2110420"/>
-                </a:lnTo>
-                <a:close/>
-                <a:lnTo>
-                  <a:pt x="95596" y="2130180"/>
-                </a:lnTo>
-                <a:close/>
-                <a:lnTo>
-                  <a:pt x="91440" y="2153412"/>
-                </a:lnTo>
-                <a:close/>
-                <a:lnTo>
-                  <a:pt x="87284" y="2181487"/>
-                </a:lnTo>
-                <a:close/>
-                <a:lnTo>
-                  <a:pt x="83127" y="2213083"/>
-                </a:lnTo>
-                <a:close/>
-                <a:lnTo>
-                  <a:pt x="78971" y="2246204"/>
-                </a:lnTo>
-                <a:close/>
-                <a:lnTo>
-                  <a:pt x="74815" y="2278853"/>
-                </a:lnTo>
-                <a:close/>
-                <a:lnTo>
-                  <a:pt x="70658" y="2309034"/>
-                </a:lnTo>
-                <a:close/>
-                <a:lnTo>
-                  <a:pt x="66502" y="2334832"/>
-                </a:lnTo>
-                <a:close/>
-                <a:lnTo>
-                  <a:pt x="62345" y="2356157"/>
-                </a:lnTo>
-                <a:close/>
-                <a:lnTo>
-                  <a:pt x="58189" y="2374749"/>
-                </a:lnTo>
-                <a:close/>
-                <a:lnTo>
-                  <a:pt x="54033" y="2392425"/>
-                </a:lnTo>
-                <a:close/>
-                <a:lnTo>
-                  <a:pt x="49876" y="2411004"/>
-                </a:lnTo>
-                <a:close/>
-                <a:lnTo>
-                  <a:pt x="45720" y="2432304"/>
-                </a:lnTo>
-                <a:close/>
-                <a:lnTo>
-                  <a:pt x="41564" y="2457648"/>
-                </a:lnTo>
-                <a:close/>
-                <a:lnTo>
-                  <a:pt x="37407" y="2486375"/>
-                </a:lnTo>
-                <a:close/>
-                <a:lnTo>
-                  <a:pt x="33251" y="2517332"/>
-                </a:lnTo>
-                <a:close/>
-                <a:lnTo>
-                  <a:pt x="29095" y="2549363"/>
-                </a:lnTo>
-                <a:close/>
-                <a:lnTo>
-                  <a:pt x="24938" y="2581313"/>
-                </a:lnTo>
-                <a:close/>
-                <a:lnTo>
-                  <a:pt x="20782" y="2612026"/>
-                </a:lnTo>
-                <a:close/>
-                <a:lnTo>
-                  <a:pt x="16625" y="2640348"/>
-                </a:lnTo>
-                <a:close/>
-                <a:lnTo>
-                  <a:pt x="12469" y="2665124"/>
-                </a:lnTo>
-                <a:close/>
-                <a:lnTo>
-                  <a:pt x="8313" y="2685199"/>
-                </a:lnTo>
-                <a:close/>
-                <a:lnTo>
-                  <a:pt x="4156" y="2699417"/>
-                </a:lnTo>
-                <a:close/>
-                <a:lnTo>
-                  <a:pt x="0" y="2706624"/>
-                </a:lnTo>
-                <a:close/>
-              </a:path>
-            </a:pathLst>
-          </a:custGeom>
-          <a:ln w="19050">
-            <a:solidFill>
-              <a:srgbClr val="B4B4B4"/>
-            </a:solidFill>
-          </a:ln>
-        </p:spPr>
-        <p:style>
-          <a:lnRef idx="1">
-            <a:schemeClr val="accent1"/>
-          </a:lnRef>
-          <a:fillRef idx="3">
-            <a:schemeClr val="accent1"/>
-          </a:fillRef>
-          <a:effectRef idx="2">
-            <a:schemeClr val="accent1"/>
-          </a:effectRef>
-          <a:fontRef idx="minor">
-            <a:schemeClr val="lt1"/>
-          </a:fontRef>
-        </p:style>
-        <p:txBody>
-          <a:bodyPr rtlCol="0" anchor="ctr"/>
-          <a:lstStyle/>
-          <a:p>
-            <a:pPr algn="ctr"/>
-          </a:p>
-        </p:txBody>
-      </p:sp>
-      <p:sp>
-        <p:nvSpPr>
           <p:cNvPr id="12" name="TextBox 11"/>
           <p:cNvSpPr txBox="1"/>
           <p:nvPr/>
         </p:nvSpPr>
         <p:spPr>
           <a:xfrm>
-            <a:off x="3906520" y="242569"/>
+            <a:off x="5323840" y="2437130"/>
             <a:ext cx="1524000" cy="508000"/>
           </a:xfrm>
           <a:prstGeom prst="rect">
@@ -5523,7 +5523,7 @@
           <a:lstStyle/>
           <a:p>
             <a:pPr>
-              <a:defRPr sz="1400" b="1">
+              <a:defRPr sz="1800" b="1">
                 <a:solidFill>
                   <a:srgbClr val="FFFFFF"/>
                 </a:solidFill>
@@ -5531,7 +5531,7 @@
               </a:defRPr>
             </a:pPr>
             <a:r>
-              <a:t>f(a)</a:t>
+              <a:t>a</a:t>
             </a:r>
           </a:p>
         </p:txBody>
@@ -5544,7 +5544,7 @@
         </p:nvSpPr>
         <p:spPr>
           <a:xfrm>
-            <a:off x="6146800" y="2437130"/>
+            <a:off x="3997960" y="911910"/>
             <a:ext cx="1524000" cy="508000"/>
           </a:xfrm>
           <a:prstGeom prst="rect">
@@ -5559,7 +5559,7 @@
           <a:lstStyle/>
           <a:p>
             <a:pPr>
-              <a:defRPr sz="1400" b="1">
+              <a:defRPr sz="1800" b="1">
                 <a:solidFill>
                   <a:srgbClr val="FFFFFF"/>
                 </a:solidFill>
@@ -5567,7 +5567,7 @@
               </a:defRPr>
             </a:pPr>
             <a:r>
-              <a:t>a</a:t>
+              <a:t>f(a)</a:t>
             </a:r>
           </a:p>
         </p:txBody>

</xml_diff>

<commit_message>
build: regenerate graphs using v3.1 logic for perfect overlay
</commit_message>
<xml_diff>
--- a/output/3.pptx
+++ b/output/3.pptx
@@ -3104,8 +3104,8 @@
         </p:nvCxnSpPr>
         <p:spPr>
           <a:xfrm>
-            <a:off x="4114800.0" y="2571750.0"/>
-            <a:ext cx="3657600.0" cy="0.0"/>
+            <a:off x="2286000.0" y="2571750.0"/>
+            <a:ext cx="4572000.0" cy="0.0"/>
           </a:xfrm>
           <a:prstGeom prst="line">
             <a:avLst/>
@@ -3139,7 +3139,7 @@
         </p:nvCxnSpPr>
         <p:spPr>
           <a:xfrm flipV="1">
-            <a:off x="4572000.0" y="-1543050.0"/>
+            <a:off x="4572000.0" y="285750.0"/>
             <a:ext cx="0.0" cy="4572000.0"/>
           </a:xfrm>
           <a:prstGeom prst="line">
@@ -3174,8 +3174,8 @@
         </p:nvSpPr>
         <p:spPr>
           <a:xfrm>
-            <a:off x="4937760" y="-1611173"/>
-            <a:ext cx="1805483" cy="3542386"/>
+            <a:off x="4937760" y="-1218438"/>
+            <a:ext cx="1623060" cy="2665882"/>
           </a:xfrm>
           <a:custGeom>
             <a:avLst/>
@@ -3184,2404 +3184,2404 @@
             <a:cxnLst/>
             <a:rect l="l" t="t" r="r" b="b"/>
             <a:pathLst>
-              <a:path w="1805483" h="3542386">
+              <a:path w="1623060" h="2665882">
                 <a:moveTo>
-                  <a:pt x="0" y="3542386"/>
+                  <a:pt x="0" y="2633472"/>
                 </a:moveTo>
                 <a:lnTo>
-                  <a:pt x="3106" y="3540249"/>
-                </a:lnTo>
-                <a:close/>
-                <a:lnTo>
-                  <a:pt x="6186" y="3538135"/>
-                </a:lnTo>
-                <a:close/>
-                <a:lnTo>
-                  <a:pt x="9243" y="3536039"/>
-                </a:lnTo>
-                <a:close/>
-                <a:lnTo>
-                  <a:pt x="12279" y="3533959"/>
-                </a:lnTo>
-                <a:close/>
-                <a:lnTo>
-                  <a:pt x="15297" y="3531891"/>
-                </a:lnTo>
-                <a:close/>
-                <a:lnTo>
-                  <a:pt x="18300" y="3529832"/>
-                </a:lnTo>
-                <a:close/>
-                <a:lnTo>
-                  <a:pt x="21291" y="3527778"/>
-                </a:lnTo>
-                <a:close/>
-                <a:lnTo>
-                  <a:pt x="24272" y="3525726"/>
-                </a:lnTo>
-                <a:close/>
-                <a:lnTo>
-                  <a:pt x="27246" y="3523674"/>
-                </a:lnTo>
-                <a:close/>
-                <a:lnTo>
-                  <a:pt x="30216" y="3521617"/>
-                </a:lnTo>
-                <a:close/>
-                <a:lnTo>
-                  <a:pt x="33185" y="3519552"/>
-                </a:lnTo>
-                <a:close/>
-                <a:lnTo>
-                  <a:pt x="36155" y="3517477"/>
-                </a:lnTo>
-                <a:close/>
-                <a:lnTo>
-                  <a:pt x="39129" y="3515387"/>
-                </a:lnTo>
-                <a:close/>
-                <a:lnTo>
-                  <a:pt x="42110" y="3513280"/>
-                </a:lnTo>
-                <a:close/>
-                <a:lnTo>
-                  <a:pt x="45101" y="3511151"/>
-                </a:lnTo>
-                <a:close/>
-                <a:lnTo>
-                  <a:pt x="48104" y="3508999"/>
-                </a:lnTo>
-                <a:close/>
-                <a:lnTo>
-                  <a:pt x="51119" y="3506825"/>
-                </a:lnTo>
-                <a:close/>
-                <a:lnTo>
-                  <a:pt x="54144" y="3504632"/>
-                </a:lnTo>
-                <a:close/>
-                <a:lnTo>
-                  <a:pt x="57179" y="3502426"/>
-                </a:lnTo>
-                <a:close/>
-                <a:lnTo>
-                  <a:pt x="60221" y="3500210"/>
-                </a:lnTo>
-                <a:close/>
-                <a:lnTo>
-                  <a:pt x="63270" y="3497990"/>
-                </a:lnTo>
-                <a:close/>
-                <a:lnTo>
-                  <a:pt x="66322" y="3495768"/>
-                </a:lnTo>
-                <a:close/>
-                <a:lnTo>
-                  <a:pt x="69377" y="3493551"/>
-                </a:lnTo>
-                <a:close/>
-                <a:lnTo>
-                  <a:pt x="72433" y="3491340"/>
-                </a:lnTo>
-                <a:close/>
-                <a:lnTo>
-                  <a:pt x="75487" y="3489136"/>
-                </a:lnTo>
-                <a:close/>
-                <a:lnTo>
-                  <a:pt x="78538" y="3486936"/>
-                </a:lnTo>
-                <a:close/>
-                <a:lnTo>
-                  <a:pt x="81583" y="3484738"/>
-                </a:lnTo>
-                <a:close/>
-                <a:lnTo>
-                  <a:pt x="84620" y="3482540"/>
-                </a:lnTo>
-                <a:close/>
-                <a:lnTo>
-                  <a:pt x="87645" y="3480340"/>
-                </a:lnTo>
-                <a:close/>
-                <a:lnTo>
-                  <a:pt x="90658" y="3478135"/>
-                </a:lnTo>
-                <a:close/>
-                <a:lnTo>
-                  <a:pt x="93655" y="3475925"/>
-                </a:lnTo>
-                <a:close/>
-                <a:lnTo>
-                  <a:pt x="96637" y="3473705"/>
-                </a:lnTo>
-                <a:close/>
-                <a:lnTo>
-                  <a:pt x="99608" y="3471476"/>
-                </a:lnTo>
-                <a:close/>
-                <a:lnTo>
-                  <a:pt x="102574" y="3469233"/>
-                </a:lnTo>
-                <a:close/>
-                <a:lnTo>
-                  <a:pt x="105538" y="3466977"/>
-                </a:lnTo>
-                <a:close/>
-                <a:lnTo>
-                  <a:pt x="108507" y="3464704"/>
-                </a:lnTo>
-                <a:close/>
-                <a:lnTo>
-                  <a:pt x="111485" y="3462412"/>
-                </a:lnTo>
-                <a:close/>
-                <a:lnTo>
-                  <a:pt x="114477" y="3460100"/>
-                </a:lnTo>
-                <a:close/>
-                <a:lnTo>
-                  <a:pt x="117488" y="3457766"/>
-                </a:lnTo>
-                <a:close/>
-                <a:lnTo>
-                  <a:pt x="120517" y="3455411"/>
-                </a:lnTo>
-                <a:close/>
-                <a:lnTo>
-                  <a:pt x="123559" y="3453040"/>
-                </a:lnTo>
-                <a:close/>
-                <a:lnTo>
-                  <a:pt x="126607" y="3450656"/>
-                </a:lnTo>
-                <a:close/>
-                <a:lnTo>
-                  <a:pt x="129656" y="3448263"/>
-                </a:lnTo>
-                <a:close/>
-                <a:lnTo>
-                  <a:pt x="132701" y="3445865"/>
-                </a:lnTo>
-                <a:close/>
-                <a:lnTo>
-                  <a:pt x="135737" y="3443467"/>
-                </a:lnTo>
-                <a:close/>
-                <a:lnTo>
-                  <a:pt x="138757" y="3441071"/>
-                </a:lnTo>
-                <a:close/>
-                <a:lnTo>
-                  <a:pt x="141758" y="3438683"/>
-                </a:lnTo>
-                <a:close/>
-                <a:lnTo>
-                  <a:pt x="144742" y="3436300"/>
-                </a:lnTo>
-                <a:close/>
-                <a:lnTo>
-                  <a:pt x="147715" y="3433921"/>
-                </a:lnTo>
-                <a:close/>
-                <a:lnTo>
-                  <a:pt x="150681" y="3431544"/>
-                </a:lnTo>
-                <a:close/>
-                <a:lnTo>
-                  <a:pt x="153646" y="3429167"/>
-                </a:lnTo>
-                <a:close/>
-                <a:lnTo>
-                  <a:pt x="156613" y="3426788"/>
-                </a:lnTo>
-                <a:close/>
-                <a:lnTo>
-                  <a:pt x="159589" y="3424406"/>
-                </a:lnTo>
-                <a:close/>
-                <a:lnTo>
-                  <a:pt x="162578" y="3422017"/>
-                </a:lnTo>
-                <a:close/>
-                <a:lnTo>
-                  <a:pt x="165584" y="3419620"/>
-                </a:lnTo>
-                <a:close/>
-                <a:lnTo>
-                  <a:pt x="168603" y="3417214"/>
-                </a:lnTo>
-                <a:close/>
-                <a:lnTo>
-                  <a:pt x="171634" y="3414794"/>
-                </a:lnTo>
-                <a:close/>
-                <a:lnTo>
-                  <a:pt x="174675" y="3412361"/>
-                </a:lnTo>
-                <a:close/>
-                <a:lnTo>
-                  <a:pt x="177724" y="3409910"/>
-                </a:lnTo>
-                <a:close/>
-                <a:lnTo>
-                  <a:pt x="180777" y="3407440"/>
-                </a:lnTo>
-                <a:close/>
-                <a:lnTo>
-                  <a:pt x="183833" y="3404948"/>
-                </a:lnTo>
-                <a:close/>
-                <a:lnTo>
-                  <a:pt x="186890" y="3402432"/>
-                </a:lnTo>
-                <a:close/>
-                <a:lnTo>
-                  <a:pt x="189946" y="3399895"/>
-                </a:lnTo>
-                <a:close/>
-                <a:lnTo>
-                  <a:pt x="192998" y="3397340"/>
-                </a:lnTo>
-                <a:close/>
-                <a:lnTo>
-                  <a:pt x="196044" y="3394774"/>
-                </a:lnTo>
-                <a:close/>
-                <a:lnTo>
-                  <a:pt x="199083" y="3392201"/>
-                </a:lnTo>
-                <a:close/>
-                <a:lnTo>
-                  <a:pt x="202113" y="3389626"/>
-                </a:lnTo>
-                <a:close/>
-                <a:lnTo>
-                  <a:pt x="205132" y="3387054"/>
-                </a:lnTo>
-                <a:close/>
-                <a:lnTo>
-                  <a:pt x="208137" y="3384490"/>
-                </a:lnTo>
-                <a:close/>
-                <a:lnTo>
-                  <a:pt x="211128" y="3381938"/>
-                </a:lnTo>
-                <a:close/>
-                <a:lnTo>
-                  <a:pt x="214107" y="3379394"/>
-                </a:lnTo>
-                <a:close/>
-                <a:lnTo>
-                  <a:pt x="217079" y="3376854"/>
-                </a:lnTo>
-                <a:close/>
-                <a:lnTo>
-                  <a:pt x="220046" y="3374311"/>
-                </a:lnTo>
-                <a:close/>
-                <a:lnTo>
-                  <a:pt x="223014" y="3371760"/>
-                </a:lnTo>
-                <a:close/>
-                <a:lnTo>
-                  <a:pt x="225986" y="3369194"/>
-                </a:lnTo>
-                <a:close/>
-                <a:lnTo>
-                  <a:pt x="228966" y="3366608"/>
-                </a:lnTo>
-                <a:close/>
-                <a:lnTo>
-                  <a:pt x="231958" y="3363997"/>
-                </a:lnTo>
-                <a:close/>
-                <a:lnTo>
-                  <a:pt x="234965" y="3361358"/>
-                </a:lnTo>
-                <a:close/>
-                <a:lnTo>
-                  <a:pt x="237985" y="3358695"/>
-                </a:lnTo>
-                <a:close/>
-                <a:lnTo>
-                  <a:pt x="241015" y="3356015"/>
-                </a:lnTo>
-                <a:close/>
-                <a:lnTo>
-                  <a:pt x="244055" y="3353323"/>
-                </a:lnTo>
-                <a:close/>
-                <a:lnTo>
-                  <a:pt x="247102" y="3350625"/>
-                </a:lnTo>
-                <a:close/>
-                <a:lnTo>
-                  <a:pt x="250155" y="3347927"/>
-                </a:lnTo>
-                <a:close/>
-                <a:lnTo>
-                  <a:pt x="253210" y="3345235"/>
-                </a:lnTo>
-                <a:close/>
-                <a:lnTo>
-                  <a:pt x="256267" y="3342553"/>
-                </a:lnTo>
-                <a:close/>
-                <a:lnTo>
-                  <a:pt x="259323" y="3339883"/>
-                </a:lnTo>
-                <a:close/>
-                <a:lnTo>
-                  <a:pt x="262377" y="3337219"/>
-                </a:lnTo>
-                <a:close/>
-                <a:lnTo>
-                  <a:pt x="265424" y="3334556"/>
-                </a:lnTo>
-                <a:close/>
-                <a:lnTo>
-                  <a:pt x="268465" y="3331888"/>
-                </a:lnTo>
-                <a:close/>
-                <a:lnTo>
-                  <a:pt x="271495" y="3329211"/>
-                </a:lnTo>
-                <a:close/>
-                <a:lnTo>
-                  <a:pt x="274513" y="3326519"/>
-                </a:lnTo>
-                <a:close/>
-                <a:lnTo>
-                  <a:pt x="277517" y="3323806"/>
-                </a:lnTo>
-                <a:close/>
-                <a:lnTo>
-                  <a:pt x="280505" y="3321070"/>
-                </a:lnTo>
-                <a:close/>
-                <a:lnTo>
-                  <a:pt x="283480" y="3318309"/>
-                </a:lnTo>
-                <a:close/>
-                <a:lnTo>
-                  <a:pt x="286447" y="3315529"/>
-                </a:lnTo>
-                <a:close/>
-                <a:lnTo>
-                  <a:pt x="289411" y="3312731"/>
-                </a:lnTo>
-                <a:close/>
-                <a:lnTo>
-                  <a:pt x="292378" y="3309918"/>
-                </a:lnTo>
-                <a:close/>
-                <a:lnTo>
-                  <a:pt x="295351" y="3307095"/>
-                </a:lnTo>
-                <a:close/>
-                <a:lnTo>
-                  <a:pt x="298337" y="3304263"/>
-                </a:lnTo>
-                <a:close/>
-                <a:lnTo>
-                  <a:pt x="301339" y="3301426"/>
-                </a:lnTo>
-                <a:close/>
-                <a:lnTo>
-                  <a:pt x="304361" y="3298585"/>
-                </a:lnTo>
-                <a:close/>
-                <a:lnTo>
-                  <a:pt x="307398" y="3295741"/>
-                </a:lnTo>
-                <a:close/>
-                <a:lnTo>
-                  <a:pt x="310444" y="3292893"/>
-                </a:lnTo>
-                <a:close/>
-                <a:lnTo>
-                  <a:pt x="313493" y="3290039"/>
-                </a:lnTo>
-                <a:close/>
-                <a:lnTo>
-                  <a:pt x="316541" y="3287178"/>
-                </a:lnTo>
-                <a:close/>
-                <a:lnTo>
-                  <a:pt x="319581" y="3284309"/>
-                </a:lnTo>
-                <a:close/>
-                <a:lnTo>
-                  <a:pt x="322609" y="3281432"/>
-                </a:lnTo>
-                <a:close/>
-                <a:lnTo>
-                  <a:pt x="325618" y="3278545"/>
-                </a:lnTo>
-                <a:close/>
-                <a:lnTo>
-                  <a:pt x="328609" y="3275649"/>
-                </a:lnTo>
-                <a:close/>
-                <a:lnTo>
-                  <a:pt x="331587" y="3272744"/>
-                </a:lnTo>
-                <a:close/>
-                <a:lnTo>
-                  <a:pt x="334555" y="3269831"/>
-                </a:lnTo>
-                <a:close/>
-                <a:lnTo>
-                  <a:pt x="337520" y="3266911"/>
-                </a:lnTo>
-                <a:close/>
-                <a:lnTo>
-                  <a:pt x="340485" y="3263985"/>
-                </a:lnTo>
-                <a:close/>
-                <a:lnTo>
-                  <a:pt x="343457" y="3261052"/>
-                </a:lnTo>
-                <a:close/>
-                <a:lnTo>
-                  <a:pt x="346440" y="3258115"/>
-                </a:lnTo>
-                <a:close/>
-                <a:lnTo>
-                  <a:pt x="349438" y="3255174"/>
-                </a:lnTo>
-                <a:close/>
-                <a:lnTo>
-                  <a:pt x="352451" y="3252228"/>
-                </a:lnTo>
-                <a:close/>
-                <a:lnTo>
-                  <a:pt x="355477" y="3249273"/>
-                </a:lnTo>
-                <a:close/>
-                <a:lnTo>
-                  <a:pt x="358514" y="3246308"/>
-                </a:lnTo>
-                <a:close/>
-                <a:lnTo>
-                  <a:pt x="361559" y="3243331"/>
-                </a:lnTo>
-                <a:close/>
-                <a:lnTo>
-                  <a:pt x="364611" y="3240339"/>
-                </a:lnTo>
-                <a:close/>
-                <a:lnTo>
-                  <a:pt x="367666" y="3237329"/>
-                </a:lnTo>
-                <a:close/>
-                <a:lnTo>
-                  <a:pt x="370724" y="3234301"/>
-                </a:lnTo>
-                <a:close/>
-                <a:lnTo>
-                  <a:pt x="373781" y="3231252"/>
-                </a:lnTo>
-                <a:close/>
-                <a:lnTo>
-                  <a:pt x="376836" y="3228184"/>
-                </a:lnTo>
-                <a:close/>
-                <a:lnTo>
-                  <a:pt x="379887" y="3225099"/>
-                </a:lnTo>
-                <a:close/>
-                <a:lnTo>
-                  <a:pt x="382930" y="3222001"/>
-                </a:lnTo>
-                <a:close/>
-                <a:lnTo>
-                  <a:pt x="385964" y="3218890"/>
-                </a:lnTo>
-                <a:close/>
-                <a:lnTo>
-                  <a:pt x="388987" y="3215770"/>
-                </a:lnTo>
-                <a:close/>
-                <a:lnTo>
-                  <a:pt x="391997" y="3212642"/>
-                </a:lnTo>
-                <a:close/>
-                <a:lnTo>
-                  <a:pt x="394991" y="3209510"/>
-                </a:lnTo>
-                <a:close/>
-                <a:lnTo>
-                  <a:pt x="397970" y="3206373"/>
-                </a:lnTo>
-                <a:close/>
-                <a:lnTo>
-                  <a:pt x="400940" y="3203230"/>
-                </a:lnTo>
-                <a:close/>
-                <a:lnTo>
-                  <a:pt x="403904" y="3200083"/>
-                </a:lnTo>
-                <a:close/>
-                <a:lnTo>
-                  <a:pt x="406870" y="3196928"/>
-                </a:lnTo>
-                <a:close/>
-                <a:lnTo>
-                  <a:pt x="409840" y="3193767"/>
-                </a:lnTo>
-                <a:close/>
-                <a:lnTo>
-                  <a:pt x="412820" y="3190597"/>
-                </a:lnTo>
-                <a:close/>
-                <a:lnTo>
-                  <a:pt x="415815" y="3187419"/>
-                </a:lnTo>
-                <a:close/>
-                <a:lnTo>
-                  <a:pt x="418830" y="3184231"/>
-                </a:lnTo>
-                <a:close/>
-                <a:lnTo>
-                  <a:pt x="421861" y="3181034"/>
-                </a:lnTo>
-                <a:close/>
-                <a:lnTo>
-                  <a:pt x="424904" y="3177829"/>
-                </a:lnTo>
-                <a:close/>
-                <a:lnTo>
-                  <a:pt x="427953" y="3174616"/>
-                </a:lnTo>
-                <a:close/>
-                <a:lnTo>
-                  <a:pt x="431002" y="3171396"/>
-                </a:lnTo>
-                <a:close/>
-                <a:lnTo>
-                  <a:pt x="434046" y="3168171"/>
-                </a:lnTo>
-                <a:close/>
-                <a:lnTo>
-                  <a:pt x="437079" y="3164940"/>
-                </a:lnTo>
-                <a:close/>
-                <a:lnTo>
-                  <a:pt x="440096" y="3161705"/>
-                </a:lnTo>
-                <a:close/>
-                <a:lnTo>
-                  <a:pt x="443094" y="3158466"/>
-                </a:lnTo>
-                <a:close/>
-                <a:lnTo>
-                  <a:pt x="446076" y="3155220"/>
-                </a:lnTo>
-                <a:close/>
-                <a:lnTo>
-                  <a:pt x="449047" y="3151966"/>
-                </a:lnTo>
-                <a:close/>
-                <a:lnTo>
-                  <a:pt x="452013" y="3148700"/>
-                </a:lnTo>
-                <a:close/>
-                <a:lnTo>
-                  <a:pt x="454977" y="3145421"/>
-                </a:lnTo>
-                <a:close/>
-                <a:lnTo>
-                  <a:pt x="457946" y="3142126"/>
-                </a:lnTo>
-                <a:close/>
-                <a:lnTo>
-                  <a:pt x="460924" y="3138813"/>
-                </a:lnTo>
-                <a:close/>
-                <a:lnTo>
-                  <a:pt x="463916" y="3135479"/>
-                </a:lnTo>
-                <a:close/>
-                <a:lnTo>
-                  <a:pt x="466924" y="3132124"/>
-                </a:lnTo>
-                <a:close/>
-                <a:lnTo>
-                  <a:pt x="469945" y="3128751"/>
-                </a:lnTo>
-                <a:close/>
-                <a:lnTo>
-                  <a:pt x="472978" y="3125363"/>
-                </a:lnTo>
-                <a:close/>
-                <a:lnTo>
-                  <a:pt x="476020" y="3121961"/>
-                </a:lnTo>
-                <a:close/>
-                <a:lnTo>
-                  <a:pt x="479070" y="3118551"/>
-                </a:lnTo>
-                <a:close/>
-                <a:lnTo>
-                  <a:pt x="482124" y="3115133"/>
-                </a:lnTo>
-                <a:close/>
-                <a:lnTo>
-                  <a:pt x="485181" y="3111711"/>
-                </a:lnTo>
-                <a:close/>
-                <a:lnTo>
-                  <a:pt x="488237" y="3108287"/>
-                </a:lnTo>
-                <a:close/>
-                <a:lnTo>
-                  <a:pt x="491292" y="3104861"/>
-                </a:lnTo>
-                <a:close/>
-                <a:lnTo>
-                  <a:pt x="494343" y="3101429"/>
-                </a:lnTo>
-                <a:close/>
-                <a:lnTo>
-                  <a:pt x="497389" y="3097989"/>
-                </a:lnTo>
-                <a:close/>
-                <a:lnTo>
-                  <a:pt x="500427" y="3094538"/>
-                </a:lnTo>
-                <a:close/>
-                <a:lnTo>
-                  <a:pt x="503455" y="3091073"/>
-                </a:lnTo>
-                <a:close/>
-                <a:lnTo>
-                  <a:pt x="506471" y="3087592"/>
-                </a:lnTo>
-                <a:close/>
-                <a:lnTo>
-                  <a:pt x="509474" y="3084091"/>
-                </a:lnTo>
-                <a:close/>
-                <a:lnTo>
-                  <a:pt x="512463" y="3080570"/>
-                </a:lnTo>
-                <a:close/>
-                <a:lnTo>
-                  <a:pt x="515441" y="3077028"/>
-                </a:lnTo>
-                <a:close/>
-                <a:lnTo>
-                  <a:pt x="518411" y="3073470"/>
-                </a:lnTo>
-                <a:close/>
-                <a:lnTo>
-                  <a:pt x="521378" y="3069896"/>
-                </a:lnTo>
-                <a:close/>
-                <a:lnTo>
-                  <a:pt x="524347" y="3066310"/>
-                </a:lnTo>
-                <a:close/>
-                <a:lnTo>
-                  <a:pt x="527319" y="3062713"/>
-                </a:lnTo>
-                <a:close/>
-                <a:lnTo>
-                  <a:pt x="530301" y="3059107"/>
-                </a:lnTo>
-                <a:close/>
-                <a:lnTo>
-                  <a:pt x="533296" y="3055496"/>
-                </a:lnTo>
-                <a:close/>
-                <a:lnTo>
-                  <a:pt x="536305" y="3051880"/>
-                </a:lnTo>
-                <a:close/>
-                <a:lnTo>
-                  <a:pt x="539327" y="3048259"/>
-                </a:lnTo>
-                <a:close/>
-                <a:lnTo>
-                  <a:pt x="542359" y="3044633"/>
-                </a:lnTo>
-                <a:close/>
-                <a:lnTo>
-                  <a:pt x="545400" y="3041002"/>
-                </a:lnTo>
-                <a:close/>
-                <a:lnTo>
-                  <a:pt x="548448" y="3037365"/>
-                </a:lnTo>
-                <a:close/>
-                <a:lnTo>
-                  <a:pt x="551501" y="3033723"/>
-                </a:lnTo>
-                <a:close/>
-                <a:lnTo>
-                  <a:pt x="554557" y="3030074"/>
-                </a:lnTo>
-                <a:close/>
-                <a:lnTo>
-                  <a:pt x="557614" y="3026419"/>
-                </a:lnTo>
-                <a:close/>
-                <a:lnTo>
-                  <a:pt x="560670" y="3022757"/>
-                </a:lnTo>
-                <a:close/>
-                <a:lnTo>
-                  <a:pt x="563723" y="3019087"/>
-                </a:lnTo>
-                <a:close/>
-                <a:lnTo>
-                  <a:pt x="566769" y="3015406"/>
-                </a:lnTo>
-                <a:close/>
-                <a:lnTo>
-                  <a:pt x="569808" y="3011714"/>
-                </a:lnTo>
-                <a:close/>
-                <a:lnTo>
-                  <a:pt x="572836" y="3008010"/>
-                </a:lnTo>
-                <a:close/>
-                <a:lnTo>
-                  <a:pt x="575852" y="3004290"/>
-                </a:lnTo>
-                <a:close/>
-                <a:lnTo>
-                  <a:pt x="578854" y="3000556"/>
-                </a:lnTo>
-                <a:close/>
-                <a:lnTo>
-                  <a:pt x="581839" y="2996804"/>
-                </a:lnTo>
-                <a:close/>
-                <a:lnTo>
-                  <a:pt x="584812" y="2993036"/>
-                </a:lnTo>
-                <a:close/>
-                <a:lnTo>
-                  <a:pt x="587779" y="2989249"/>
-                </a:lnTo>
-                <a:close/>
-                <a:lnTo>
-                  <a:pt x="590743" y="2985445"/>
-                </a:lnTo>
-                <a:close/>
-                <a:lnTo>
-                  <a:pt x="593710" y="2981624"/>
-                </a:lnTo>
-                <a:close/>
-                <a:lnTo>
-                  <a:pt x="596685" y="2977784"/>
-                </a:lnTo>
-                <a:close/>
-                <a:lnTo>
-                  <a:pt x="599674" y="2973925"/>
-                </a:lnTo>
-                <a:close/>
-                <a:lnTo>
-                  <a:pt x="602679" y="2970049"/>
-                </a:lnTo>
-                <a:close/>
-                <a:lnTo>
-                  <a:pt x="605704" y="2966154"/>
-                </a:lnTo>
-                <a:close/>
-                <a:lnTo>
-                  <a:pt x="608743" y="2962244"/>
-                </a:lnTo>
-                <a:close/>
-                <a:lnTo>
-                  <a:pt x="611789" y="2958320"/>
-                </a:lnTo>
-                <a:close/>
-                <a:lnTo>
-                  <a:pt x="614839" y="2954386"/>
-                </a:lnTo>
-                <a:close/>
-                <a:lnTo>
-                  <a:pt x="617886" y="2950442"/>
-                </a:lnTo>
-                <a:close/>
-                <a:lnTo>
-                  <a:pt x="620925" y="2946492"/>
-                </a:lnTo>
-                <a:close/>
-                <a:lnTo>
-                  <a:pt x="623950" y="2942537"/>
-                </a:lnTo>
-                <a:close/>
-                <a:lnTo>
-                  <a:pt x="626956" y="2938580"/>
-                </a:lnTo>
-                <a:close/>
-                <a:lnTo>
-                  <a:pt x="629944" y="2934620"/>
-                </a:lnTo>
-                <a:close/>
-                <a:lnTo>
-                  <a:pt x="632919" y="2930655"/>
-                </a:lnTo>
-                <a:close/>
-                <a:lnTo>
-                  <a:pt x="635887" y="2926680"/>
-                </a:lnTo>
-                <a:close/>
-                <a:lnTo>
-                  <a:pt x="638851" y="2922694"/>
-                </a:lnTo>
-                <a:close/>
-                <a:lnTo>
-                  <a:pt x="641817" y="2918694"/>
-                </a:lnTo>
-                <a:close/>
-                <a:lnTo>
-                  <a:pt x="644790" y="2914676"/>
-                </a:lnTo>
-                <a:close/>
-                <a:lnTo>
-                  <a:pt x="647776" y="2910639"/>
-                </a:lnTo>
-                <a:close/>
-                <a:lnTo>
-                  <a:pt x="650777" y="2906580"/>
-                </a:lnTo>
-                <a:close/>
-                <a:lnTo>
-                  <a:pt x="653792" y="2902502"/>
-                </a:lnTo>
-                <a:close/>
-                <a:lnTo>
-                  <a:pt x="656821" y="2898406"/>
-                </a:lnTo>
-                <a:close/>
-                <a:lnTo>
-                  <a:pt x="659859" y="2894295"/>
-                </a:lnTo>
-                <a:close/>
-                <a:lnTo>
-                  <a:pt x="662906" y="2890174"/>
-                </a:lnTo>
-                <a:close/>
-                <a:lnTo>
-                  <a:pt x="665958" y="2886043"/>
-                </a:lnTo>
-                <a:close/>
-                <a:lnTo>
-                  <a:pt x="669014" y="2881907"/>
-                </a:lnTo>
-                <a:close/>
-                <a:lnTo>
-                  <a:pt x="672071" y="2877768"/>
-                </a:lnTo>
-                <a:close/>
-                <a:lnTo>
-                  <a:pt x="675127" y="2873627"/>
-                </a:lnTo>
-                <a:close/>
-                <a:lnTo>
-                  <a:pt x="678180" y="2869481"/>
-                </a:lnTo>
-                <a:close/>
-                <a:lnTo>
-                  <a:pt x="681228" y="2865329"/>
-                </a:lnTo>
-                <a:close/>
-                <a:lnTo>
-                  <a:pt x="684270" y="2861168"/>
-                </a:lnTo>
-                <a:close/>
-                <a:lnTo>
-                  <a:pt x="687302" y="2856995"/>
-                </a:lnTo>
-                <a:close/>
-                <a:lnTo>
-                  <a:pt x="690324" y="2852809"/>
-                </a:lnTo>
-                <a:close/>
-                <a:lnTo>
-                  <a:pt x="693333" y="2848606"/>
-                </a:lnTo>
-                <a:close/>
-                <a:lnTo>
-                  <a:pt x="696328" y="2844384"/>
-                </a:lnTo>
-                <a:close/>
-                <a:lnTo>
-                  <a:pt x="699310" y="2840144"/>
-                </a:lnTo>
-                <a:close/>
-                <a:lnTo>
-                  <a:pt x="702283" y="2835885"/>
-                </a:lnTo>
-                <a:close/>
-                <a:lnTo>
-                  <a:pt x="705251" y="2831608"/>
-                </a:lnTo>
-                <a:close/>
-                <a:lnTo>
-                  <a:pt x="708218" y="2827315"/>
-                </a:lnTo>
-                <a:close/>
-                <a:lnTo>
-                  <a:pt x="711189" y="2823006"/>
-                </a:lnTo>
-                <a:close/>
-                <a:lnTo>
-                  <a:pt x="714166" y="2818683"/>
-                </a:lnTo>
-                <a:close/>
-                <a:lnTo>
-                  <a:pt x="717155" y="2814345"/>
-                </a:lnTo>
-                <a:close/>
-                <a:lnTo>
-                  <a:pt x="720158" y="2809993"/>
-                </a:lnTo>
-                <a:close/>
-                <a:lnTo>
-                  <a:pt x="723174" y="2805628"/>
-                </a:lnTo>
-                <a:close/>
-                <a:lnTo>
-                  <a:pt x="726202" y="2801247"/>
-                </a:lnTo>
-                <a:close/>
-                <a:lnTo>
-                  <a:pt x="729240" y="2796851"/>
-                </a:lnTo>
-                <a:close/>
-                <a:lnTo>
-                  <a:pt x="732285" y="2792437"/>
-                </a:lnTo>
-                <a:close/>
-                <a:lnTo>
-                  <a:pt x="735336" y="2788006"/>
-                </a:lnTo>
-                <a:close/>
-                <a:lnTo>
-                  <a:pt x="738391" y="2783555"/>
-                </a:lnTo>
-                <a:close/>
-                <a:lnTo>
-                  <a:pt x="741448" y="2779085"/>
-                </a:lnTo>
-                <a:close/>
-                <a:lnTo>
-                  <a:pt x="744504" y="2774595"/>
-                </a:lnTo>
-                <a:close/>
-                <a:lnTo>
-                  <a:pt x="747559" y="2770089"/>
-                </a:lnTo>
-                <a:close/>
-                <a:lnTo>
-                  <a:pt x="750608" y="2765568"/>
-                </a:lnTo>
-                <a:close/>
-                <a:lnTo>
-                  <a:pt x="753651" y="2761037"/>
-                </a:lnTo>
-                <a:close/>
-                <a:lnTo>
-                  <a:pt x="756684" y="2756498"/>
-                </a:lnTo>
-                <a:close/>
-                <a:lnTo>
-                  <a:pt x="759705" y="2751955"/>
-                </a:lnTo>
-                <a:close/>
-                <a:lnTo>
-                  <a:pt x="762713" y="2747409"/>
-                </a:lnTo>
-                <a:close/>
-                <a:lnTo>
-                  <a:pt x="765705" y="2742865"/>
-                </a:lnTo>
-                <a:close/>
-                <a:lnTo>
-                  <a:pt x="768683" y="2738320"/>
-                </a:lnTo>
-                <a:close/>
-                <a:lnTo>
-                  <a:pt x="771652" y="2733770"/>
-                </a:lnTo>
-                <a:close/>
-                <a:lnTo>
-                  <a:pt x="774617" y="2729209"/>
-                </a:lnTo>
-                <a:close/>
-                <a:lnTo>
-                  <a:pt x="777582" y="2724633"/>
-                </a:lnTo>
-                <a:close/>
-                <a:lnTo>
-                  <a:pt x="780553" y="2720036"/>
-                </a:lnTo>
-                <a:close/>
-                <a:lnTo>
-                  <a:pt x="783535" y="2715414"/>
-                </a:lnTo>
-                <a:close/>
-                <a:lnTo>
-                  <a:pt x="786533" y="2710761"/>
-                </a:lnTo>
-                <a:close/>
-                <a:lnTo>
-                  <a:pt x="789550" y="2706074"/>
-                </a:lnTo>
-                <a:close/>
-                <a:lnTo>
-                  <a:pt x="792583" y="2701355"/>
-                </a:lnTo>
-                <a:close/>
-                <a:lnTo>
-                  <a:pt x="795627" y="2696609"/>
-                </a:lnTo>
-                <a:close/>
-                <a:lnTo>
-                  <a:pt x="798676" y="2691842"/>
-                </a:lnTo>
-                <a:close/>
-                <a:lnTo>
-                  <a:pt x="801725" y="2687059"/>
-                </a:lnTo>
-                <a:close/>
-                <a:lnTo>
-                  <a:pt x="804767" y="2682264"/>
-                </a:lnTo>
-                <a:close/>
-                <a:lnTo>
-                  <a:pt x="807799" y="2677462"/>
-                </a:lnTo>
-                <a:close/>
-                <a:lnTo>
-                  <a:pt x="810814" y="2672659"/>
-                </a:lnTo>
-                <a:close/>
-                <a:lnTo>
-                  <a:pt x="813809" y="2667857"/>
-                </a:lnTo>
-                <a:close/>
-                <a:lnTo>
-                  <a:pt x="816790" y="2663055"/>
-                </a:lnTo>
-                <a:close/>
-                <a:lnTo>
-                  <a:pt x="819760" y="2658248"/>
-                </a:lnTo>
-                <a:close/>
-                <a:lnTo>
-                  <a:pt x="822725" y="2653433"/>
-                </a:lnTo>
-                <a:close/>
-                <a:lnTo>
-                  <a:pt x="825690" y="2648609"/>
-                </a:lnTo>
-                <a:close/>
-                <a:lnTo>
-                  <a:pt x="828659" y="2643772"/>
-                </a:lnTo>
-                <a:close/>
-                <a:lnTo>
-                  <a:pt x="831639" y="2638919"/>
-                </a:lnTo>
-                <a:close/>
-                <a:lnTo>
-                  <a:pt x="834633" y="2634047"/>
-                </a:lnTo>
-                <a:close/>
-                <a:lnTo>
-                  <a:pt x="837642" y="2629154"/>
-                </a:lnTo>
-                <a:close/>
-                <a:lnTo>
-                  <a:pt x="840665" y="2624243"/>
-                </a:lnTo>
-                <a:close/>
-                <a:lnTo>
-                  <a:pt x="843700" y="2619314"/>
-                </a:lnTo>
-                <a:close/>
-                <a:lnTo>
-                  <a:pt x="846743" y="2614367"/>
-                </a:lnTo>
-                <a:close/>
-                <a:lnTo>
-                  <a:pt x="849793" y="2609403"/>
-                </a:lnTo>
-                <a:close/>
-                <a:lnTo>
-                  <a:pt x="852848" y="2604424"/>
-                </a:lnTo>
-                <a:close/>
-                <a:lnTo>
-                  <a:pt x="855904" y="2599430"/>
-                </a:lnTo>
-                <a:close/>
-                <a:lnTo>
-                  <a:pt x="858961" y="2594422"/>
-                </a:lnTo>
-                <a:close/>
-                <a:lnTo>
-                  <a:pt x="862016" y="2589400"/>
-                </a:lnTo>
-                <a:close/>
-                <a:lnTo>
-                  <a:pt x="865066" y="2584363"/>
-                </a:lnTo>
-                <a:close/>
-                <a:lnTo>
-                  <a:pt x="868111" y="2579311"/>
-                </a:lnTo>
-                <a:close/>
-                <a:lnTo>
-                  <a:pt x="871147" y="2574243"/>
-                </a:lnTo>
-                <a:close/>
-                <a:lnTo>
-                  <a:pt x="874174" y="2569160"/>
-                </a:lnTo>
-                <a:close/>
-                <a:lnTo>
-                  <a:pt x="877189" y="2564060"/>
-                </a:lnTo>
-                <a:close/>
-                <a:lnTo>
-                  <a:pt x="880190" y="2558943"/>
-                </a:lnTo>
-                <a:close/>
-                <a:lnTo>
-                  <a:pt x="883177" y="2553810"/>
-                </a:lnTo>
-                <a:close/>
-                <a:lnTo>
-                  <a:pt x="886154" y="2548660"/>
-                </a:lnTo>
-                <a:close/>
-                <a:lnTo>
-                  <a:pt x="889124" y="2543495"/>
-                </a:lnTo>
-                <a:close/>
-                <a:lnTo>
-                  <a:pt x="892091" y="2538316"/>
-                </a:lnTo>
-                <a:close/>
-                <a:lnTo>
-                  <a:pt x="895059" y="2533123"/>
-                </a:lnTo>
-                <a:close/>
-                <a:lnTo>
-                  <a:pt x="898033" y="2527917"/>
-                </a:lnTo>
-                <a:close/>
-                <a:lnTo>
-                  <a:pt x="901016" y="2522700"/>
-                </a:lnTo>
-                <a:close/>
-                <a:lnTo>
-                  <a:pt x="904013" y="2517471"/>
-                </a:lnTo>
-                <a:close/>
-                <a:lnTo>
-                  <a:pt x="907024" y="2512230"/>
-                </a:lnTo>
-                <a:close/>
-                <a:lnTo>
-                  <a:pt x="910047" y="2506974"/>
-                </a:lnTo>
-                <a:close/>
-                <a:lnTo>
-                  <a:pt x="913081" y="2501700"/>
-                </a:lnTo>
-                <a:close/>
-                <a:lnTo>
-                  <a:pt x="916123" y="2496405"/>
-                </a:lnTo>
-                <a:close/>
-                <a:lnTo>
-                  <a:pt x="919172" y="2491086"/>
-                </a:lnTo>
-                <a:close/>
-                <a:lnTo>
-                  <a:pt x="922225" y="2485740"/>
-                </a:lnTo>
-                <a:close/>
-                <a:lnTo>
-                  <a:pt x="925281" y="2480364"/>
-                </a:lnTo>
-                <a:close/>
-                <a:lnTo>
-                  <a:pt x="928338" y="2474956"/>
-                </a:lnTo>
-                <a:close/>
-                <a:lnTo>
-                  <a:pt x="931394" y="2469518"/>
-                </a:lnTo>
-                <a:close/>
-                <a:lnTo>
-                  <a:pt x="934446" y="2464056"/>
-                </a:lnTo>
-                <a:close/>
-                <a:lnTo>
-                  <a:pt x="937491" y="2458575"/>
-                </a:lnTo>
-                <a:close/>
-                <a:lnTo>
-                  <a:pt x="940529" y="2453079"/>
-                </a:lnTo>
-                <a:close/>
-                <a:lnTo>
-                  <a:pt x="943556" y="2447574"/>
-                </a:lnTo>
-                <a:close/>
-                <a:lnTo>
-                  <a:pt x="946570" y="2442065"/>
-                </a:lnTo>
-                <a:close/>
-                <a:lnTo>
-                  <a:pt x="949569" y="2436557"/>
-                </a:lnTo>
-                <a:close/>
-                <a:lnTo>
-                  <a:pt x="952553" y="2431052"/>
-                </a:lnTo>
-                <a:close/>
-                <a:lnTo>
-                  <a:pt x="955525" y="2425546"/>
-                </a:lnTo>
-                <a:close/>
-                <a:lnTo>
-                  <a:pt x="958491" y="2420035"/>
-                </a:lnTo>
-                <a:close/>
-                <a:lnTo>
-                  <a:pt x="961455" y="2414513"/>
-                </a:lnTo>
-                <a:close/>
-                <a:lnTo>
-                  <a:pt x="964423" y="2408976"/>
-                </a:lnTo>
-                <a:close/>
-                <a:lnTo>
-                  <a:pt x="967400" y="2403417"/>
-                </a:lnTo>
-                <a:close/>
-                <a:lnTo>
-                  <a:pt x="970390" y="2397833"/>
-                </a:lnTo>
-                <a:close/>
-                <a:lnTo>
-                  <a:pt x="973398" y="2392218"/>
-                </a:lnTo>
-                <a:close/>
-                <a:lnTo>
-                  <a:pt x="976425" y="2386571"/>
-                </a:lnTo>
-                <a:close/>
-                <a:lnTo>
-                  <a:pt x="979465" y="2380895"/>
-                </a:lnTo>
-                <a:close/>
-                <a:lnTo>
-                  <a:pt x="982512" y="2375193"/>
-                </a:lnTo>
-                <a:close/>
-                <a:lnTo>
-                  <a:pt x="985562" y="2369468"/>
-                </a:lnTo>
-                <a:close/>
-                <a:lnTo>
-                  <a:pt x="988608" y="2363722"/>
-                </a:lnTo>
-                <a:close/>
-                <a:lnTo>
-                  <a:pt x="991645" y="2357960"/>
-                </a:lnTo>
-                <a:close/>
-                <a:lnTo>
-                  <a:pt x="994668" y="2352183"/>
-                </a:lnTo>
-                <a:close/>
-                <a:lnTo>
-                  <a:pt x="997672" y="2346395"/>
-                </a:lnTo>
-                <a:close/>
-                <a:lnTo>
-                  <a:pt x="1000658" y="2340596"/>
-                </a:lnTo>
-                <a:close/>
-                <a:lnTo>
-                  <a:pt x="1003632" y="2334785"/>
-                </a:lnTo>
-                <a:close/>
-                <a:lnTo>
-                  <a:pt x="1006599" y="2328960"/>
-                </a:lnTo>
-                <a:close/>
-                <a:lnTo>
-                  <a:pt x="1009563" y="2323122"/>
-                </a:lnTo>
-                <a:close/>
-                <a:lnTo>
-                  <a:pt x="1012530" y="2317268"/>
-                </a:lnTo>
-                <a:close/>
-                <a:lnTo>
-                  <a:pt x="1015504" y="2311399"/>
-                </a:lnTo>
-                <a:close/>
-                <a:lnTo>
-                  <a:pt x="1018491" y="2305512"/>
-                </a:lnTo>
-                <a:close/>
-                <a:lnTo>
-                  <a:pt x="1021494" y="2299608"/>
-                </a:lnTo>
-                <a:close/>
-                <a:lnTo>
-                  <a:pt x="1024512" y="2293688"/>
-                </a:lnTo>
-                <a:close/>
-                <a:lnTo>
-                  <a:pt x="1027542" y="2287751"/>
-                </a:lnTo>
-                <a:close/>
-                <a:lnTo>
-                  <a:pt x="1030582" y="2281799"/>
-                </a:lnTo>
-                <a:close/>
-                <a:lnTo>
-                  <a:pt x="1033629" y="2275832"/>
-                </a:lnTo>
-                <a:close/>
-                <a:lnTo>
-                  <a:pt x="1036682" y="2269852"/>
-                </a:lnTo>
-                <a:close/>
-                <a:lnTo>
-                  <a:pt x="1039738" y="2263860"/>
-                </a:lnTo>
-                <a:close/>
-                <a:lnTo>
-                  <a:pt x="1042795" y="2257855"/>
-                </a:lnTo>
-                <a:close/>
-                <a:lnTo>
-                  <a:pt x="1045851" y="2251838"/>
-                </a:lnTo>
-                <a:close/>
-                <a:lnTo>
-                  <a:pt x="1048903" y="2245807"/>
-                </a:lnTo>
-                <a:close/>
-                <a:lnTo>
-                  <a:pt x="1051951" y="2239758"/>
-                </a:lnTo>
-                <a:close/>
-                <a:lnTo>
-                  <a:pt x="1054991" y="2233690"/>
-                </a:lnTo>
-                <a:close/>
-                <a:lnTo>
-                  <a:pt x="1058022" y="2227599"/>
-                </a:lnTo>
-                <a:close/>
-                <a:lnTo>
-                  <a:pt x="1061043" y="2221484"/>
-                </a:lnTo>
-                <a:close/>
-                <a:lnTo>
-                  <a:pt x="1064050" y="2215342"/>
-                </a:lnTo>
-                <a:close/>
-                <a:lnTo>
-                  <a:pt x="1067043" y="2209171"/>
-                </a:lnTo>
-                <a:close/>
-                <a:lnTo>
-                  <a:pt x="1070024" y="2202972"/>
-                </a:lnTo>
-                <a:close/>
-                <a:lnTo>
-                  <a:pt x="1072996" y="2196748"/>
-                </a:lnTo>
-                <a:close/>
-                <a:lnTo>
-                  <a:pt x="1075964" y="2190502"/>
-                </a:lnTo>
-                <a:close/>
-                <a:lnTo>
-                  <a:pt x="1078931" y="2184236"/>
-                </a:lnTo>
-                <a:close/>
-                <a:lnTo>
-                  <a:pt x="1081902" y="2177954"/>
-                </a:lnTo>
-                <a:close/>
-                <a:lnTo>
-                  <a:pt x="1084881" y="2171658"/>
-                </a:lnTo>
-                <a:close/>
-                <a:lnTo>
-                  <a:pt x="1087871" y="2165352"/>
-                </a:lnTo>
-                <a:close/>
-                <a:lnTo>
-                  <a:pt x="1090876" y="2159037"/>
-                </a:lnTo>
-                <a:close/>
-                <a:lnTo>
-                  <a:pt x="1093894" y="2152710"/>
-                </a:lnTo>
-                <a:close/>
-                <a:lnTo>
-                  <a:pt x="1096923" y="2146370"/>
-                </a:lnTo>
-                <a:close/>
-                <a:lnTo>
-                  <a:pt x="1099962" y="2140012"/>
-                </a:lnTo>
-                <a:close/>
-                <a:lnTo>
-                  <a:pt x="1103008" y="2133634"/>
-                </a:lnTo>
-                <a:close/>
-                <a:lnTo>
-                  <a:pt x="1106060" y="2127233"/>
-                </a:lnTo>
-                <a:close/>
-                <a:lnTo>
-                  <a:pt x="1109115" y="2120806"/>
-                </a:lnTo>
-                <a:close/>
-                <a:lnTo>
-                  <a:pt x="1112172" y="2114349"/>
-                </a:lnTo>
-                <a:close/>
-                <a:lnTo>
-                  <a:pt x="1115228" y="2107864"/>
-                </a:lnTo>
-                <a:close/>
-                <a:lnTo>
-                  <a:pt x="1118282" y="2101351"/>
-                </a:lnTo>
-                <a:close/>
-                <a:lnTo>
-                  <a:pt x="1121331" y="2094815"/>
-                </a:lnTo>
-                <a:close/>
-                <a:lnTo>
-                  <a:pt x="1124372" y="2088258"/>
-                </a:lnTo>
-                <a:close/>
-                <a:lnTo>
-                  <a:pt x="1127404" y="2081683"/>
-                </a:lnTo>
-                <a:close/>
-                <a:lnTo>
-                  <a:pt x="1130424" y="2075094"/>
-                </a:lnTo>
-                <a:close/>
-                <a:lnTo>
-                  <a:pt x="1133430" y="2068493"/>
-                </a:lnTo>
-                <a:close/>
-                <a:lnTo>
-                  <a:pt x="1136420" y="2061882"/>
-                </a:lnTo>
-                <a:close/>
-                <a:lnTo>
-                  <a:pt x="1139396" y="2055262"/>
-                </a:lnTo>
-                <a:close/>
-                <a:lnTo>
-                  <a:pt x="1142364" y="2048629"/>
-                </a:lnTo>
-                <a:close/>
-                <a:lnTo>
-                  <a:pt x="1145329" y="2041980"/>
-                </a:lnTo>
-                <a:close/>
-                <a:lnTo>
-                  <a:pt x="1148295" y="2035312"/>
-                </a:lnTo>
-                <a:close/>
-                <a:lnTo>
-                  <a:pt x="1151267" y="2028622"/>
-                </a:lnTo>
-                <a:close/>
-                <a:lnTo>
-                  <a:pt x="1154250" y="2021907"/>
-                </a:lnTo>
-                <a:close/>
-                <a:lnTo>
-                  <a:pt x="1157250" y="2015165"/>
-                </a:lnTo>
-                <a:close/>
-                <a:lnTo>
-                  <a:pt x="1160270" y="2008392"/>
-                </a:lnTo>
-                <a:close/>
-                <a:lnTo>
-                  <a:pt x="1163305" y="2001592"/>
-                </a:lnTo>
-                <a:close/>
-                <a:lnTo>
-                  <a:pt x="1166349" y="1994767"/>
-                </a:lnTo>
-                <a:close/>
-                <a:lnTo>
-                  <a:pt x="1169399" y="1987920"/>
-                </a:lnTo>
-                <a:close/>
-                <a:lnTo>
-                  <a:pt x="1172447" y="1981054"/>
-                </a:lnTo>
-                <a:close/>
-                <a:lnTo>
-                  <a:pt x="1175489" y="1974171"/>
-                </a:lnTo>
-                <a:close/>
-                <a:lnTo>
-                  <a:pt x="1178519" y="1967275"/>
-                </a:lnTo>
-                <a:close/>
-                <a:lnTo>
-                  <a:pt x="1181531" y="1960368"/>
-                </a:lnTo>
-                <a:close/>
-                <a:lnTo>
-                  <a:pt x="1184524" y="1953451"/>
-                </a:lnTo>
-                <a:close/>
-                <a:lnTo>
-                  <a:pt x="1187503" y="1946522"/>
-                </a:lnTo>
-                <a:close/>
-                <a:lnTo>
-                  <a:pt x="1190472" y="1939579"/>
-                </a:lnTo>
-                <a:close/>
-                <a:lnTo>
-                  <a:pt x="1193437" y="1932619"/>
-                </a:lnTo>
-                <a:close/>
-                <a:lnTo>
-                  <a:pt x="1196402" y="1925640"/>
-                </a:lnTo>
-                <a:close/>
-                <a:lnTo>
-                  <a:pt x="1199373" y="1918639"/>
-                </a:lnTo>
-                <a:close/>
-                <a:lnTo>
-                  <a:pt x="1202354" y="1911615"/>
-                </a:lnTo>
-                <a:close/>
-                <a:lnTo>
-                  <a:pt x="1205350" y="1904564"/>
-                </a:lnTo>
-                <a:close/>
-                <a:lnTo>
-                  <a:pt x="1208361" y="1897487"/>
-                </a:lnTo>
-                <a:close/>
-                <a:lnTo>
-                  <a:pt x="1211386" y="1890383"/>
-                </a:lnTo>
-                <a:close/>
-                <a:lnTo>
-                  <a:pt x="1214421" y="1883254"/>
-                </a:lnTo>
-                <a:close/>
-                <a:lnTo>
-                  <a:pt x="1217466" y="1876101"/>
-                </a:lnTo>
-                <a:close/>
-                <a:lnTo>
-                  <a:pt x="1220517" y="1868923"/>
-                </a:lnTo>
-                <a:close/>
-                <a:lnTo>
-                  <a:pt x="1223572" y="1861721"/>
-                </a:lnTo>
-                <a:close/>
-                <a:lnTo>
-                  <a:pt x="1226628" y="1854496"/>
-                </a:lnTo>
-                <a:close/>
-                <a:lnTo>
-                  <a:pt x="1229685" y="1847249"/>
-                </a:lnTo>
-                <a:close/>
-                <a:lnTo>
-                  <a:pt x="1232739" y="1839979"/>
-                </a:lnTo>
-                <a:close/>
-                <a:lnTo>
-                  <a:pt x="1235789" y="1832687"/>
-                </a:lnTo>
-                <a:close/>
-                <a:lnTo>
-                  <a:pt x="1238833" y="1825372"/>
-                </a:lnTo>
-                <a:close/>
-                <a:lnTo>
-                  <a:pt x="1241868" y="1818035"/>
-                </a:lnTo>
-                <a:close/>
-                <a:lnTo>
-                  <a:pt x="1244893" y="1810675"/>
-                </a:lnTo>
-                <a:close/>
-                <a:lnTo>
-                  <a:pt x="1247907" y="1803292"/>
-                </a:lnTo>
-                <a:close/>
-                <a:lnTo>
-                  <a:pt x="1250906" y="1795887"/>
-                </a:lnTo>
-                <a:close/>
-                <a:lnTo>
-                  <a:pt x="1253892" y="1788459"/>
-                </a:lnTo>
-                <a:close/>
-                <a:lnTo>
-                  <a:pt x="1256867" y="1781007"/>
-                </a:lnTo>
-                <a:close/>
-                <a:lnTo>
-                  <a:pt x="1259836" y="1773532"/>
-                </a:lnTo>
-                <a:close/>
-                <a:lnTo>
-                  <a:pt x="1262803" y="1766033"/>
-                </a:lnTo>
-                <a:close/>
-                <a:lnTo>
-                  <a:pt x="1265772" y="1758509"/>
-                </a:lnTo>
-                <a:close/>
-                <a:lnTo>
-                  <a:pt x="1268747" y="1750959"/>
-                </a:lnTo>
-                <a:close/>
-                <a:lnTo>
-                  <a:pt x="1271732" y="1743384"/>
-                </a:lnTo>
-                <a:close/>
-                <a:lnTo>
-                  <a:pt x="1274730" y="1735782"/>
-                </a:lnTo>
-                <a:close/>
-                <a:lnTo>
-                  <a:pt x="1277743" y="1728156"/>
-                </a:lnTo>
-                <a:close/>
-                <a:lnTo>
-                  <a:pt x="1280767" y="1720506"/>
-                </a:lnTo>
-                <a:close/>
-                <a:lnTo>
-                  <a:pt x="1283802" y="1712835"/>
-                </a:lnTo>
-                <a:close/>
-                <a:lnTo>
-                  <a:pt x="1286845" y="1705145"/>
-                </a:lnTo>
-                <a:close/>
-                <a:lnTo>
-                  <a:pt x="1289895" y="1697437"/>
-                </a:lnTo>
-                <a:close/>
-                <a:lnTo>
-                  <a:pt x="1292949" y="1689715"/>
-                </a:lnTo>
-                <a:close/>
-                <a:lnTo>
-                  <a:pt x="1296005" y="1681979"/>
-                </a:lnTo>
-                <a:close/>
-                <a:lnTo>
-                  <a:pt x="1299062" y="1674231"/>
-                </a:lnTo>
-                <a:close/>
-                <a:lnTo>
-                  <a:pt x="1302117" y="1666471"/>
-                </a:lnTo>
-                <a:close/>
-                <a:lnTo>
-                  <a:pt x="1305168" y="1658697"/>
-                </a:lnTo>
-                <a:close/>
-                <a:lnTo>
-                  <a:pt x="1308213" y="1650908"/>
-                </a:lnTo>
-                <a:close/>
-                <a:lnTo>
-                  <a:pt x="1311250" y="1643102"/>
-                </a:lnTo>
-                <a:close/>
-                <a:lnTo>
-                  <a:pt x="1314275" y="1635278"/>
-                </a:lnTo>
-                <a:close/>
-                <a:lnTo>
-                  <a:pt x="1317287" y="1627434"/>
-                </a:lnTo>
-                <a:close/>
-                <a:lnTo>
-                  <a:pt x="1320284" y="1619569"/>
-                </a:lnTo>
-                <a:close/>
-                <a:lnTo>
-                  <a:pt x="1323266" y="1611681"/>
-                </a:lnTo>
-                <a:close/>
-                <a:lnTo>
-                  <a:pt x="1326237" y="1603769"/>
-                </a:lnTo>
-                <a:close/>
-                <a:lnTo>
-                  <a:pt x="1329203" y="1595829"/>
-                </a:lnTo>
-                <a:close/>
-                <a:lnTo>
-                  <a:pt x="1332167" y="1587859"/>
-                </a:lnTo>
-                <a:close/>
-                <a:lnTo>
-                  <a:pt x="1335136" y="1579857"/>
-                </a:lnTo>
-                <a:close/>
-                <a:lnTo>
-                  <a:pt x="1338114" y="1571821"/>
-                </a:lnTo>
-                <a:close/>
-                <a:lnTo>
-                  <a:pt x="1341106" y="1563747"/>
-                </a:lnTo>
-                <a:close/>
-                <a:lnTo>
-                  <a:pt x="1344117" y="1555635"/>
-                </a:lnTo>
-                <a:close/>
-                <a:lnTo>
-                  <a:pt x="1347146" y="1547485"/>
-                </a:lnTo>
-                <a:close/>
-                <a:lnTo>
-                  <a:pt x="1350187" y="1539303"/>
-                </a:lnTo>
-                <a:close/>
-                <a:lnTo>
-                  <a:pt x="1353235" y="1531093"/>
-                </a:lnTo>
-                <a:close/>
-                <a:lnTo>
-                  <a:pt x="1356285" y="1522860"/>
-                </a:lnTo>
-                <a:close/>
-                <a:lnTo>
-                  <a:pt x="1359330" y="1514609"/>
-                </a:lnTo>
-                <a:close/>
-                <a:lnTo>
-                  <a:pt x="1362366" y="1506345"/>
-                </a:lnTo>
-                <a:close/>
-                <a:lnTo>
-                  <a:pt x="1365386" y="1498073"/>
-                </a:lnTo>
-                <a:close/>
-                <a:lnTo>
-                  <a:pt x="1368387" y="1489796"/>
-                </a:lnTo>
-                <a:close/>
-                <a:lnTo>
-                  <a:pt x="1371372" y="1481512"/>
-                </a:lnTo>
-                <a:close/>
-                <a:lnTo>
-                  <a:pt x="1374345" y="1473215"/>
-                </a:lnTo>
-                <a:close/>
-                <a:lnTo>
-                  <a:pt x="1377311" y="1464901"/>
-                </a:lnTo>
-                <a:close/>
-                <a:lnTo>
-                  <a:pt x="1380275" y="1456565"/>
-                </a:lnTo>
-                <a:close/>
-                <a:lnTo>
-                  <a:pt x="1383243" y="1448201"/>
-                </a:lnTo>
-                <a:close/>
-                <a:lnTo>
-                  <a:pt x="1386219" y="1439805"/>
-                </a:lnTo>
-                <a:close/>
-                <a:lnTo>
-                  <a:pt x="1389208" y="1431373"/>
-                </a:lnTo>
-                <a:close/>
-                <a:lnTo>
-                  <a:pt x="1392213" y="1422900"/>
-                </a:lnTo>
-                <a:close/>
-                <a:lnTo>
-                  <a:pt x="1395232" y="1414390"/>
-                </a:lnTo>
-                <a:close/>
-                <a:lnTo>
-                  <a:pt x="1398263" y="1405845"/>
-                </a:lnTo>
-                <a:close/>
-                <a:lnTo>
-                  <a:pt x="1401304" y="1397269"/>
-                </a:lnTo>
-                <a:close/>
-                <a:lnTo>
-                  <a:pt x="1404352" y="1388663"/>
-                </a:lnTo>
-                <a:close/>
-                <a:lnTo>
-                  <a:pt x="1407406" y="1380031"/>
-                </a:lnTo>
-                <a:close/>
-                <a:lnTo>
-                  <a:pt x="1410462" y="1371376"/>
-                </a:lnTo>
-                <a:close/>
-                <a:lnTo>
-                  <a:pt x="1413519" y="1362700"/>
-                </a:lnTo>
-                <a:close/>
-                <a:lnTo>
-                  <a:pt x="1416574" y="1354004"/>
-                </a:lnTo>
-                <a:close/>
-                <a:lnTo>
-                  <a:pt x="1419626" y="1345289"/>
-                </a:lnTo>
-                <a:close/>
-                <a:lnTo>
-                  <a:pt x="1422673" y="1336554"/>
-                </a:lnTo>
-                <a:close/>
-                <a:lnTo>
-                  <a:pt x="1425712" y="1327798"/>
-                </a:lnTo>
-                <a:close/>
-                <a:lnTo>
-                  <a:pt x="1428742" y="1319022"/>
-                </a:lnTo>
-                <a:close/>
-                <a:lnTo>
-                  <a:pt x="1431761" y="1310226"/>
-                </a:lnTo>
-                <a:close/>
-                <a:lnTo>
-                  <a:pt x="1434767" y="1301409"/>
-                </a:lnTo>
-                <a:close/>
-                <a:lnTo>
-                  <a:pt x="1437758" y="1292571"/>
-                </a:lnTo>
-                <a:close/>
-                <a:lnTo>
-                  <a:pt x="1440737" y="1283710"/>
-                </a:lnTo>
-                <a:close/>
-                <a:lnTo>
-                  <a:pt x="1443708" y="1274824"/>
-                </a:lnTo>
-                <a:close/>
-                <a:lnTo>
-                  <a:pt x="1446676" y="1265912"/>
-                </a:lnTo>
-                <a:close/>
-                <a:lnTo>
-                  <a:pt x="1449644" y="1256971"/>
-                </a:lnTo>
-                <a:close/>
-                <a:lnTo>
-                  <a:pt x="1452615" y="1247999"/>
-                </a:lnTo>
-                <a:close/>
-                <a:lnTo>
-                  <a:pt x="1455595" y="1238995"/>
-                </a:lnTo>
-                <a:close/>
-                <a:lnTo>
-                  <a:pt x="1458587" y="1229956"/>
-                </a:lnTo>
-                <a:close/>
-                <a:lnTo>
-                  <a:pt x="1461594" y="1220882"/>
-                </a:lnTo>
-                <a:close/>
-                <a:lnTo>
-                  <a:pt x="1464613" y="1211774"/>
-                </a:lnTo>
-                <a:close/>
-                <a:lnTo>
-                  <a:pt x="1467644" y="1202634"/>
-                </a:lnTo>
-                <a:close/>
-                <a:lnTo>
-                  <a:pt x="1470684" y="1193465"/>
-                </a:lnTo>
-                <a:close/>
-                <a:lnTo>
-                  <a:pt x="1473731" y="1184268"/>
-                </a:lnTo>
-                <a:close/>
-                <a:lnTo>
-                  <a:pt x="1476783" y="1175046"/>
-                </a:lnTo>
-                <a:close/>
-                <a:lnTo>
-                  <a:pt x="1479839" y="1165800"/>
-                </a:lnTo>
-                <a:close/>
-                <a:lnTo>
-                  <a:pt x="1482896" y="1156533"/>
-                </a:lnTo>
-                <a:close/>
-                <a:lnTo>
-                  <a:pt x="1485952" y="1147245"/>
-                </a:lnTo>
-                <a:close/>
-                <a:lnTo>
-                  <a:pt x="1489005" y="1137937"/>
-                </a:lnTo>
-                <a:close/>
-                <a:lnTo>
-                  <a:pt x="1492053" y="1128608"/>
-                </a:lnTo>
-                <a:close/>
-                <a:lnTo>
-                  <a:pt x="1495093" y="1119257"/>
-                </a:lnTo>
-                <a:close/>
-                <a:lnTo>
-                  <a:pt x="1498124" y="1109886"/>
-                </a:lnTo>
-                <a:close/>
-                <a:lnTo>
-                  <a:pt x="1501142" y="1100493"/>
-                </a:lnTo>
-                <a:close/>
-                <a:lnTo>
-                  <a:pt x="1504146" y="1091079"/>
-                </a:lnTo>
-                <a:close/>
-                <a:lnTo>
-                  <a:pt x="1507134" y="1081643"/>
-                </a:lnTo>
-                <a:close/>
-                <a:lnTo>
-                  <a:pt x="1510109" y="1072184"/>
-                </a:lnTo>
-                <a:close/>
-                <a:lnTo>
-                  <a:pt x="1513077" y="1062701"/>
-                </a:lnTo>
-                <a:close/>
-                <a:lnTo>
-                  <a:pt x="1516041" y="1053193"/>
-                </a:lnTo>
-                <a:close/>
-                <a:lnTo>
-                  <a:pt x="1519007" y="1043657"/>
-                </a:lnTo>
-                <a:close/>
-                <a:lnTo>
-                  <a:pt x="1521981" y="1034093"/>
-                </a:lnTo>
-                <a:close/>
-                <a:lnTo>
-                  <a:pt x="1524966" y="1024499"/>
-                </a:lnTo>
-                <a:close/>
-                <a:lnTo>
-                  <a:pt x="1527968" y="1014873"/>
-                </a:lnTo>
-                <a:close/>
-                <a:lnTo>
-                  <a:pt x="1530990" y="1005215"/>
-                </a:lnTo>
-                <a:close/>
-                <a:lnTo>
-                  <a:pt x="1534026" y="995524"/>
-                </a:lnTo>
-                <a:close/>
-                <a:lnTo>
-                  <a:pt x="1537072" y="985800"/>
-                </a:lnTo>
-                <a:close/>
-                <a:lnTo>
-                  <a:pt x="1540122" y="976042"/>
-                </a:lnTo>
-                <a:close/>
-                <a:lnTo>
-                  <a:pt x="1543170" y="966252"/>
-                </a:lnTo>
-                <a:close/>
-                <a:lnTo>
-                  <a:pt x="1546210" y="956428"/>
-                </a:lnTo>
-                <a:close/>
-                <a:lnTo>
-                  <a:pt x="1549238" y="946570"/>
-                </a:lnTo>
-                <a:close/>
-                <a:lnTo>
-                  <a:pt x="1552248" y="936679"/>
-                </a:lnTo>
-                <a:close/>
-                <a:lnTo>
-                  <a:pt x="1555239" y="926754"/>
-                </a:lnTo>
-                <a:close/>
-                <a:lnTo>
-                  <a:pt x="1558216" y="916799"/>
-                </a:lnTo>
-                <a:close/>
-                <a:lnTo>
-                  <a:pt x="1561184" y="906815"/>
-                </a:lnTo>
-                <a:close/>
-                <a:lnTo>
-                  <a:pt x="1564149" y="896805"/>
-                </a:lnTo>
-                <a:close/>
-                <a:lnTo>
-                  <a:pt x="1567114" y="886770"/>
-                </a:lnTo>
-                <a:close/>
-                <a:lnTo>
-                  <a:pt x="1570086" y="876713"/>
-                </a:lnTo>
-                <a:close/>
-                <a:lnTo>
-                  <a:pt x="1573069" y="866635"/>
-                </a:lnTo>
-                <a:close/>
-                <a:lnTo>
-                  <a:pt x="1576067" y="856539"/>
-                </a:lnTo>
-                <a:close/>
-                <a:lnTo>
-                  <a:pt x="1579080" y="846423"/>
-                </a:lnTo>
-                <a:close/>
-                <a:lnTo>
-                  <a:pt x="1582106" y="836286"/>
-                </a:lnTo>
-                <a:close/>
-                <a:lnTo>
-                  <a:pt x="1585143" y="826124"/>
-                </a:lnTo>
-                <a:close/>
-                <a:lnTo>
-                  <a:pt x="1588189" y="815937"/>
-                </a:lnTo>
-                <a:close/>
-                <a:lnTo>
-                  <a:pt x="1591240" y="805721"/>
-                </a:lnTo>
-                <a:close/>
-                <a:lnTo>
-                  <a:pt x="1594295" y="795475"/>
-                </a:lnTo>
-                <a:close/>
-                <a:lnTo>
-                  <a:pt x="1597352" y="785196"/>
-                </a:lnTo>
-                <a:close/>
-                <a:lnTo>
-                  <a:pt x="1600409" y="774884"/>
-                </a:lnTo>
-                <a:close/>
-                <a:lnTo>
-                  <a:pt x="1603462" y="764537"/>
-                </a:lnTo>
-                <a:close/>
-                <a:lnTo>
-                  <a:pt x="1606512" y="754157"/>
-                </a:lnTo>
-                <a:close/>
-                <a:lnTo>
-                  <a:pt x="1609554" y="743744"/>
-                </a:lnTo>
-                <a:close/>
-                <a:lnTo>
-                  <a:pt x="1612589" y="733299"/>
-                </a:lnTo>
-                <a:close/>
-                <a:lnTo>
-                  <a:pt x="1615613" y="722822"/>
-                </a:lnTo>
-                <a:close/>
-                <a:lnTo>
-                  <a:pt x="1618624" y="712315"/>
-                </a:lnTo>
-                <a:close/>
-                <a:lnTo>
-                  <a:pt x="1621622" y="701777"/>
-                </a:lnTo>
-                <a:close/>
-                <a:lnTo>
-                  <a:pt x="1624605" y="691209"/>
-                </a:lnTo>
-                <a:close/>
-                <a:lnTo>
-                  <a:pt x="1627580" y="680611"/>
-                </a:lnTo>
-                <a:close/>
-                <a:lnTo>
-                  <a:pt x="1630549" y="669982"/>
-                </a:lnTo>
-                <a:close/>
-                <a:lnTo>
-                  <a:pt x="1633516" y="659323"/>
-                </a:lnTo>
-                <a:close/>
-                <a:lnTo>
-                  <a:pt x="1636485" y="648632"/>
-                </a:lnTo>
-                <a:close/>
-                <a:lnTo>
-                  <a:pt x="1639461" y="637911"/>
-                </a:lnTo>
-                <a:close/>
-                <a:lnTo>
-                  <a:pt x="1642447" y="627159"/>
-                </a:lnTo>
-                <a:close/>
-                <a:lnTo>
-                  <a:pt x="1645448" y="616376"/>
-                </a:lnTo>
-                <a:close/>
-                <a:lnTo>
-                  <a:pt x="1648462" y="605561"/>
-                </a:lnTo>
-                <a:close/>
-                <a:lnTo>
-                  <a:pt x="1651488" y="594716"/>
-                </a:lnTo>
-                <a:close/>
-                <a:lnTo>
-                  <a:pt x="1654524" y="583839"/>
-                </a:lnTo>
-                <a:close/>
-                <a:lnTo>
-                  <a:pt x="1657568" y="572931"/>
-                </a:lnTo>
-                <a:close/>
-                <a:lnTo>
-                  <a:pt x="1660618" y="561992"/>
-                </a:lnTo>
-                <a:close/>
-                <a:lnTo>
-                  <a:pt x="1663673" y="551022"/>
-                </a:lnTo>
-                <a:close/>
-                <a:lnTo>
-                  <a:pt x="1666729" y="540020"/>
-                </a:lnTo>
-                <a:close/>
-                <a:lnTo>
-                  <a:pt x="1669786" y="528988"/>
-                </a:lnTo>
-                <a:close/>
-                <a:lnTo>
-                  <a:pt x="1672841" y="517926"/>
-                </a:lnTo>
-                <a:close/>
-                <a:lnTo>
-                  <a:pt x="1675891" y="506832"/>
-                </a:lnTo>
-                <a:close/>
-                <a:lnTo>
-                  <a:pt x="1678935" y="495707"/>
-                </a:lnTo>
-                <a:close/>
-                <a:lnTo>
-                  <a:pt x="1681970" y="484551"/>
-                </a:lnTo>
-                <a:close/>
-                <a:lnTo>
-                  <a:pt x="1684994" y="473364"/>
-                </a:lnTo>
-                <a:close/>
-                <a:lnTo>
-                  <a:pt x="1688005" y="462146"/>
-                </a:lnTo>
-                <a:close/>
-                <a:lnTo>
-                  <a:pt x="1691000" y="450897"/>
-                </a:lnTo>
-                <a:close/>
-                <a:lnTo>
-                  <a:pt x="1693980" y="439617"/>
-                </a:lnTo>
-                <a:close/>
-                <a:lnTo>
-                  <a:pt x="1696950" y="428306"/>
-                </a:lnTo>
-                <a:close/>
-                <a:lnTo>
-                  <a:pt x="1699915" y="416964"/>
-                </a:lnTo>
-                <a:close/>
-                <a:lnTo>
-                  <a:pt x="1702880" y="405591"/>
-                </a:lnTo>
-                <a:close/>
-                <a:lnTo>
-                  <a:pt x="1705849" y="394187"/>
-                </a:lnTo>
-                <a:close/>
-                <a:lnTo>
-                  <a:pt x="1708829" y="382752"/>
-                </a:lnTo>
-                <a:close/>
-                <a:lnTo>
-                  <a:pt x="1711823" y="371286"/>
-                </a:lnTo>
-                <a:close/>
-                <a:lnTo>
-                  <a:pt x="1714837" y="359789"/>
-                </a:lnTo>
-                <a:close/>
-                <a:lnTo>
-                  <a:pt x="1717867" y="348261"/>
-                </a:lnTo>
-                <a:close/>
-                <a:lnTo>
-                  <a:pt x="1720910" y="336703"/>
-                </a:lnTo>
-                <a:close/>
-                <a:lnTo>
-                  <a:pt x="1723958" y="325113"/>
-                </a:lnTo>
-                <a:close/>
-                <a:lnTo>
-                  <a:pt x="1727007" y="313492"/>
-                </a:lnTo>
-                <a:close/>
-                <a:lnTo>
-                  <a:pt x="1730052" y="301840"/>
-                </a:lnTo>
-                <a:close/>
-                <a:lnTo>
-                  <a:pt x="1733086" y="290156"/>
-                </a:lnTo>
-                <a:close/>
-                <a:lnTo>
-                  <a:pt x="1736104" y="278441"/>
-                </a:lnTo>
-                <a:close/>
-                <a:lnTo>
-                  <a:pt x="1739103" y="266694"/>
-                </a:lnTo>
-                <a:close/>
-                <a:lnTo>
-                  <a:pt x="1742086" y="254917"/>
-                </a:lnTo>
-                <a:close/>
-                <a:lnTo>
-                  <a:pt x="1745057" y="243108"/>
-                </a:lnTo>
-                <a:close/>
-                <a:lnTo>
-                  <a:pt x="1748023" y="231269"/>
-                </a:lnTo>
-                <a:close/>
-                <a:lnTo>
-                  <a:pt x="1750988" y="219399"/>
-                </a:lnTo>
-                <a:close/>
-                <a:lnTo>
-                  <a:pt x="1753956" y="207500"/>
-                </a:lnTo>
-                <a:close/>
-                <a:lnTo>
-                  <a:pt x="1756933" y="195571"/>
-                </a:lnTo>
-                <a:close/>
-                <a:lnTo>
-                  <a:pt x="1759924" y="183613"/>
-                </a:lnTo>
-                <a:close/>
-                <a:lnTo>
-                  <a:pt x="1762931" y="171626"/>
-                </a:lnTo>
-                <a:close/>
-                <a:lnTo>
-                  <a:pt x="1765951" y="159608"/>
-                </a:lnTo>
-                <a:close/>
-                <a:lnTo>
-                  <a:pt x="1768983" y="147558"/>
-                </a:lnTo>
-                <a:close/>
-                <a:lnTo>
-                  <a:pt x="1772025" y="135475"/>
-                </a:lnTo>
-                <a:close/>
-                <a:lnTo>
-                  <a:pt x="1775074" y="123357"/>
-                </a:lnTo>
-                <a:close/>
-                <a:lnTo>
-                  <a:pt x="1778128" y="111204"/>
-                </a:lnTo>
-                <a:close/>
-                <a:lnTo>
-                  <a:pt x="1781186" y="99013"/>
-                </a:lnTo>
-                <a:close/>
-                <a:lnTo>
-                  <a:pt x="1784243" y="86784"/>
-                </a:lnTo>
-                <a:close/>
-                <a:lnTo>
-                  <a:pt x="1787300" y="74516"/>
-                </a:lnTo>
-                <a:close/>
-                <a:lnTo>
-                  <a:pt x="1790352" y="62206"/>
-                </a:lnTo>
-                <a:close/>
-                <a:lnTo>
-                  <a:pt x="1793399" y="49854"/>
-                </a:lnTo>
-                <a:close/>
-                <a:lnTo>
-                  <a:pt x="1796438" y="37459"/>
-                </a:lnTo>
-                <a:close/>
-                <a:lnTo>
-                  <a:pt x="1799466" y="25019"/>
-                </a:lnTo>
-                <a:close/>
-                <a:lnTo>
-                  <a:pt x="1802482" y="12533"/>
-                </a:lnTo>
-                <a:close/>
-                <a:lnTo>
-                  <a:pt x="1805483" y="0"/>
+                  <a:pt x="2504" y="2635205"/>
+                </a:lnTo>
+                <a:close/>
+                <a:lnTo>
+                  <a:pt x="5007" y="2636760"/>
+                </a:lnTo>
+                <a:close/>
+                <a:lnTo>
+                  <a:pt x="7511" y="2638150"/>
+                </a:lnTo>
+                <a:close/>
+                <a:lnTo>
+                  <a:pt x="10014" y="2639391"/>
+                </a:lnTo>
+                <a:close/>
+                <a:lnTo>
+                  <a:pt x="12518" y="2640497"/>
+                </a:lnTo>
+                <a:close/>
+                <a:lnTo>
+                  <a:pt x="15021" y="2641484"/>
+                </a:lnTo>
+                <a:close/>
+                <a:lnTo>
+                  <a:pt x="17525" y="2642366"/>
+                </a:lnTo>
+                <a:close/>
+                <a:lnTo>
+                  <a:pt x="20028" y="2643157"/>
+                </a:lnTo>
+                <a:close/>
+                <a:lnTo>
+                  <a:pt x="22532" y="2643874"/>
+                </a:lnTo>
+                <a:close/>
+                <a:lnTo>
+                  <a:pt x="25035" y="2644529"/>
+                </a:lnTo>
+                <a:close/>
+                <a:lnTo>
+                  <a:pt x="27539" y="2645139"/>
+                </a:lnTo>
+                <a:close/>
+                <a:lnTo>
+                  <a:pt x="30042" y="2645717"/>
+                </a:lnTo>
+                <a:close/>
+                <a:lnTo>
+                  <a:pt x="32546" y="2646280"/>
+                </a:lnTo>
+                <a:close/>
+                <a:lnTo>
+                  <a:pt x="35049" y="2646840"/>
+                </a:lnTo>
+                <a:close/>
+                <a:lnTo>
+                  <a:pt x="37553" y="2647414"/>
+                </a:lnTo>
+                <a:close/>
+                <a:lnTo>
+                  <a:pt x="40057" y="2648008"/>
+                </a:lnTo>
+                <a:close/>
+                <a:lnTo>
+                  <a:pt x="42560" y="2648620"/>
+                </a:lnTo>
+                <a:close/>
+                <a:lnTo>
+                  <a:pt x="45064" y="2649245"/>
+                </a:lnTo>
+                <a:close/>
+                <a:lnTo>
+                  <a:pt x="47567" y="2649881"/>
+                </a:lnTo>
+                <a:close/>
+                <a:lnTo>
+                  <a:pt x="50071" y="2650523"/>
+                </a:lnTo>
+                <a:close/>
+                <a:lnTo>
+                  <a:pt x="52574" y="2651169"/>
+                </a:lnTo>
+                <a:close/>
+                <a:lnTo>
+                  <a:pt x="55078" y="2651815"/>
+                </a:lnTo>
+                <a:close/>
+                <a:lnTo>
+                  <a:pt x="57581" y="2652458"/>
+                </a:lnTo>
+                <a:close/>
+                <a:lnTo>
+                  <a:pt x="60085" y="2653096"/>
+                </a:lnTo>
+                <a:close/>
+                <a:lnTo>
+                  <a:pt x="62588" y="2653730"/>
+                </a:lnTo>
+                <a:close/>
+                <a:lnTo>
+                  <a:pt x="65092" y="2654358"/>
+                </a:lnTo>
+                <a:close/>
+                <a:lnTo>
+                  <a:pt x="67595" y="2654979"/>
+                </a:lnTo>
+                <a:close/>
+                <a:lnTo>
+                  <a:pt x="70099" y="2655594"/>
+                </a:lnTo>
+                <a:close/>
+                <a:lnTo>
+                  <a:pt x="72602" y="2656200"/>
+                </a:lnTo>
+                <a:close/>
+                <a:lnTo>
+                  <a:pt x="75106" y="2656798"/>
+                </a:lnTo>
+                <a:close/>
+                <a:lnTo>
+                  <a:pt x="77610" y="2657393"/>
+                </a:lnTo>
+                <a:close/>
+                <a:lnTo>
+                  <a:pt x="80113" y="2657990"/>
+                </a:lnTo>
+                <a:close/>
+                <a:lnTo>
+                  <a:pt x="82617" y="2658597"/>
+                </a:lnTo>
+                <a:close/>
+                <a:lnTo>
+                  <a:pt x="85120" y="2659219"/>
+                </a:lnTo>
+                <a:close/>
+                <a:lnTo>
+                  <a:pt x="87624" y="2659864"/>
+                </a:lnTo>
+                <a:close/>
+                <a:lnTo>
+                  <a:pt x="90127" y="2660537"/>
+                </a:lnTo>
+                <a:close/>
+                <a:lnTo>
+                  <a:pt x="92631" y="2661245"/>
+                </a:lnTo>
+                <a:close/>
+                <a:lnTo>
+                  <a:pt x="95134" y="2661979"/>
+                </a:lnTo>
+                <a:close/>
+                <a:lnTo>
+                  <a:pt x="97638" y="2662714"/>
+                </a:lnTo>
+                <a:close/>
+                <a:lnTo>
+                  <a:pt x="100141" y="2663425"/>
+                </a:lnTo>
+                <a:close/>
+                <a:lnTo>
+                  <a:pt x="102645" y="2664087"/>
+                </a:lnTo>
+                <a:close/>
+                <a:lnTo>
+                  <a:pt x="105148" y="2664675"/>
+                </a:lnTo>
+                <a:close/>
+                <a:lnTo>
+                  <a:pt x="107652" y="2665164"/>
+                </a:lnTo>
+                <a:close/>
+                <a:lnTo>
+                  <a:pt x="110155" y="2665528"/>
+                </a:lnTo>
+                <a:close/>
+                <a:lnTo>
+                  <a:pt x="112659" y="2665756"/>
+                </a:lnTo>
+                <a:close/>
+                <a:lnTo>
+                  <a:pt x="115162" y="2665866"/>
+                </a:lnTo>
+                <a:close/>
+                <a:lnTo>
+                  <a:pt x="117666" y="2665882"/>
+                </a:lnTo>
+                <a:close/>
+                <a:lnTo>
+                  <a:pt x="120170" y="2665829"/>
+                </a:lnTo>
+                <a:close/>
+                <a:lnTo>
+                  <a:pt x="122673" y="2665730"/>
+                </a:lnTo>
+                <a:close/>
+                <a:lnTo>
+                  <a:pt x="125177" y="2665609"/>
+                </a:lnTo>
+                <a:close/>
+                <a:lnTo>
+                  <a:pt x="127680" y="2665490"/>
+                </a:lnTo>
+                <a:close/>
+                <a:lnTo>
+                  <a:pt x="130184" y="2665395"/>
+                </a:lnTo>
+                <a:close/>
+                <a:lnTo>
+                  <a:pt x="132687" y="2665329"/>
+                </a:lnTo>
+                <a:close/>
+                <a:lnTo>
+                  <a:pt x="135191" y="2665292"/>
+                </a:lnTo>
+                <a:close/>
+                <a:lnTo>
+                  <a:pt x="137694" y="2665285"/>
+                </a:lnTo>
+                <a:close/>
+                <a:lnTo>
+                  <a:pt x="140198" y="2665305"/>
+                </a:lnTo>
+                <a:close/>
+                <a:lnTo>
+                  <a:pt x="142701" y="2665355"/>
+                </a:lnTo>
+                <a:close/>
+                <a:lnTo>
+                  <a:pt x="145205" y="2665433"/>
+                </a:lnTo>
+                <a:close/>
+                <a:lnTo>
+                  <a:pt x="147708" y="2665538"/>
+                </a:lnTo>
+                <a:close/>
+                <a:lnTo>
+                  <a:pt x="150212" y="2665659"/>
+                </a:lnTo>
+                <a:close/>
+                <a:lnTo>
+                  <a:pt x="152715" y="2665771"/>
+                </a:lnTo>
+                <a:close/>
+                <a:lnTo>
+                  <a:pt x="155219" y="2665852"/>
+                </a:lnTo>
+                <a:close/>
+                <a:lnTo>
+                  <a:pt x="157723" y="2665878"/>
+                </a:lnTo>
+                <a:close/>
+                <a:lnTo>
+                  <a:pt x="160226" y="2665825"/>
+                </a:lnTo>
+                <a:close/>
+                <a:lnTo>
+                  <a:pt x="162730" y="2665671"/>
+                </a:lnTo>
+                <a:close/>
+                <a:lnTo>
+                  <a:pt x="165233" y="2665391"/>
+                </a:lnTo>
+                <a:close/>
+                <a:lnTo>
+                  <a:pt x="167737" y="2664978"/>
+                </a:lnTo>
+                <a:close/>
+                <a:lnTo>
+                  <a:pt x="170240" y="2664452"/>
+                </a:lnTo>
+                <a:close/>
+                <a:lnTo>
+                  <a:pt x="172744" y="2663835"/>
+                </a:lnTo>
+                <a:close/>
+                <a:lnTo>
+                  <a:pt x="175247" y="2663153"/>
+                </a:lnTo>
+                <a:close/>
+                <a:lnTo>
+                  <a:pt x="177751" y="2662427"/>
+                </a:lnTo>
+                <a:close/>
+                <a:lnTo>
+                  <a:pt x="180254" y="2661681"/>
+                </a:lnTo>
+                <a:close/>
+                <a:lnTo>
+                  <a:pt x="182758" y="2660940"/>
+                </a:lnTo>
+                <a:close/>
+                <a:lnTo>
+                  <a:pt x="185261" y="2660222"/>
+                </a:lnTo>
+                <a:close/>
+                <a:lnTo>
+                  <a:pt x="187765" y="2659532"/>
+                </a:lnTo>
+                <a:close/>
+                <a:lnTo>
+                  <a:pt x="190268" y="2658871"/>
+                </a:lnTo>
+                <a:close/>
+                <a:lnTo>
+                  <a:pt x="192772" y="2658239"/>
+                </a:lnTo>
+                <a:close/>
+                <a:lnTo>
+                  <a:pt x="195276" y="2657636"/>
+                </a:lnTo>
+                <a:close/>
+                <a:lnTo>
+                  <a:pt x="197779" y="2657062"/>
+                </a:lnTo>
+                <a:close/>
+                <a:lnTo>
+                  <a:pt x="200283" y="2656518"/>
+                </a:lnTo>
+                <a:close/>
+                <a:lnTo>
+                  <a:pt x="202786" y="2656001"/>
+                </a:lnTo>
+                <a:close/>
+                <a:lnTo>
+                  <a:pt x="205290" y="2655499"/>
+                </a:lnTo>
+                <a:close/>
+                <a:lnTo>
+                  <a:pt x="207793" y="2654987"/>
+                </a:lnTo>
+                <a:close/>
+                <a:lnTo>
+                  <a:pt x="210297" y="2654440"/>
+                </a:lnTo>
+                <a:close/>
+                <a:lnTo>
+                  <a:pt x="212800" y="2653835"/>
+                </a:lnTo>
+                <a:close/>
+                <a:lnTo>
+                  <a:pt x="215304" y="2653147"/>
+                </a:lnTo>
+                <a:close/>
+                <a:lnTo>
+                  <a:pt x="217807" y="2652353"/>
+                </a:lnTo>
+                <a:close/>
+                <a:lnTo>
+                  <a:pt x="220311" y="2651428"/>
+                </a:lnTo>
+                <a:close/>
+                <a:lnTo>
+                  <a:pt x="222814" y="2650368"/>
+                </a:lnTo>
+                <a:close/>
+                <a:lnTo>
+                  <a:pt x="225318" y="2649196"/>
+                </a:lnTo>
+                <a:close/>
+                <a:lnTo>
+                  <a:pt x="227821" y="2647939"/>
+                </a:lnTo>
+                <a:close/>
+                <a:lnTo>
+                  <a:pt x="230325" y="2646621"/>
+                </a:lnTo>
+                <a:close/>
+                <a:lnTo>
+                  <a:pt x="232829" y="2645269"/>
+                </a:lnTo>
+                <a:close/>
+                <a:lnTo>
+                  <a:pt x="235332" y="2643909"/>
+                </a:lnTo>
+                <a:close/>
+                <a:lnTo>
+                  <a:pt x="237836" y="2642568"/>
+                </a:lnTo>
+                <a:close/>
+                <a:lnTo>
+                  <a:pt x="240339" y="2641263"/>
+                </a:lnTo>
+                <a:close/>
+                <a:lnTo>
+                  <a:pt x="242843" y="2639991"/>
+                </a:lnTo>
+                <a:close/>
+                <a:lnTo>
+                  <a:pt x="245346" y="2638744"/>
+                </a:lnTo>
+                <a:close/>
+                <a:lnTo>
+                  <a:pt x="247850" y="2637511"/>
+                </a:lnTo>
+                <a:close/>
+                <a:lnTo>
+                  <a:pt x="250353" y="2636284"/>
+                </a:lnTo>
+                <a:close/>
+                <a:lnTo>
+                  <a:pt x="252857" y="2635053"/>
+                </a:lnTo>
+                <a:close/>
+                <a:lnTo>
+                  <a:pt x="255360" y="2633809"/>
+                </a:lnTo>
+                <a:close/>
+                <a:lnTo>
+                  <a:pt x="257864" y="2632544"/>
+                </a:lnTo>
+                <a:close/>
+                <a:lnTo>
+                  <a:pt x="260367" y="2631263"/>
+                </a:lnTo>
+                <a:close/>
+                <a:lnTo>
+                  <a:pt x="262871" y="2629976"/>
+                </a:lnTo>
+                <a:close/>
+                <a:lnTo>
+                  <a:pt x="265374" y="2628694"/>
+                </a:lnTo>
+                <a:close/>
+                <a:lnTo>
+                  <a:pt x="267878" y="2627429"/>
+                </a:lnTo>
+                <a:close/>
+                <a:lnTo>
+                  <a:pt x="270382" y="2626192"/>
+                </a:lnTo>
+                <a:close/>
+                <a:lnTo>
+                  <a:pt x="272885" y="2624993"/>
+                </a:lnTo>
+                <a:close/>
+                <a:lnTo>
+                  <a:pt x="275389" y="2623844"/>
+                </a:lnTo>
+                <a:close/>
+                <a:lnTo>
+                  <a:pt x="277892" y="2622734"/>
+                </a:lnTo>
+                <a:close/>
+                <a:lnTo>
+                  <a:pt x="280396" y="2621630"/>
+                </a:lnTo>
+                <a:close/>
+                <a:lnTo>
+                  <a:pt x="282899" y="2620498"/>
+                </a:lnTo>
+                <a:close/>
+                <a:lnTo>
+                  <a:pt x="285403" y="2619301"/>
+                </a:lnTo>
+                <a:close/>
+                <a:lnTo>
+                  <a:pt x="287906" y="2618006"/>
+                </a:lnTo>
+                <a:close/>
+                <a:lnTo>
+                  <a:pt x="290410" y="2616577"/>
+                </a:lnTo>
+                <a:close/>
+                <a:lnTo>
+                  <a:pt x="292913" y="2614979"/>
+                </a:lnTo>
+                <a:close/>
+                <a:lnTo>
+                  <a:pt x="295417" y="2613199"/>
+                </a:lnTo>
+                <a:close/>
+                <a:lnTo>
+                  <a:pt x="297920" y="2611285"/>
+                </a:lnTo>
+                <a:close/>
+                <a:lnTo>
+                  <a:pt x="300424" y="2609296"/>
+                </a:lnTo>
+                <a:close/>
+                <a:lnTo>
+                  <a:pt x="302927" y="2607290"/>
+                </a:lnTo>
+                <a:close/>
+                <a:lnTo>
+                  <a:pt x="305431" y="2605326"/>
+                </a:lnTo>
+                <a:close/>
+                <a:lnTo>
+                  <a:pt x="307935" y="2603463"/>
+                </a:lnTo>
+                <a:close/>
+                <a:lnTo>
+                  <a:pt x="310438" y="2601758"/>
+                </a:lnTo>
+                <a:close/>
+                <a:lnTo>
+                  <a:pt x="312942" y="2600260"/>
+                </a:lnTo>
+                <a:close/>
+                <a:lnTo>
+                  <a:pt x="315445" y="2598943"/>
+                </a:lnTo>
+                <a:close/>
+                <a:lnTo>
+                  <a:pt x="317949" y="2597748"/>
+                </a:lnTo>
+                <a:close/>
+                <a:lnTo>
+                  <a:pt x="320452" y="2596616"/>
+                </a:lnTo>
+                <a:close/>
+                <a:lnTo>
+                  <a:pt x="322956" y="2595488"/>
+                </a:lnTo>
+                <a:close/>
+                <a:lnTo>
+                  <a:pt x="325459" y="2594307"/>
+                </a:lnTo>
+                <a:close/>
+                <a:lnTo>
+                  <a:pt x="327963" y="2593014"/>
+                </a:lnTo>
+                <a:close/>
+                <a:lnTo>
+                  <a:pt x="330466" y="2591551"/>
+                </a:lnTo>
+                <a:close/>
+                <a:lnTo>
+                  <a:pt x="332970" y="2589908"/>
+                </a:lnTo>
+                <a:close/>
+                <a:lnTo>
+                  <a:pt x="335473" y="2588119"/>
+                </a:lnTo>
+                <a:close/>
+                <a:lnTo>
+                  <a:pt x="337977" y="2586218"/>
+                </a:lnTo>
+                <a:close/>
+                <a:lnTo>
+                  <a:pt x="340480" y="2584241"/>
+                </a:lnTo>
+                <a:close/>
+                <a:lnTo>
+                  <a:pt x="342984" y="2582221"/>
+                </a:lnTo>
+                <a:close/>
+                <a:lnTo>
+                  <a:pt x="345487" y="2580195"/>
+                </a:lnTo>
+                <a:close/>
+                <a:lnTo>
+                  <a:pt x="347991" y="2578198"/>
+                </a:lnTo>
+                <a:close/>
+                <a:lnTo>
+                  <a:pt x="350495" y="2576250"/>
+                </a:lnTo>
+                <a:close/>
+                <a:lnTo>
+                  <a:pt x="352998" y="2574346"/>
+                </a:lnTo>
+                <a:close/>
+                <a:lnTo>
+                  <a:pt x="355502" y="2572472"/>
+                </a:lnTo>
+                <a:close/>
+                <a:lnTo>
+                  <a:pt x="358005" y="2570620"/>
+                </a:lnTo>
+                <a:close/>
+                <a:lnTo>
+                  <a:pt x="360509" y="2568777"/>
+                </a:lnTo>
+                <a:close/>
+                <a:lnTo>
+                  <a:pt x="363012" y="2566932"/>
+                </a:lnTo>
+                <a:close/>
+                <a:lnTo>
+                  <a:pt x="365516" y="2565074"/>
+                </a:lnTo>
+                <a:close/>
+                <a:lnTo>
+                  <a:pt x="368019" y="2563195"/>
+                </a:lnTo>
+                <a:close/>
+                <a:lnTo>
+                  <a:pt x="370523" y="2561300"/>
+                </a:lnTo>
+                <a:close/>
+                <a:lnTo>
+                  <a:pt x="373026" y="2559398"/>
+                </a:lnTo>
+                <a:close/>
+                <a:lnTo>
+                  <a:pt x="375530" y="2557498"/>
+                </a:lnTo>
+                <a:close/>
+                <a:lnTo>
+                  <a:pt x="378033" y="2555609"/>
+                </a:lnTo>
+                <a:close/>
+                <a:lnTo>
+                  <a:pt x="380537" y="2553742"/>
+                </a:lnTo>
+                <a:close/>
+                <a:lnTo>
+                  <a:pt x="383040" y="2551905"/>
+                </a:lnTo>
+                <a:close/>
+                <a:lnTo>
+                  <a:pt x="385544" y="2550106"/>
+                </a:lnTo>
+                <a:close/>
+                <a:lnTo>
+                  <a:pt x="388048" y="2548335"/>
+                </a:lnTo>
+                <a:close/>
+                <a:lnTo>
+                  <a:pt x="390551" y="2546565"/>
+                </a:lnTo>
+                <a:close/>
+                <a:lnTo>
+                  <a:pt x="393055" y="2544770"/>
+                </a:lnTo>
+                <a:close/>
+                <a:lnTo>
+                  <a:pt x="395558" y="2542924"/>
+                </a:lnTo>
+                <a:close/>
+                <a:lnTo>
+                  <a:pt x="398062" y="2541000"/>
+                </a:lnTo>
+                <a:close/>
+                <a:lnTo>
+                  <a:pt x="400565" y="2538972"/>
+                </a:lnTo>
+                <a:close/>
+                <a:lnTo>
+                  <a:pt x="403069" y="2536813"/>
+                </a:lnTo>
+                <a:close/>
+                <a:lnTo>
+                  <a:pt x="405572" y="2534516"/>
+                </a:lnTo>
+                <a:close/>
+                <a:lnTo>
+                  <a:pt x="408076" y="2532104"/>
+                </a:lnTo>
+                <a:close/>
+                <a:lnTo>
+                  <a:pt x="410579" y="2529601"/>
+                </a:lnTo>
+                <a:close/>
+                <a:lnTo>
+                  <a:pt x="413083" y="2527034"/>
+                </a:lnTo>
+                <a:close/>
+                <a:lnTo>
+                  <a:pt x="415586" y="2524428"/>
+                </a:lnTo>
+                <a:close/>
+                <a:lnTo>
+                  <a:pt x="418090" y="2521809"/>
+                </a:lnTo>
+                <a:close/>
+                <a:lnTo>
+                  <a:pt x="420593" y="2519204"/>
+                </a:lnTo>
+                <a:close/>
+                <a:lnTo>
+                  <a:pt x="423097" y="2516631"/>
+                </a:lnTo>
+                <a:close/>
+                <a:lnTo>
+                  <a:pt x="425601" y="2514092"/>
+                </a:lnTo>
+                <a:close/>
+                <a:lnTo>
+                  <a:pt x="428104" y="2511579"/>
+                </a:lnTo>
+                <a:close/>
+                <a:lnTo>
+                  <a:pt x="430608" y="2509087"/>
+                </a:lnTo>
+                <a:close/>
+                <a:lnTo>
+                  <a:pt x="433111" y="2506608"/>
+                </a:lnTo>
+                <a:close/>
+                <a:lnTo>
+                  <a:pt x="435615" y="2504137"/>
+                </a:lnTo>
+                <a:close/>
+                <a:lnTo>
+                  <a:pt x="438118" y="2501668"/>
+                </a:lnTo>
+                <a:close/>
+                <a:lnTo>
+                  <a:pt x="440622" y="2499194"/>
+                </a:lnTo>
+                <a:close/>
+                <a:lnTo>
+                  <a:pt x="443125" y="2496712"/>
+                </a:lnTo>
+                <a:close/>
+                <a:lnTo>
+                  <a:pt x="445629" y="2494223"/>
+                </a:lnTo>
+                <a:close/>
+                <a:lnTo>
+                  <a:pt x="448132" y="2491725"/>
+                </a:lnTo>
+                <a:close/>
+                <a:lnTo>
+                  <a:pt x="450636" y="2489218"/>
+                </a:lnTo>
+                <a:close/>
+                <a:lnTo>
+                  <a:pt x="453139" y="2486701"/>
+                </a:lnTo>
+                <a:close/>
+                <a:lnTo>
+                  <a:pt x="455643" y="2484173"/>
+                </a:lnTo>
+                <a:close/>
+                <a:lnTo>
+                  <a:pt x="458146" y="2481635"/>
+                </a:lnTo>
+                <a:close/>
+                <a:lnTo>
+                  <a:pt x="460650" y="2479089"/>
+                </a:lnTo>
+                <a:close/>
+                <a:lnTo>
+                  <a:pt x="463154" y="2476544"/>
+                </a:lnTo>
+                <a:close/>
+                <a:lnTo>
+                  <a:pt x="465657" y="2474008"/>
+                </a:lnTo>
+                <a:close/>
+                <a:lnTo>
+                  <a:pt x="468161" y="2471490"/>
+                </a:lnTo>
+                <a:close/>
+                <a:lnTo>
+                  <a:pt x="470664" y="2468999"/>
+                </a:lnTo>
+                <a:close/>
+                <a:lnTo>
+                  <a:pt x="473168" y="2466544"/>
+                </a:lnTo>
+                <a:close/>
+                <a:lnTo>
+                  <a:pt x="475671" y="2464133"/>
+                </a:lnTo>
+                <a:close/>
+                <a:lnTo>
+                  <a:pt x="478175" y="2461767"/>
+                </a:lnTo>
+                <a:close/>
+                <a:lnTo>
+                  <a:pt x="480678" y="2459416"/>
+                </a:lnTo>
+                <a:close/>
+                <a:lnTo>
+                  <a:pt x="483182" y="2457046"/>
+                </a:lnTo>
+                <a:close/>
+                <a:lnTo>
+                  <a:pt x="485685" y="2454623"/>
+                </a:lnTo>
+                <a:close/>
+                <a:lnTo>
+                  <a:pt x="488189" y="2452113"/>
+                </a:lnTo>
+                <a:close/>
+                <a:lnTo>
+                  <a:pt x="490692" y="2449481"/>
+                </a:lnTo>
+                <a:close/>
+                <a:lnTo>
+                  <a:pt x="493196" y="2446692"/>
+                </a:lnTo>
+                <a:close/>
+                <a:lnTo>
+                  <a:pt x="495699" y="2443720"/>
+                </a:lnTo>
+                <a:close/>
+                <a:lnTo>
+                  <a:pt x="498203" y="2440594"/>
+                </a:lnTo>
+                <a:close/>
+                <a:lnTo>
+                  <a:pt x="500707" y="2437373"/>
+                </a:lnTo>
+                <a:close/>
+                <a:lnTo>
+                  <a:pt x="503210" y="2434115"/>
+                </a:lnTo>
+                <a:close/>
+                <a:lnTo>
+                  <a:pt x="505714" y="2430878"/>
+                </a:lnTo>
+                <a:close/>
+                <a:lnTo>
+                  <a:pt x="508217" y="2427721"/>
+                </a:lnTo>
+                <a:close/>
+                <a:lnTo>
+                  <a:pt x="510721" y="2424702"/>
+                </a:lnTo>
+                <a:close/>
+                <a:lnTo>
+                  <a:pt x="513224" y="2421878"/>
+                </a:lnTo>
+                <a:close/>
+                <a:lnTo>
+                  <a:pt x="515728" y="2419252"/>
+                </a:lnTo>
+                <a:close/>
+                <a:lnTo>
+                  <a:pt x="518231" y="2416768"/>
+                </a:lnTo>
+                <a:close/>
+                <a:lnTo>
+                  <a:pt x="520735" y="2414368"/>
+                </a:lnTo>
+                <a:close/>
+                <a:lnTo>
+                  <a:pt x="523238" y="2411994"/>
+                </a:lnTo>
+                <a:close/>
+                <a:lnTo>
+                  <a:pt x="525742" y="2409587"/>
+                </a:lnTo>
+                <a:close/>
+                <a:lnTo>
+                  <a:pt x="528245" y="2407088"/>
+                </a:lnTo>
+                <a:close/>
+                <a:lnTo>
+                  <a:pt x="530749" y="2404440"/>
+                </a:lnTo>
+                <a:close/>
+                <a:lnTo>
+                  <a:pt x="533252" y="2401607"/>
+                </a:lnTo>
+                <a:close/>
+                <a:lnTo>
+                  <a:pt x="535756" y="2398616"/>
+                </a:lnTo>
+                <a:close/>
+                <a:lnTo>
+                  <a:pt x="538259" y="2395501"/>
+                </a:lnTo>
+                <a:close/>
+                <a:lnTo>
+                  <a:pt x="540763" y="2392295"/>
+                </a:lnTo>
+                <a:close/>
+                <a:lnTo>
+                  <a:pt x="543267" y="2389035"/>
+                </a:lnTo>
+                <a:close/>
+                <a:lnTo>
+                  <a:pt x="545770" y="2385754"/>
+                </a:lnTo>
+                <a:close/>
+                <a:lnTo>
+                  <a:pt x="548274" y="2382487"/>
+                </a:lnTo>
+                <a:close/>
+                <a:lnTo>
+                  <a:pt x="550777" y="2379264"/>
+                </a:lnTo>
+                <a:close/>
+                <a:lnTo>
+                  <a:pt x="553281" y="2376086"/>
+                </a:lnTo>
+                <a:close/>
+                <a:lnTo>
+                  <a:pt x="555784" y="2372944"/>
+                </a:lnTo>
+                <a:close/>
+                <a:lnTo>
+                  <a:pt x="558288" y="2369829"/>
+                </a:lnTo>
+                <a:close/>
+                <a:lnTo>
+                  <a:pt x="560791" y="2366732"/>
+                </a:lnTo>
+                <a:close/>
+                <a:lnTo>
+                  <a:pt x="563295" y="2363642"/>
+                </a:lnTo>
+                <a:close/>
+                <a:lnTo>
+                  <a:pt x="565798" y="2360550"/>
+                </a:lnTo>
+                <a:close/>
+                <a:lnTo>
+                  <a:pt x="568302" y="2357448"/>
+                </a:lnTo>
+                <a:close/>
+                <a:lnTo>
+                  <a:pt x="570805" y="2354332"/>
+                </a:lnTo>
+                <a:close/>
+                <a:lnTo>
+                  <a:pt x="573309" y="2351206"/>
+                </a:lnTo>
+                <a:close/>
+                <a:lnTo>
+                  <a:pt x="575812" y="2348073"/>
+                </a:lnTo>
+                <a:close/>
+                <a:lnTo>
+                  <a:pt x="578316" y="2344935"/>
+                </a:lnTo>
+                <a:close/>
+                <a:lnTo>
+                  <a:pt x="580820" y="2341797"/>
+                </a:lnTo>
+                <a:close/>
+                <a:lnTo>
+                  <a:pt x="583323" y="2338660"/>
+                </a:lnTo>
+                <a:close/>
+                <a:lnTo>
+                  <a:pt x="585827" y="2335529"/>
+                </a:lnTo>
+                <a:close/>
+                <a:lnTo>
+                  <a:pt x="588330" y="2332404"/>
+                </a:lnTo>
+                <a:close/>
+                <a:lnTo>
+                  <a:pt x="590834" y="2329283"/>
+                </a:lnTo>
+                <a:close/>
+                <a:lnTo>
+                  <a:pt x="593337" y="2326163"/>
+                </a:lnTo>
+                <a:close/>
+                <a:lnTo>
+                  <a:pt x="595841" y="2323040"/>
+                </a:lnTo>
+                <a:close/>
+                <a:lnTo>
+                  <a:pt x="598344" y="2319911"/>
+                </a:lnTo>
+                <a:close/>
+                <a:lnTo>
+                  <a:pt x="600848" y="2316774"/>
+                </a:lnTo>
+                <a:close/>
+                <a:lnTo>
+                  <a:pt x="603351" y="2313624"/>
+                </a:lnTo>
+                <a:close/>
+                <a:lnTo>
+                  <a:pt x="605855" y="2310462"/>
+                </a:lnTo>
+                <a:close/>
+                <a:lnTo>
+                  <a:pt x="608358" y="2307292"/>
+                </a:lnTo>
+                <a:close/>
+                <a:lnTo>
+                  <a:pt x="610862" y="2304126"/>
+                </a:lnTo>
+                <a:close/>
+                <a:lnTo>
+                  <a:pt x="613365" y="2300972"/>
+                </a:lnTo>
+                <a:close/>
+                <a:lnTo>
+                  <a:pt x="615869" y="2297840"/>
+                </a:lnTo>
+                <a:close/>
+                <a:lnTo>
+                  <a:pt x="618373" y="2294740"/>
+                </a:lnTo>
+                <a:close/>
+                <a:lnTo>
+                  <a:pt x="620876" y="2291680"/>
+                </a:lnTo>
+                <a:close/>
+                <a:lnTo>
+                  <a:pt x="623380" y="2288668"/>
+                </a:lnTo>
+                <a:close/>
+                <a:lnTo>
+                  <a:pt x="625883" y="2285687"/>
+                </a:lnTo>
+                <a:close/>
+                <a:lnTo>
+                  <a:pt x="628387" y="2282704"/>
+                </a:lnTo>
+                <a:close/>
+                <a:lnTo>
+                  <a:pt x="630890" y="2279683"/>
+                </a:lnTo>
+                <a:close/>
+                <a:lnTo>
+                  <a:pt x="633394" y="2276590"/>
+                </a:lnTo>
+                <a:close/>
+                <a:lnTo>
+                  <a:pt x="635897" y="2273390"/>
+                </a:lnTo>
+                <a:close/>
+                <a:lnTo>
+                  <a:pt x="638401" y="2270049"/>
+                </a:lnTo>
+                <a:close/>
+                <a:lnTo>
+                  <a:pt x="640904" y="2266533"/>
+                </a:lnTo>
+                <a:close/>
+                <a:lnTo>
+                  <a:pt x="643408" y="2262842"/>
+                </a:lnTo>
+                <a:close/>
+                <a:lnTo>
+                  <a:pt x="645911" y="2259030"/>
+                </a:lnTo>
+                <a:close/>
+                <a:lnTo>
+                  <a:pt x="648415" y="2255155"/>
+                </a:lnTo>
+                <a:close/>
+                <a:lnTo>
+                  <a:pt x="650918" y="2251276"/>
+                </a:lnTo>
+                <a:close/>
+                <a:lnTo>
+                  <a:pt x="653422" y="2247451"/>
+                </a:lnTo>
+                <a:close/>
+                <a:lnTo>
+                  <a:pt x="655926" y="2243738"/>
+                </a:lnTo>
+                <a:close/>
+                <a:lnTo>
+                  <a:pt x="658429" y="2240196"/>
+                </a:lnTo>
+                <a:close/>
+                <a:lnTo>
+                  <a:pt x="660933" y="2236863"/>
+                </a:lnTo>
+                <a:close/>
+                <a:lnTo>
+                  <a:pt x="663436" y="2233698"/>
+                </a:lnTo>
+                <a:close/>
+                <a:lnTo>
+                  <a:pt x="665940" y="2230642"/>
+                </a:lnTo>
+                <a:close/>
+                <a:lnTo>
+                  <a:pt x="668443" y="2227638"/>
+                </a:lnTo>
+                <a:close/>
+                <a:lnTo>
+                  <a:pt x="670947" y="2224626"/>
+                </a:lnTo>
+                <a:close/>
+                <a:lnTo>
+                  <a:pt x="673450" y="2221549"/>
+                </a:lnTo>
+                <a:close/>
+                <a:lnTo>
+                  <a:pt x="675954" y="2218348"/>
+                </a:lnTo>
+                <a:close/>
+                <a:lnTo>
+                  <a:pt x="678457" y="2214970"/>
+                </a:lnTo>
+                <a:close/>
+                <a:lnTo>
+                  <a:pt x="680961" y="2211419"/>
+                </a:lnTo>
+                <a:close/>
+                <a:lnTo>
+                  <a:pt x="683464" y="2207728"/>
+                </a:lnTo>
+                <a:close/>
+                <a:lnTo>
+                  <a:pt x="685968" y="2203932"/>
+                </a:lnTo>
+                <a:close/>
+                <a:lnTo>
+                  <a:pt x="688471" y="2200065"/>
+                </a:lnTo>
+                <a:close/>
+                <a:lnTo>
+                  <a:pt x="690975" y="2196163"/>
+                </a:lnTo>
+                <a:close/>
+                <a:lnTo>
+                  <a:pt x="693479" y="2192260"/>
+                </a:lnTo>
+                <a:close/>
+                <a:lnTo>
+                  <a:pt x="695982" y="2188389"/>
+                </a:lnTo>
+                <a:close/>
+                <a:lnTo>
+                  <a:pt x="698486" y="2184567"/>
+                </a:lnTo>
+                <a:close/>
+                <a:lnTo>
+                  <a:pt x="700989" y="2180784"/>
+                </a:lnTo>
+                <a:close/>
+                <a:lnTo>
+                  <a:pt x="703493" y="2177033"/>
+                </a:lnTo>
+                <a:close/>
+                <a:lnTo>
+                  <a:pt x="705996" y="2173303"/>
+                </a:lnTo>
+                <a:close/>
+                <a:lnTo>
+                  <a:pt x="708500" y="2169585"/>
+                </a:lnTo>
+                <a:close/>
+                <a:lnTo>
+                  <a:pt x="711003" y="2165869"/>
+                </a:lnTo>
+                <a:close/>
+                <a:lnTo>
+                  <a:pt x="713507" y="2162147"/>
+                </a:lnTo>
+                <a:close/>
+                <a:lnTo>
+                  <a:pt x="716010" y="2158411"/>
+                </a:lnTo>
+                <a:close/>
+                <a:lnTo>
+                  <a:pt x="718514" y="2154663"/>
+                </a:lnTo>
+                <a:close/>
+                <a:lnTo>
+                  <a:pt x="721017" y="2150907"/>
+                </a:lnTo>
+                <a:close/>
+                <a:lnTo>
+                  <a:pt x="723521" y="2147145"/>
+                </a:lnTo>
+                <a:close/>
+                <a:lnTo>
+                  <a:pt x="726024" y="2143380"/>
+                </a:lnTo>
+                <a:close/>
+                <a:lnTo>
+                  <a:pt x="728528" y="2139617"/>
+                </a:lnTo>
+                <a:close/>
+                <a:lnTo>
+                  <a:pt x="731032" y="2135857"/>
+                </a:lnTo>
+                <a:close/>
+                <a:lnTo>
+                  <a:pt x="733535" y="2132104"/>
+                </a:lnTo>
+                <a:close/>
+                <a:lnTo>
+                  <a:pt x="736039" y="2128356"/>
+                </a:lnTo>
+                <a:close/>
+                <a:lnTo>
+                  <a:pt x="738542" y="2124609"/>
+                </a:lnTo>
+                <a:close/>
+                <a:lnTo>
+                  <a:pt x="741046" y="2120862"/>
+                </a:lnTo>
+                <a:close/>
+                <a:lnTo>
+                  <a:pt x="743549" y="2117110"/>
+                </a:lnTo>
+                <a:close/>
+                <a:lnTo>
+                  <a:pt x="746053" y="2113351"/>
+                </a:lnTo>
+                <a:close/>
+                <a:lnTo>
+                  <a:pt x="748556" y="2109582"/>
+                </a:lnTo>
+                <a:close/>
+                <a:lnTo>
+                  <a:pt x="751060" y="2105799"/>
+                </a:lnTo>
+                <a:close/>
+                <a:lnTo>
+                  <a:pt x="753563" y="2102005"/>
+                </a:lnTo>
+                <a:close/>
+                <a:lnTo>
+                  <a:pt x="756067" y="2098211"/>
+                </a:lnTo>
+                <a:close/>
+                <a:lnTo>
+                  <a:pt x="758570" y="2094424"/>
+                </a:lnTo>
+                <a:close/>
+                <a:lnTo>
+                  <a:pt x="761074" y="2090656"/>
+                </a:lnTo>
+                <a:close/>
+                <a:lnTo>
+                  <a:pt x="763577" y="2086914"/>
+                </a:lnTo>
+                <a:close/>
+                <a:lnTo>
+                  <a:pt x="766081" y="2083209"/>
+                </a:lnTo>
+                <a:close/>
+                <a:lnTo>
+                  <a:pt x="768584" y="2079550"/>
+                </a:lnTo>
+                <a:close/>
+                <a:lnTo>
+                  <a:pt x="771088" y="2075934"/>
+                </a:lnTo>
+                <a:close/>
+                <a:lnTo>
+                  <a:pt x="773592" y="2072330"/>
+                </a:lnTo>
+                <a:close/>
+                <a:lnTo>
+                  <a:pt x="776095" y="2068704"/>
+                </a:lnTo>
+                <a:close/>
+                <a:lnTo>
+                  <a:pt x="778599" y="2065021"/>
+                </a:lnTo>
+                <a:close/>
+                <a:lnTo>
+                  <a:pt x="781102" y="2061246"/>
+                </a:lnTo>
+                <a:close/>
+                <a:lnTo>
+                  <a:pt x="783606" y="2057346"/>
+                </a:lnTo>
+                <a:close/>
+                <a:lnTo>
+                  <a:pt x="786109" y="2053285"/>
+                </a:lnTo>
+                <a:close/>
+                <a:lnTo>
+                  <a:pt x="788613" y="2049040"/>
+                </a:lnTo>
+                <a:close/>
+                <a:lnTo>
+                  <a:pt x="791116" y="2044648"/>
+                </a:lnTo>
+                <a:close/>
+                <a:lnTo>
+                  <a:pt x="793620" y="2040167"/>
+                </a:lnTo>
+                <a:close/>
+                <a:lnTo>
+                  <a:pt x="796123" y="2035657"/>
+                </a:lnTo>
+                <a:close/>
+                <a:lnTo>
+                  <a:pt x="798627" y="2031175"/>
+                </a:lnTo>
+                <a:close/>
+                <a:lnTo>
+                  <a:pt x="801130" y="2026780"/>
+                </a:lnTo>
+                <a:close/>
+                <a:lnTo>
+                  <a:pt x="803634" y="2022530"/>
+                </a:lnTo>
+                <a:close/>
+                <a:lnTo>
+                  <a:pt x="806137" y="2018480"/>
+                </a:lnTo>
+                <a:close/>
+                <a:lnTo>
+                  <a:pt x="808641" y="2014622"/>
+                </a:lnTo>
+                <a:close/>
+                <a:lnTo>
+                  <a:pt x="811145" y="2010900"/>
+                </a:lnTo>
+                <a:close/>
+                <a:lnTo>
+                  <a:pt x="813648" y="2007254"/>
+                </a:lnTo>
+                <a:close/>
+                <a:lnTo>
+                  <a:pt x="816152" y="2003627"/>
+                </a:lnTo>
+                <a:close/>
+                <a:lnTo>
+                  <a:pt x="818655" y="1999960"/>
+                </a:lnTo>
+                <a:close/>
+                <a:lnTo>
+                  <a:pt x="821159" y="1996195"/>
+                </a:lnTo>
+                <a:close/>
+                <a:lnTo>
+                  <a:pt x="823662" y="1992273"/>
+                </a:lnTo>
+                <a:close/>
+                <a:lnTo>
+                  <a:pt x="826166" y="1988168"/>
+                </a:lnTo>
+                <a:close/>
+                <a:lnTo>
+                  <a:pt x="828669" y="1983908"/>
+                </a:lnTo>
+                <a:close/>
+                <a:lnTo>
+                  <a:pt x="831173" y="1979528"/>
+                </a:lnTo>
+                <a:close/>
+                <a:lnTo>
+                  <a:pt x="833676" y="1975062"/>
+                </a:lnTo>
+                <a:close/>
+                <a:lnTo>
+                  <a:pt x="836180" y="1970545"/>
+                </a:lnTo>
+                <a:close/>
+                <a:lnTo>
+                  <a:pt x="838683" y="1966012"/>
+                </a:lnTo>
+                <a:close/>
+                <a:lnTo>
+                  <a:pt x="841187" y="1961498"/>
+                </a:lnTo>
+                <a:close/>
+                <a:lnTo>
+                  <a:pt x="843690" y="1957029"/>
+                </a:lnTo>
+                <a:close/>
+                <a:lnTo>
+                  <a:pt x="846194" y="1952604"/>
+                </a:lnTo>
+                <a:close/>
+                <a:lnTo>
+                  <a:pt x="848698" y="1948214"/>
+                </a:lnTo>
+                <a:close/>
+                <a:lnTo>
+                  <a:pt x="851201" y="1943850"/>
+                </a:lnTo>
+                <a:close/>
+                <a:lnTo>
+                  <a:pt x="853705" y="1939502"/>
+                </a:lnTo>
+                <a:close/>
+                <a:lnTo>
+                  <a:pt x="856208" y="1935161"/>
+                </a:lnTo>
+                <a:close/>
+                <a:lnTo>
+                  <a:pt x="858712" y="1930817"/>
+                </a:lnTo>
+                <a:close/>
+                <a:lnTo>
+                  <a:pt x="861215" y="1926461"/>
+                </a:lnTo>
+                <a:close/>
+                <a:lnTo>
+                  <a:pt x="863719" y="1922092"/>
+                </a:lnTo>
+                <a:close/>
+                <a:lnTo>
+                  <a:pt x="866222" y="1917713"/>
+                </a:lnTo>
+                <a:close/>
+                <a:lnTo>
+                  <a:pt x="868726" y="1913327"/>
+                </a:lnTo>
+                <a:close/>
+                <a:lnTo>
+                  <a:pt x="871229" y="1908938"/>
+                </a:lnTo>
+                <a:close/>
+                <a:lnTo>
+                  <a:pt x="873733" y="1904547"/>
+                </a:lnTo>
+                <a:close/>
+                <a:lnTo>
+                  <a:pt x="876236" y="1900160"/>
+                </a:lnTo>
+                <a:close/>
+                <a:lnTo>
+                  <a:pt x="878740" y="1895778"/>
+                </a:lnTo>
+                <a:close/>
+                <a:lnTo>
+                  <a:pt x="881243" y="1891402"/>
+                </a:lnTo>
+                <a:close/>
+                <a:lnTo>
+                  <a:pt x="883747" y="1887029"/>
+                </a:lnTo>
+                <a:close/>
+                <a:lnTo>
+                  <a:pt x="886251" y="1882657"/>
+                </a:lnTo>
+                <a:close/>
+                <a:lnTo>
+                  <a:pt x="888754" y="1878282"/>
+                </a:lnTo>
+                <a:close/>
+                <a:lnTo>
+                  <a:pt x="891258" y="1873900"/>
+                </a:lnTo>
+                <a:close/>
+                <a:lnTo>
+                  <a:pt x="893761" y="1869510"/>
+                </a:lnTo>
+                <a:close/>
+                <a:lnTo>
+                  <a:pt x="896265" y="1865107"/>
+                </a:lnTo>
+                <a:close/>
+                <a:lnTo>
+                  <a:pt x="898768" y="1860691"/>
+                </a:lnTo>
+                <a:close/>
+                <a:lnTo>
+                  <a:pt x="901272" y="1856270"/>
+                </a:lnTo>
+                <a:close/>
+                <a:lnTo>
+                  <a:pt x="903775" y="1851853"/>
+                </a:lnTo>
+                <a:close/>
+                <a:lnTo>
+                  <a:pt x="906279" y="1847450"/>
+                </a:lnTo>
+                <a:close/>
+                <a:lnTo>
+                  <a:pt x="908782" y="1843069"/>
+                </a:lnTo>
+                <a:close/>
+                <a:lnTo>
+                  <a:pt x="911286" y="1838721"/>
+                </a:lnTo>
+                <a:close/>
+                <a:lnTo>
+                  <a:pt x="913789" y="1834415"/>
+                </a:lnTo>
+                <a:close/>
+                <a:lnTo>
+                  <a:pt x="916293" y="1830157"/>
+                </a:lnTo>
+                <a:close/>
+                <a:lnTo>
+                  <a:pt x="918796" y="1825926"/>
+                </a:lnTo>
+                <a:close/>
+                <a:lnTo>
+                  <a:pt x="921300" y="1821688"/>
+                </a:lnTo>
+                <a:close/>
+                <a:lnTo>
+                  <a:pt x="923804" y="1817408"/>
+                </a:lnTo>
+                <a:close/>
+                <a:lnTo>
+                  <a:pt x="926307" y="1813052"/>
+                </a:lnTo>
+                <a:close/>
+                <a:lnTo>
+                  <a:pt x="928811" y="1808585"/>
+                </a:lnTo>
+                <a:close/>
+                <a:lnTo>
+                  <a:pt x="931314" y="1803973"/>
+                </a:lnTo>
+                <a:close/>
+                <a:lnTo>
+                  <a:pt x="933818" y="1799183"/>
+                </a:lnTo>
+                <a:close/>
+                <a:lnTo>
+                  <a:pt x="936321" y="1794222"/>
+                </a:lnTo>
+                <a:close/>
+                <a:lnTo>
+                  <a:pt x="938825" y="1789147"/>
+                </a:lnTo>
+                <a:close/>
+                <a:lnTo>
+                  <a:pt x="941328" y="1784017"/>
+                </a:lnTo>
+                <a:close/>
+                <a:lnTo>
+                  <a:pt x="943832" y="1778889"/>
+                </a:lnTo>
+                <a:close/>
+                <a:lnTo>
+                  <a:pt x="946335" y="1773823"/>
+                </a:lnTo>
+                <a:close/>
+                <a:lnTo>
+                  <a:pt x="948839" y="1768876"/>
+                </a:lnTo>
+                <a:close/>
+                <a:lnTo>
+                  <a:pt x="951342" y="1764107"/>
+                </a:lnTo>
+                <a:close/>
+                <a:lnTo>
+                  <a:pt x="953846" y="1759546"/>
+                </a:lnTo>
+                <a:close/>
+                <a:lnTo>
+                  <a:pt x="956349" y="1755146"/>
+                </a:lnTo>
+                <a:close/>
+                <a:lnTo>
+                  <a:pt x="958853" y="1750848"/>
+                </a:lnTo>
+                <a:close/>
+                <a:lnTo>
+                  <a:pt x="961357" y="1746594"/>
+                </a:lnTo>
+                <a:close/>
+                <a:lnTo>
+                  <a:pt x="963860" y="1742326"/>
+                </a:lnTo>
+                <a:close/>
+                <a:lnTo>
+                  <a:pt x="966364" y="1737985"/>
+                </a:lnTo>
+                <a:close/>
+                <a:lnTo>
+                  <a:pt x="968867" y="1733513"/>
+                </a:lnTo>
+                <a:close/>
+                <a:lnTo>
+                  <a:pt x="971371" y="1728860"/>
+                </a:lnTo>
+                <a:close/>
+                <a:lnTo>
+                  <a:pt x="973874" y="1724038"/>
+                </a:lnTo>
+                <a:close/>
+                <a:lnTo>
+                  <a:pt x="976378" y="1719081"/>
+                </a:lnTo>
+                <a:close/>
+                <a:lnTo>
+                  <a:pt x="978881" y="1714023"/>
+                </a:lnTo>
+                <a:close/>
+                <a:lnTo>
+                  <a:pt x="981385" y="1708898"/>
+                </a:lnTo>
+                <a:close/>
+                <a:lnTo>
+                  <a:pt x="983888" y="1703742"/>
+                </a:lnTo>
+                <a:close/>
+                <a:lnTo>
+                  <a:pt x="986392" y="1698589"/>
+                </a:lnTo>
+                <a:close/>
+                <a:lnTo>
+                  <a:pt x="988895" y="1693473"/>
+                </a:lnTo>
+                <a:close/>
+                <a:lnTo>
+                  <a:pt x="991399" y="1688404"/>
+                </a:lnTo>
+                <a:close/>
+                <a:lnTo>
+                  <a:pt x="993902" y="1683374"/>
+                </a:lnTo>
+                <a:close/>
+                <a:lnTo>
+                  <a:pt x="996406" y="1678374"/>
+                </a:lnTo>
+                <a:close/>
+                <a:lnTo>
+                  <a:pt x="998909" y="1673394"/>
+                </a:lnTo>
+                <a:close/>
+                <a:lnTo>
+                  <a:pt x="1001413" y="1668425"/>
+                </a:lnTo>
+                <a:close/>
+                <a:lnTo>
+                  <a:pt x="1003917" y="1663458"/>
+                </a:lnTo>
+                <a:close/>
+                <a:lnTo>
+                  <a:pt x="1006420" y="1658482"/>
+                </a:lnTo>
+                <a:close/>
+                <a:lnTo>
+                  <a:pt x="1008924" y="1653493"/>
+                </a:lnTo>
+                <a:close/>
+                <a:lnTo>
+                  <a:pt x="1011427" y="1648492"/>
+                </a:lnTo>
+                <a:close/>
+                <a:lnTo>
+                  <a:pt x="1013931" y="1643483"/>
+                </a:lnTo>
+                <a:close/>
+                <a:lnTo>
+                  <a:pt x="1016434" y="1638469"/>
+                </a:lnTo>
+                <a:close/>
+                <a:lnTo>
+                  <a:pt x="1018938" y="1633452"/>
+                </a:lnTo>
+                <a:close/>
+                <a:lnTo>
+                  <a:pt x="1021441" y="1628437"/>
+                </a:lnTo>
+                <a:close/>
+                <a:lnTo>
+                  <a:pt x="1023945" y="1623426"/>
+                </a:lnTo>
+                <a:close/>
+                <a:lnTo>
+                  <a:pt x="1026448" y="1618422"/>
+                </a:lnTo>
+                <a:close/>
+                <a:lnTo>
+                  <a:pt x="1028952" y="1613423"/>
+                </a:lnTo>
+                <a:close/>
+                <a:lnTo>
+                  <a:pt x="1031455" y="1608425"/>
+                </a:lnTo>
+                <a:close/>
+                <a:lnTo>
+                  <a:pt x="1033959" y="1603425"/>
+                </a:lnTo>
+                <a:close/>
+                <a:lnTo>
+                  <a:pt x="1036462" y="1598421"/>
+                </a:lnTo>
+                <a:close/>
+                <a:lnTo>
+                  <a:pt x="1038966" y="1593409"/>
+                </a:lnTo>
+                <a:close/>
+                <a:lnTo>
+                  <a:pt x="1041470" y="1588386"/>
+                </a:lnTo>
+                <a:close/>
+                <a:lnTo>
+                  <a:pt x="1043973" y="1583350"/>
+                </a:lnTo>
+                <a:close/>
+                <a:lnTo>
+                  <a:pt x="1046477" y="1578304"/>
+                </a:lnTo>
+                <a:close/>
+                <a:lnTo>
+                  <a:pt x="1048980" y="1573259"/>
+                </a:lnTo>
+                <a:close/>
+                <a:lnTo>
+                  <a:pt x="1051484" y="1568222"/>
+                </a:lnTo>
+                <a:close/>
+                <a:lnTo>
+                  <a:pt x="1053987" y="1563205"/>
+                </a:lnTo>
+                <a:close/>
+                <a:lnTo>
+                  <a:pt x="1056491" y="1558215"/>
+                </a:lnTo>
+                <a:close/>
+                <a:lnTo>
+                  <a:pt x="1058994" y="1553263"/>
+                </a:lnTo>
+                <a:close/>
+                <a:lnTo>
+                  <a:pt x="1061498" y="1548358"/>
+                </a:lnTo>
+                <a:close/>
+                <a:lnTo>
+                  <a:pt x="1064001" y="1543493"/>
+                </a:lnTo>
+                <a:close/>
+                <a:lnTo>
+                  <a:pt x="1066505" y="1538636"/>
+                </a:lnTo>
+                <a:close/>
+                <a:lnTo>
+                  <a:pt x="1069008" y="1533752"/>
+                </a:lnTo>
+                <a:close/>
+                <a:lnTo>
+                  <a:pt x="1071512" y="1528808"/>
+                </a:lnTo>
+                <a:close/>
+                <a:lnTo>
+                  <a:pt x="1074016" y="1523768"/>
+                </a:lnTo>
+                <a:close/>
+                <a:lnTo>
+                  <a:pt x="1076519" y="1518599"/>
+                </a:lnTo>
+                <a:close/>
+                <a:lnTo>
+                  <a:pt x="1079023" y="1513266"/>
+                </a:lnTo>
+                <a:close/>
+                <a:lnTo>
+                  <a:pt x="1081526" y="1507750"/>
+                </a:lnTo>
+                <a:close/>
+                <a:lnTo>
+                  <a:pt x="1084030" y="1502095"/>
+                </a:lnTo>
+                <a:close/>
+                <a:lnTo>
+                  <a:pt x="1086533" y="1496358"/>
+                </a:lnTo>
+                <a:close/>
+                <a:lnTo>
+                  <a:pt x="1089037" y="1490598"/>
+                </a:lnTo>
+                <a:close/>
+                <a:lnTo>
+                  <a:pt x="1091540" y="1484871"/>
+                </a:lnTo>
+                <a:close/>
+                <a:lnTo>
+                  <a:pt x="1094044" y="1479237"/>
+                </a:lnTo>
+                <a:close/>
+                <a:lnTo>
+                  <a:pt x="1096547" y="1473753"/>
+                </a:lnTo>
+                <a:close/>
+                <a:lnTo>
+                  <a:pt x="1099051" y="1468469"/>
+                </a:lnTo>
+                <a:close/>
+                <a:lnTo>
+                  <a:pt x="1101555" y="1463370"/>
+                </a:lnTo>
+                <a:close/>
+                <a:lnTo>
+                  <a:pt x="1104058" y="1458399"/>
+                </a:lnTo>
+                <a:close/>
+                <a:lnTo>
+                  <a:pt x="1106562" y="1453501"/>
+                </a:lnTo>
+                <a:close/>
+                <a:lnTo>
+                  <a:pt x="1109066" y="1448618"/>
+                </a:lnTo>
+                <a:close/>
+                <a:lnTo>
+                  <a:pt x="1111569" y="1443696"/>
+                </a:lnTo>
+                <a:close/>
+                <a:lnTo>
+                  <a:pt x="1114072" y="1438677"/>
+                </a:lnTo>
+                <a:close/>
+                <a:lnTo>
+                  <a:pt x="1116575" y="1433506"/>
+                </a:lnTo>
+                <a:close/>
+                <a:lnTo>
+                  <a:pt x="1119078" y="1428162"/>
+                </a:lnTo>
+                <a:close/>
+                <a:lnTo>
+                  <a:pt x="1121581" y="1422669"/>
+                </a:lnTo>
+                <a:close/>
+                <a:lnTo>
+                  <a:pt x="1124084" y="1417053"/>
+                </a:lnTo>
+                <a:close/>
+                <a:lnTo>
+                  <a:pt x="1126587" y="1411341"/>
+                </a:lnTo>
+                <a:close/>
+                <a:lnTo>
+                  <a:pt x="1129091" y="1405559"/>
+                </a:lnTo>
+                <a:close/>
+                <a:lnTo>
+                  <a:pt x="1131595" y="1399733"/>
+                </a:lnTo>
+                <a:close/>
+                <a:lnTo>
+                  <a:pt x="1134100" y="1393890"/>
+                </a:lnTo>
+                <a:close/>
+                <a:lnTo>
+                  <a:pt x="1136606" y="1388055"/>
+                </a:lnTo>
+                <a:close/>
+                <a:lnTo>
+                  <a:pt x="1139112" y="1382250"/>
+                </a:lnTo>
+                <a:close/>
+                <a:lnTo>
+                  <a:pt x="1141618" y="1376495"/>
+                </a:lnTo>
+                <a:close/>
+                <a:lnTo>
+                  <a:pt x="1144123" y="1370812"/>
+                </a:lnTo>
+                <a:close/>
+                <a:lnTo>
+                  <a:pt x="1146626" y="1365222"/>
+                </a:lnTo>
+                <a:close/>
+                <a:lnTo>
+                  <a:pt x="1149127" y="1359744"/>
+                </a:lnTo>
+                <a:close/>
+                <a:lnTo>
+                  <a:pt x="1151626" y="1354401"/>
+                </a:lnTo>
+                <a:close/>
+                <a:lnTo>
+                  <a:pt x="1154122" y="1349202"/>
+                </a:lnTo>
+                <a:close/>
+                <a:lnTo>
+                  <a:pt x="1156617" y="1344075"/>
+                </a:lnTo>
+                <a:close/>
+                <a:lnTo>
+                  <a:pt x="1159112" y="1338910"/>
+                </a:lnTo>
+                <a:close/>
+                <a:lnTo>
+                  <a:pt x="1161610" y="1333597"/>
+                </a:lnTo>
+                <a:close/>
+                <a:lnTo>
+                  <a:pt x="1164112" y="1328027"/>
+                </a:lnTo>
+                <a:close/>
+                <a:lnTo>
+                  <a:pt x="1166621" y="1322088"/>
+                </a:lnTo>
+                <a:close/>
+                <a:lnTo>
+                  <a:pt x="1169138" y="1315671"/>
+                </a:lnTo>
+                <a:close/>
+                <a:lnTo>
+                  <a:pt x="1171667" y="1308677"/>
+                </a:lnTo>
+                <a:close/>
+                <a:lnTo>
+                  <a:pt x="1174203" y="1301255"/>
+                </a:lnTo>
+                <a:close/>
+                <a:lnTo>
+                  <a:pt x="1176739" y="1293812"/>
+                </a:lnTo>
+                <a:close/>
+                <a:lnTo>
+                  <a:pt x="1179269" y="1286767"/>
+                </a:lnTo>
+                <a:close/>
+                <a:lnTo>
+                  <a:pt x="1181783" y="1280541"/>
+                </a:lnTo>
+                <a:close/>
+                <a:lnTo>
+                  <a:pt x="1184275" y="1275551"/>
+                </a:lnTo>
+                <a:close/>
+                <a:lnTo>
+                  <a:pt x="1186736" y="1272218"/>
+                </a:lnTo>
+                <a:close/>
+                <a:lnTo>
+                  <a:pt x="1189160" y="1270958"/>
+                </a:lnTo>
+                <a:close/>
+                <a:lnTo>
+                  <a:pt x="1191548" y="1271649"/>
+                </a:lnTo>
+                <a:close/>
+                <a:lnTo>
+                  <a:pt x="1193926" y="1272905"/>
+                </a:lnTo>
+                <a:close/>
+                <a:lnTo>
+                  <a:pt x="1196322" y="1273158"/>
+                </a:lnTo>
+                <a:close/>
+                <a:lnTo>
+                  <a:pt x="1198765" y="1270842"/>
+                </a:lnTo>
+                <a:close/>
+                <a:lnTo>
+                  <a:pt x="1201284" y="1264390"/>
+                </a:lnTo>
+                <a:close/>
+                <a:lnTo>
+                  <a:pt x="1203906" y="1252235"/>
+                </a:lnTo>
+                <a:close/>
+                <a:lnTo>
+                  <a:pt x="1206662" y="1232810"/>
+                </a:lnTo>
+                <a:close/>
+                <a:lnTo>
+                  <a:pt x="1209563" y="1205385"/>
+                </a:lnTo>
+                <a:close/>
+                <a:lnTo>
+                  <a:pt x="1212535" y="1174069"/>
+                </a:lnTo>
+                <a:close/>
+                <a:lnTo>
+                  <a:pt x="1215471" y="1144710"/>
+                </a:lnTo>
+                <a:close/>
+                <a:lnTo>
+                  <a:pt x="1218266" y="1123153"/>
+                </a:lnTo>
+                <a:close/>
+                <a:lnTo>
+                  <a:pt x="1220811" y="1115249"/>
+                </a:lnTo>
+                <a:close/>
+                <a:lnTo>
+                  <a:pt x="1223000" y="1126846"/>
+                </a:lnTo>
+                <a:close/>
+                <a:lnTo>
+                  <a:pt x="1224726" y="1163791"/>
+                </a:lnTo>
+                <a:close/>
+                <a:lnTo>
+                  <a:pt x="1225895" y="1231458"/>
+                </a:lnTo>
+                <a:close/>
+                <a:lnTo>
+                  <a:pt x="1226601" y="1327292"/>
+                </a:lnTo>
+                <a:close/>
+                <a:lnTo>
+                  <a:pt x="1227098" y="1442189"/>
+                </a:lnTo>
+                <a:close/>
+                <a:lnTo>
+                  <a:pt x="1227642" y="1566850"/>
+                </a:lnTo>
+                <a:close/>
+                <a:lnTo>
+                  <a:pt x="1228492" y="1691975"/>
+                </a:lnTo>
+                <a:close/>
+                <a:lnTo>
+                  <a:pt x="1229904" y="1808266"/>
+                </a:lnTo>
+                <a:close/>
+                <a:lnTo>
+                  <a:pt x="1232138" y="1906421"/>
+                </a:lnTo>
+                <a:close/>
+                <a:lnTo>
+                  <a:pt x="1235447" y="1977190"/>
+                </a:lnTo>
+                <a:close/>
+                <a:lnTo>
+                  <a:pt x="1239933" y="2016217"/>
+                </a:lnTo>
+                <a:close/>
+                <a:lnTo>
+                  <a:pt x="1245407" y="2028187"/>
+                </a:lnTo>
+                <a:close/>
+                <a:lnTo>
+                  <a:pt x="1251649" y="2018764"/>
+                </a:lnTo>
+                <a:close/>
+                <a:lnTo>
+                  <a:pt x="1258440" y="1993611"/>
+                </a:lnTo>
+                <a:close/>
+                <a:lnTo>
+                  <a:pt x="1265559" y="1958390"/>
+                </a:lnTo>
+                <a:close/>
+                <a:lnTo>
+                  <a:pt x="1272787" y="1918765"/>
+                </a:lnTo>
+                <a:close/>
+                <a:lnTo>
+                  <a:pt x="1279905" y="1880399"/>
+                </a:lnTo>
+                <a:close/>
+                <a:lnTo>
+                  <a:pt x="1286733" y="1847914"/>
+                </a:lnTo>
+                <a:close/>
+                <a:lnTo>
+                  <a:pt x="1293279" y="1821288"/>
+                </a:lnTo>
+                <a:close/>
+                <a:lnTo>
+                  <a:pt x="1299602" y="1799202"/>
+                </a:lnTo>
+                <a:close/>
+                <a:lnTo>
+                  <a:pt x="1305758" y="1780338"/>
+                </a:lnTo>
+                <a:close/>
+                <a:lnTo>
+                  <a:pt x="1311807" y="1763377"/>
+                </a:lnTo>
+                <a:close/>
+                <a:lnTo>
+                  <a:pt x="1317807" y="1747001"/>
+                </a:lnTo>
+                <a:close/>
+                <a:lnTo>
+                  <a:pt x="1323816" y="1729890"/>
+                </a:lnTo>
+                <a:close/>
+                <a:lnTo>
+                  <a:pt x="1329888" y="1710805"/>
+                </a:lnTo>
+                <a:close/>
+                <a:lnTo>
+                  <a:pt x="1336039" y="1689436"/>
+                </a:lnTo>
+                <a:close/>
+                <a:lnTo>
+                  <a:pt x="1342254" y="1666086"/>
+                </a:lnTo>
+                <a:close/>
+                <a:lnTo>
+                  <a:pt x="1348522" y="1641070"/>
+                </a:lnTo>
+                <a:close/>
+                <a:lnTo>
+                  <a:pt x="1354827" y="1614704"/>
+                </a:lnTo>
+                <a:close/>
+                <a:lnTo>
+                  <a:pt x="1361158" y="1587301"/>
+                </a:lnTo>
+                <a:close/>
+                <a:lnTo>
+                  <a:pt x="1367501" y="1559177"/>
+                </a:lnTo>
+                <a:close/>
+                <a:lnTo>
+                  <a:pt x="1373842" y="1530645"/>
+                </a:lnTo>
+                <a:close/>
+                <a:lnTo>
+                  <a:pt x="1380171" y="1501891"/>
+                </a:lnTo>
+                <a:close/>
+                <a:lnTo>
+                  <a:pt x="1386483" y="1472919"/>
+                </a:lnTo>
+                <a:close/>
+                <a:lnTo>
+                  <a:pt x="1392774" y="1443718"/>
+                </a:lnTo>
+                <a:close/>
+                <a:lnTo>
+                  <a:pt x="1399038" y="1414277"/>
+                </a:lnTo>
+                <a:close/>
+                <a:lnTo>
+                  <a:pt x="1405270" y="1384584"/>
+                </a:lnTo>
+                <a:close/>
+                <a:lnTo>
+                  <a:pt x="1411465" y="1354628"/>
+                </a:lnTo>
+                <a:close/>
+                <a:lnTo>
+                  <a:pt x="1417619" y="1324399"/>
+                </a:lnTo>
+                <a:close/>
+                <a:lnTo>
+                  <a:pt x="1423734" y="1293848"/>
+                </a:lnTo>
+                <a:close/>
+                <a:lnTo>
+                  <a:pt x="1429836" y="1262803"/>
+                </a:lnTo>
+                <a:close/>
+                <a:lnTo>
+                  <a:pt x="1435961" y="1231064"/>
+                </a:lnTo>
+                <a:close/>
+                <a:lnTo>
+                  <a:pt x="1442140" y="1198432"/>
+                </a:lnTo>
+                <a:close/>
+                <a:lnTo>
+                  <a:pt x="1448406" y="1164707"/>
+                </a:lnTo>
+                <a:close/>
+                <a:lnTo>
+                  <a:pt x="1454794" y="1129689"/>
+                </a:lnTo>
+                <a:close/>
+                <a:lnTo>
+                  <a:pt x="1461336" y="1093178"/>
+                </a:lnTo>
+                <a:close/>
+                <a:lnTo>
+                  <a:pt x="1468054" y="1055045"/>
+                </a:lnTo>
+                <a:close/>
+                <a:lnTo>
+                  <a:pt x="1474872" y="1015774"/>
+                </a:lnTo>
+                <a:close/>
+                <a:lnTo>
+                  <a:pt x="1481664" y="976172"/>
+                </a:lnTo>
+                <a:close/>
+                <a:lnTo>
+                  <a:pt x="1488301" y="937049"/>
+                </a:lnTo>
+                <a:close/>
+                <a:lnTo>
+                  <a:pt x="1494656" y="899215"/>
+                </a:lnTo>
+                <a:close/>
+                <a:lnTo>
+                  <a:pt x="1500601" y="863480"/>
+                </a:lnTo>
+                <a:close/>
+                <a:lnTo>
+                  <a:pt x="1506009" y="830654"/>
+                </a:lnTo>
+                <a:close/>
+                <a:lnTo>
+                  <a:pt x="1510756" y="801526"/>
+                </a:lnTo>
+                <a:close/>
+                <a:lnTo>
+                  <a:pt x="1514828" y="776210"/>
+                </a:lnTo>
+                <a:close/>
+                <a:lnTo>
+                  <a:pt x="1518345" y="754035"/>
+                </a:lnTo>
+                <a:close/>
+                <a:lnTo>
+                  <a:pt x="1521431" y="734282"/>
+                </a:lnTo>
+                <a:close/>
+                <a:lnTo>
+                  <a:pt x="1524212" y="716235"/>
+                </a:lnTo>
+                <a:close/>
+                <a:lnTo>
+                  <a:pt x="1526813" y="699175"/>
+                </a:lnTo>
+                <a:close/>
+                <a:lnTo>
+                  <a:pt x="1529361" y="682385"/>
+                </a:lnTo>
+                <a:close/>
+                <a:lnTo>
+                  <a:pt x="1531980" y="665148"/>
+                </a:lnTo>
+                <a:close/>
+                <a:lnTo>
+                  <a:pt x="1534760" y="646941"/>
+                </a:lnTo>
+                <a:close/>
+                <a:lnTo>
+                  <a:pt x="1537695" y="627767"/>
+                </a:lnTo>
+                <a:close/>
+                <a:lnTo>
+                  <a:pt x="1540762" y="607716"/>
+                </a:lnTo>
+                <a:close/>
+                <a:lnTo>
+                  <a:pt x="1543939" y="586879"/>
+                </a:lnTo>
+                <a:close/>
+                <a:lnTo>
+                  <a:pt x="1547203" y="565345"/>
+                </a:lnTo>
+                <a:close/>
+                <a:lnTo>
+                  <a:pt x="1550531" y="543205"/>
+                </a:lnTo>
+                <a:close/>
+                <a:lnTo>
+                  <a:pt x="1553902" y="520549"/>
+                </a:lnTo>
+                <a:close/>
+                <a:lnTo>
+                  <a:pt x="1557291" y="497486"/>
+                </a:lnTo>
+                <a:close/>
+                <a:lnTo>
+                  <a:pt x="1560666" y="474251"/>
+                </a:lnTo>
+                <a:close/>
+                <a:lnTo>
+                  <a:pt x="1563992" y="451129"/>
+                </a:lnTo>
+                <a:close/>
+                <a:lnTo>
+                  <a:pt x="1567234" y="428407"/>
+                </a:lnTo>
+                <a:close/>
+                <a:lnTo>
+                  <a:pt x="1570356" y="406372"/>
+                </a:lnTo>
+                <a:close/>
+                <a:lnTo>
+                  <a:pt x="1573322" y="385311"/>
+                </a:lnTo>
+                <a:close/>
+                <a:lnTo>
+                  <a:pt x="1576097" y="365509"/>
+                </a:lnTo>
+                <a:close/>
+                <a:lnTo>
+                  <a:pt x="1578648" y="347242"/>
+                </a:lnTo>
+                <a:close/>
+                <a:lnTo>
+                  <a:pt x="1580968" y="330555"/>
+                </a:lnTo>
+                <a:close/>
+                <a:lnTo>
+                  <a:pt x="1583081" y="315275"/>
+                </a:lnTo>
+                <a:close/>
+                <a:lnTo>
+                  <a:pt x="1585011" y="301221"/>
+                </a:lnTo>
+                <a:close/>
+                <a:lnTo>
+                  <a:pt x="1586780" y="288214"/>
+                </a:lnTo>
+                <a:close/>
+                <a:lnTo>
+                  <a:pt x="1588413" y="276072"/>
+                </a:lnTo>
+                <a:close/>
+                <a:lnTo>
+                  <a:pt x="1589933" y="264615"/>
+                </a:lnTo>
+                <a:close/>
+                <a:lnTo>
+                  <a:pt x="1591364" y="253662"/>
+                </a:lnTo>
+                <a:close/>
+                <a:lnTo>
+                  <a:pt x="1592724" y="243070"/>
+                </a:lnTo>
+                <a:close/>
+                <a:lnTo>
+                  <a:pt x="1594028" y="232772"/>
+                </a:lnTo>
+                <a:close/>
+                <a:lnTo>
+                  <a:pt x="1595287" y="222711"/>
+                </a:lnTo>
+                <a:close/>
+                <a:lnTo>
+                  <a:pt x="1596512" y="212831"/>
+                </a:lnTo>
+                <a:close/>
+                <a:lnTo>
+                  <a:pt x="1597714" y="203075"/>
+                </a:lnTo>
+                <a:close/>
+                <a:lnTo>
+                  <a:pt x="1598906" y="193386"/>
+                </a:lnTo>
+                <a:close/>
+                <a:lnTo>
+                  <a:pt x="1600098" y="183708"/>
+                </a:lnTo>
+                <a:close/>
+                <a:lnTo>
+                  <a:pt x="1601301" y="173988"/>
+                </a:lnTo>
+                <a:close/>
+                <a:lnTo>
+                  <a:pt x="1602518" y="164204"/>
+                </a:lnTo>
+                <a:close/>
+                <a:lnTo>
+                  <a:pt x="1603749" y="154340"/>
+                </a:lnTo>
+                <a:close/>
+                <a:lnTo>
+                  <a:pt x="1604996" y="144383"/>
+                </a:lnTo>
+                <a:close/>
+                <a:lnTo>
+                  <a:pt x="1606258" y="134317"/>
+                </a:lnTo>
+                <a:close/>
+                <a:lnTo>
+                  <a:pt x="1607537" y="124127"/>
+                </a:lnTo>
+                <a:close/>
+                <a:lnTo>
+                  <a:pt x="1608833" y="113799"/>
+                </a:lnTo>
+                <a:close/>
+                <a:lnTo>
+                  <a:pt x="1610147" y="103323"/>
+                </a:lnTo>
+                <a:close/>
+                <a:lnTo>
+                  <a:pt x="1611470" y="92761"/>
+                </a:lnTo>
+                <a:close/>
+                <a:lnTo>
+                  <a:pt x="1612788" y="82226"/>
+                </a:lnTo>
+                <a:close/>
+                <a:lnTo>
+                  <a:pt x="1614087" y="71833"/>
+                </a:lnTo>
+                <a:close/>
+                <a:lnTo>
+                  <a:pt x="1615352" y="61700"/>
+                </a:lnTo>
+                <a:close/>
+                <a:lnTo>
+                  <a:pt x="1616571" y="51940"/>
+                </a:lnTo>
+                <a:close/>
+                <a:lnTo>
+                  <a:pt x="1617728" y="42670"/>
+                </a:lnTo>
+                <a:close/>
+                <a:lnTo>
+                  <a:pt x="1618809" y="34005"/>
+                </a:lnTo>
+                <a:close/>
+                <a:lnTo>
+                  <a:pt x="1619800" y="26061"/>
+                </a:lnTo>
+                <a:close/>
+                <a:lnTo>
+                  <a:pt x="1620687" y="18953"/>
+                </a:lnTo>
+                <a:close/>
+                <a:lnTo>
+                  <a:pt x="1621455" y="12797"/>
+                </a:lnTo>
+                <a:close/>
+                <a:lnTo>
+                  <a:pt x="1622091" y="7708"/>
+                </a:lnTo>
+                <a:close/>
+                <a:lnTo>
+                  <a:pt x="1622580" y="3802"/>
+                </a:lnTo>
+                <a:close/>
+                <a:lnTo>
+                  <a:pt x="1622907" y="1194"/>
+                </a:lnTo>
+                <a:close/>
+                <a:lnTo>
+                  <a:pt x="1623060" y="0"/>
                 </a:lnTo>
                 <a:close/>
               </a:path>
@@ -5623,8 +5623,8 @@
         </p:nvCxnSpPr>
         <p:spPr>
           <a:xfrm flipV="1">
-            <a:off x="6400800.0" y="-379476.0"/>
-            <a:ext cx="0.0" cy="2951226.0"/>
+            <a:off x="6172200.0" y="742950.0"/>
+            <a:ext cx="0.0" cy="1828800.0"/>
           </a:xfrm>
           <a:prstGeom prst="line">
             <a:avLst/>
@@ -5659,8 +5659,8 @@
         </p:nvCxnSpPr>
         <p:spPr>
           <a:xfrm>
-            <a:off x="4572000.0" y="-379476.0"/>
-            <a:ext cx="1828800.0" cy="0.0"/>
+            <a:off x="4572000.0" y="742950.0"/>
+            <a:ext cx="1600200.0" cy="0.0"/>
           </a:xfrm>
           <a:prstGeom prst="line">
             <a:avLst/>
@@ -5695,7 +5695,7 @@
         </p:nvSpPr>
         <p:spPr>
           <a:xfrm>
-            <a:off x="6311900" y="-468376"/>
+            <a:off x="6083300" y="654050"/>
             <a:ext cx="177800" cy="177800"/>
           </a:xfrm>
           <a:prstGeom prst="ellipse">
@@ -5740,8 +5740,8 @@
         </p:nvCxnSpPr>
         <p:spPr>
           <a:xfrm>
-            <a:off x="5257800.0" y="2434590.0"/>
-            <a:ext cx="1051560.0" cy="0.0"/>
+            <a:off x="5257800.0" y="2503170.0"/>
+            <a:ext cx="822960.0" cy="0.0"/>
           </a:xfrm>
           <a:prstGeom prst="line">
             <a:avLst/>
@@ -5775,8 +5775,8 @@
         </p:nvCxnSpPr>
         <p:spPr>
           <a:xfrm flipH="1">
-            <a:off x="6492240.0" y="2434590.0"/>
-            <a:ext cx="1051560.0" cy="0.0"/>
+            <a:off x="6263640.0" y="2503170.0"/>
+            <a:ext cx="502920.0" cy="0.0"/>
           </a:xfrm>
           <a:prstGeom prst="line">
             <a:avLst/>
@@ -5810,7 +5810,7 @@
         </p:nvSpPr>
         <p:spPr>
           <a:xfrm>
-            <a:off x="5918200" y="-1631950"/>
+            <a:off x="5918200" y="-1769110"/>
             <a:ext cx="1524000" cy="508000"/>
           </a:xfrm>
           <a:prstGeom prst="rect">
@@ -5846,7 +5846,7 @@
         </p:nvSpPr>
         <p:spPr>
           <a:xfrm>
-            <a:off x="3952240" y="-696976"/>
+            <a:off x="3906520" y="425450"/>
             <a:ext cx="1524000" cy="508000"/>
           </a:xfrm>
           <a:prstGeom prst="rect">
@@ -5882,7 +5882,7 @@
         </p:nvSpPr>
         <p:spPr>
           <a:xfrm>
-            <a:off x="6146800" y="2528570"/>
+            <a:off x="5918200" y="2528570"/>
             <a:ext cx="1524000" cy="508000"/>
           </a:xfrm>
           <a:prstGeom prst="rect">
@@ -5918,7 +5918,7 @@
         </p:nvSpPr>
         <p:spPr>
           <a:xfrm>
-            <a:off x="4089400" y="2482850"/>
+            <a:off x="4135120" y="2437130"/>
             <a:ext cx="1524000" cy="508000"/>
           </a:xfrm>
           <a:prstGeom prst="rect">

</xml_diff>